<commit_message>
Revise the LinkedIn carousel
Removes the PDF export of the previous version.
</commit_message>
<xml_diff>
--- a/docs/presentations/Connected-Care-LinkedIn-Carousel.pptx
+++ b/docs/presentations/Connected-Care-LinkedIn-Carousel.pptx
@@ -1,28 +1,123 @@
 
 <file path=ppt/presentation.xml><?xml version="1.0" encoding="utf-8"?>
-<p:presentation xmlns:p="http://schemas.openxmlformats.org/presentationml/2006/main">
+<p:presentation xmlns:a="http://schemas.openxmlformats.org/drawingml/2006/main" xmlns:r="http://schemas.openxmlformats.org/officeDocument/2006/relationships" xmlns:p="http://schemas.openxmlformats.org/presentationml/2006/main">
   <p:sldMasterIdLst>
-    <p:sldMasterId xmlns:r="http://schemas.openxmlformats.org/officeDocument/2006/relationships" id="2147483648" r:id="R585a16a0ce44405e"/>
+    <p:sldMasterId id="2147483648" r:id="rId1"/>
   </p:sldMasterIdLst>
   <p:notesMasterIdLst>
-    <p:notesMasterId xmlns:r="http://schemas.openxmlformats.org/officeDocument/2006/relationships" r:id="R6c72fa023c7a43fb"/>
+    <p:notesMasterId r:id="rId5"/>
   </p:notesMasterIdLst>
   <p:sldIdLst>
-    <p:sldId xmlns:r="http://schemas.openxmlformats.org/officeDocument/2006/relationships" id="256" r:id="R414004ccf5db46e4"/>
-    <p:sldId xmlns:r="http://schemas.openxmlformats.org/officeDocument/2006/relationships" id="257" r:id="Rfa40b7e773a247b2"/>
-    <p:sldId xmlns:r="http://schemas.openxmlformats.org/officeDocument/2006/relationships" id="258" r:id="R4dc9a3f87faf427e"/>
+    <p:sldId id="256" r:id="rId2"/>
+    <p:sldId id="257" r:id="rId3"/>
+    <p:sldId id="258" r:id="rId4"/>
   </p:sldIdLst>
   <p:sldSz cx="10287000" cy="10287000"/>
   <p:notesSz cx="6858000" cy="9144000"/>
+  <p:defaultTextStyle>
+    <a:defPPr>
+      <a:defRPr lang="en-US"/>
+    </a:defPPr>
+    <a:lvl1pPr marL="0" algn="l" defTabSz="914400" rtl="0" eaLnBrk="1" latinLnBrk="0" hangingPunct="1">
+      <a:defRPr sz="1800" kern="1200">
+        <a:solidFill>
+          <a:schemeClr val="tx1"/>
+        </a:solidFill>
+        <a:latin typeface="+mn-lt"/>
+        <a:ea typeface="+mn-ea"/>
+        <a:cs typeface="+mn-cs"/>
+      </a:defRPr>
+    </a:lvl1pPr>
+    <a:lvl2pPr marL="457200" algn="l" defTabSz="914400" rtl="0" eaLnBrk="1" latinLnBrk="0" hangingPunct="1">
+      <a:defRPr sz="1800" kern="1200">
+        <a:solidFill>
+          <a:schemeClr val="tx1"/>
+        </a:solidFill>
+        <a:latin typeface="+mn-lt"/>
+        <a:ea typeface="+mn-ea"/>
+        <a:cs typeface="+mn-cs"/>
+      </a:defRPr>
+    </a:lvl2pPr>
+    <a:lvl3pPr marL="914400" algn="l" defTabSz="914400" rtl="0" eaLnBrk="1" latinLnBrk="0" hangingPunct="1">
+      <a:defRPr sz="1800" kern="1200">
+        <a:solidFill>
+          <a:schemeClr val="tx1"/>
+        </a:solidFill>
+        <a:latin typeface="+mn-lt"/>
+        <a:ea typeface="+mn-ea"/>
+        <a:cs typeface="+mn-cs"/>
+      </a:defRPr>
+    </a:lvl3pPr>
+    <a:lvl4pPr marL="1371600" algn="l" defTabSz="914400" rtl="0" eaLnBrk="1" latinLnBrk="0" hangingPunct="1">
+      <a:defRPr sz="1800" kern="1200">
+        <a:solidFill>
+          <a:schemeClr val="tx1"/>
+        </a:solidFill>
+        <a:latin typeface="+mn-lt"/>
+        <a:ea typeface="+mn-ea"/>
+        <a:cs typeface="+mn-cs"/>
+      </a:defRPr>
+    </a:lvl4pPr>
+    <a:lvl5pPr marL="1828800" algn="l" defTabSz="914400" rtl="0" eaLnBrk="1" latinLnBrk="0" hangingPunct="1">
+      <a:defRPr sz="1800" kern="1200">
+        <a:solidFill>
+          <a:schemeClr val="tx1"/>
+        </a:solidFill>
+        <a:latin typeface="+mn-lt"/>
+        <a:ea typeface="+mn-ea"/>
+        <a:cs typeface="+mn-cs"/>
+      </a:defRPr>
+    </a:lvl5pPr>
+    <a:lvl6pPr marL="2286000" algn="l" defTabSz="914400" rtl="0" eaLnBrk="1" latinLnBrk="0" hangingPunct="1">
+      <a:defRPr sz="1800" kern="1200">
+        <a:solidFill>
+          <a:schemeClr val="tx1"/>
+        </a:solidFill>
+        <a:latin typeface="+mn-lt"/>
+        <a:ea typeface="+mn-ea"/>
+        <a:cs typeface="+mn-cs"/>
+      </a:defRPr>
+    </a:lvl6pPr>
+    <a:lvl7pPr marL="2743200" algn="l" defTabSz="914400" rtl="0" eaLnBrk="1" latinLnBrk="0" hangingPunct="1">
+      <a:defRPr sz="1800" kern="1200">
+        <a:solidFill>
+          <a:schemeClr val="tx1"/>
+        </a:solidFill>
+        <a:latin typeface="+mn-lt"/>
+        <a:ea typeface="+mn-ea"/>
+        <a:cs typeface="+mn-cs"/>
+      </a:defRPr>
+    </a:lvl7pPr>
+    <a:lvl8pPr marL="3200400" algn="l" defTabSz="914400" rtl="0" eaLnBrk="1" latinLnBrk="0" hangingPunct="1">
+      <a:defRPr sz="1800" kern="1200">
+        <a:solidFill>
+          <a:schemeClr val="tx1"/>
+        </a:solidFill>
+        <a:latin typeface="+mn-lt"/>
+        <a:ea typeface="+mn-ea"/>
+        <a:cs typeface="+mn-cs"/>
+      </a:defRPr>
+    </a:lvl8pPr>
+    <a:lvl9pPr marL="3657600" algn="l" defTabSz="914400" rtl="0" eaLnBrk="1" latinLnBrk="0" hangingPunct="1">
+      <a:defRPr sz="1800" kern="1200">
+        <a:solidFill>
+          <a:schemeClr val="tx1"/>
+        </a:solidFill>
+        <a:latin typeface="+mn-lt"/>
+        <a:ea typeface="+mn-ea"/>
+        <a:cs typeface="+mn-cs"/>
+      </a:defRPr>
+    </a:lvl9pPr>
+  </p:defaultTextStyle>
 </p:presentation>
 </file>
 
 <file path=ppt/notesMasters/notesMaster1.xml><?xml version="1.0" encoding="utf-8"?>
-<p:notesMaster xmlns:p="http://schemas.openxmlformats.org/presentationml/2006/main">
+<p:notesMaster xmlns:a="http://schemas.openxmlformats.org/drawingml/2006/main" xmlns:r="http://schemas.openxmlformats.org/officeDocument/2006/relationships" xmlns:p="http://schemas.openxmlformats.org/presentationml/2006/main">
   <p:cSld>
     <p:bg>
       <p:bgRef idx="1001">
-        <a:schemeClr xmlns:a="http://schemas.openxmlformats.org/drawingml/2006/main" val="bg1"/>
+        <a:schemeClr val="bg1"/>
       </p:bgRef>
     </p:bg>
     <p:spTree>
@@ -32,590 +127,373 @@
         <p:nvPr/>
       </p:nvGrpSpPr>
       <p:grpSpPr>
-        <a:xfrm xmlns:a="http://schemas.openxmlformats.org/drawingml/2006/main"/>
+        <a:xfrm>
+          <a:off x="0" y="0"/>
+          <a:ext cx="0" cy="0"/>
+          <a:chOff x="0" y="0"/>
+          <a:chExt cx="0" cy="0"/>
+        </a:xfrm>
       </p:grpSpPr>
       <p:sp>
         <p:nvSpPr>
-          <p:cNvPr id="2" name="Header Placeholder"/>
-          <p:cNvSpPr/>
+          <p:cNvPr id="2" name="Header Placeholder 1">
+            <a:extLst>
+              <a:ext uri="{FF2B5EF4-FFF2-40B4-BE49-F238E27FC236}">
+                <a16:creationId xmlns:a16="http://schemas.microsoft.com/office/drawing/2014/main" id="{57F4E949-9A86-D250-05DA-9E3341798737}"/>
+              </a:ext>
+            </a:extLst>
+          </p:cNvPr>
+          <p:cNvSpPr>
+            <a:spLocks noGrp="1"/>
+          </p:cNvSpPr>
           <p:nvPr>
             <p:ph type="hdr" sz="quarter"/>
           </p:nvPr>
         </p:nvSpPr>
         <p:spPr>
-          <a:prstGeom xmlns:a="http://schemas.openxmlformats.org/drawingml/2006/main" prst="rect">
+          <a:xfrm>
+            <a:off x="0" y="0"/>
+            <a:ext cx="2971800" cy="458788"/>
+          </a:xfrm>
+          <a:prstGeom prst="rect">
             <a:avLst/>
           </a:prstGeom>
         </p:spPr>
         <p:txBody>
-          <a:bodyPr xmlns:a="http://schemas.openxmlformats.org/drawingml/2006/main"/>
-          <a:lstStyle xmlns:a="http://schemas.openxmlformats.org/drawingml/2006/main"/>
-          <a:p xmlns:a="http://schemas.openxmlformats.org/drawingml/2006/main"/>
+          <a:bodyPr vert="horz" lIns="91440" tIns="45720" rIns="91440" bIns="45720" rtlCol="0"/>
+          <a:lstStyle>
+            <a:lvl1pPr algn="l">
+              <a:defRPr sz="1200"/>
+            </a:lvl1pPr>
+          </a:lstStyle>
+          <a:p>
+            <a:endParaRPr lang="en-US"/>
+          </a:p>
         </p:txBody>
       </p:sp>
       <p:sp>
         <p:nvSpPr>
-          <p:cNvPr id="3" name="Date Placeholder"/>
-          <p:cNvSpPr/>
+          <p:cNvPr id="3" name="Date Placeholder 2">
+            <a:extLst>
+              <a:ext uri="{FF2B5EF4-FFF2-40B4-BE49-F238E27FC236}">
+                <a16:creationId xmlns:a16="http://schemas.microsoft.com/office/drawing/2014/main" id="{E052E6CB-2EEF-542B-D3B6-7745791E790E}"/>
+              </a:ext>
+            </a:extLst>
+          </p:cNvPr>
+          <p:cNvSpPr>
+            <a:spLocks noGrp="1"/>
+          </p:cNvSpPr>
           <p:nvPr>
-            <p:ph type="dt" sz="quarter" idx="1"/>
+            <p:ph type="dt" idx="1"/>
           </p:nvPr>
         </p:nvSpPr>
         <p:spPr>
-          <a:prstGeom xmlns:a="http://schemas.openxmlformats.org/drawingml/2006/main" prst="rect">
+          <a:xfrm>
+            <a:off x="3884613" y="0"/>
+            <a:ext cx="2971800" cy="458788"/>
+          </a:xfrm>
+          <a:prstGeom prst="rect">
             <a:avLst/>
           </a:prstGeom>
         </p:spPr>
         <p:txBody>
-          <a:bodyPr xmlns:a="http://schemas.openxmlformats.org/drawingml/2006/main"/>
-          <a:lstStyle xmlns:a="http://schemas.openxmlformats.org/drawingml/2006/main"/>
-          <a:p xmlns:a="http://schemas.openxmlformats.org/drawingml/2006/main"/>
+          <a:bodyPr vert="horz" lIns="91440" tIns="45720" rIns="91440" bIns="45720" rtlCol="0"/>
+          <a:lstStyle>
+            <a:lvl1pPr algn="r">
+              <a:defRPr sz="1200"/>
+            </a:lvl1pPr>
+          </a:lstStyle>
+          <a:p>
+            <a:fld id="{C275578F-A291-DF4F-BEB6-182C034D887E}" type="datetimeFigureOut">
+              <a:rPr lang="en-US" smtClean="0"/>
+              <a:t>10/11/26</a:t>
+            </a:fld>
+            <a:endParaRPr lang="en-US"/>
+          </a:p>
         </p:txBody>
       </p:sp>
       <p:sp>
         <p:nvSpPr>
-          <p:cNvPr id="4" name="Slide Image Placeholder"/>
-          <p:cNvSpPr/>
+          <p:cNvPr id="4" name="Slide Image Placeholder 3">
+            <a:extLst>
+              <a:ext uri="{FF2B5EF4-FFF2-40B4-BE49-F238E27FC236}">
+                <a16:creationId xmlns:a16="http://schemas.microsoft.com/office/drawing/2014/main" id="{1FCA49BE-3A94-5ADA-5922-08448B41DAB2}"/>
+              </a:ext>
+            </a:extLst>
+          </p:cNvPr>
+          <p:cNvSpPr>
+            <a:spLocks noGrp="1" noRot="1" noChangeAspect="1"/>
+          </p:cNvSpPr>
           <p:nvPr>
             <p:ph type="sldImg" idx="2"/>
           </p:nvPr>
         </p:nvSpPr>
         <p:spPr>
-          <a:prstGeom xmlns:a="http://schemas.openxmlformats.org/drawingml/2006/main" prst="rect">
+          <a:xfrm>
+            <a:off x="1885950" y="1143000"/>
+            <a:ext cx="3086100" cy="3086100"/>
+          </a:xfrm>
+          <a:prstGeom prst="rect">
             <a:avLst/>
           </a:prstGeom>
+          <a:noFill/>
+          <a:ln w="12700">
+            <a:solidFill>
+              <a:prstClr val="black"/>
+            </a:solidFill>
+          </a:ln>
         </p:spPr>
         <p:txBody>
-          <a:bodyPr xmlns:a="http://schemas.openxmlformats.org/drawingml/2006/main"/>
-          <a:lstStyle xmlns:a="http://schemas.openxmlformats.org/drawingml/2006/main"/>
-          <a:p xmlns:a="http://schemas.openxmlformats.org/drawingml/2006/main"/>
+          <a:bodyPr vert="horz" lIns="91440" tIns="45720" rIns="91440" bIns="45720" rtlCol="0" anchor="ctr"/>
+          <a:lstStyle/>
+          <a:p>
+            <a:endParaRPr lang="en-US"/>
+          </a:p>
         </p:txBody>
       </p:sp>
       <p:sp>
         <p:nvSpPr>
-          <p:cNvPr id="5" name="Notes Placeholder"/>
-          <p:cNvSpPr/>
+          <p:cNvPr id="5" name="Notes Placeholder 4">
+            <a:extLst>
+              <a:ext uri="{FF2B5EF4-FFF2-40B4-BE49-F238E27FC236}">
+                <a16:creationId xmlns:a16="http://schemas.microsoft.com/office/drawing/2014/main" id="{946EA4E9-3780-AD16-2408-FAF6BF91CEBA}"/>
+              </a:ext>
+            </a:extLst>
+          </p:cNvPr>
+          <p:cNvSpPr>
+            <a:spLocks noGrp="1"/>
+          </p:cNvSpPr>
           <p:nvPr>
             <p:ph type="body" sz="quarter" idx="3"/>
           </p:nvPr>
         </p:nvSpPr>
         <p:spPr>
-          <a:prstGeom xmlns:a="http://schemas.openxmlformats.org/drawingml/2006/main" prst="rect">
+          <a:xfrm>
+            <a:off x="685800" y="4400550"/>
+            <a:ext cx="5486400" cy="3600450"/>
+          </a:xfrm>
+          <a:prstGeom prst="rect">
             <a:avLst/>
           </a:prstGeom>
         </p:spPr>
         <p:txBody>
-          <a:bodyPr xmlns:a="http://schemas.openxmlformats.org/drawingml/2006/main"/>
-          <a:lstStyle xmlns:a="http://schemas.openxmlformats.org/drawingml/2006/main"/>
-          <a:p xmlns:a="http://schemas.openxmlformats.org/drawingml/2006/main"/>
+          <a:bodyPr vert="horz" lIns="91440" tIns="45720" rIns="91440" bIns="45720" rtlCol="0"/>
+          <a:lstStyle/>
+          <a:p>
+            <a:pPr lvl="0"/>
+            <a:r>
+              <a:rPr lang="en-US"/>
+              <a:t>Click to edit Master text styles</a:t>
+            </a:r>
+          </a:p>
+          <a:p>
+            <a:pPr lvl="1"/>
+            <a:r>
+              <a:rPr lang="en-US"/>
+              <a:t>Second level</a:t>
+            </a:r>
+          </a:p>
+          <a:p>
+            <a:pPr lvl="2"/>
+            <a:r>
+              <a:rPr lang="en-US"/>
+              <a:t>Third level</a:t>
+            </a:r>
+          </a:p>
+          <a:p>
+            <a:pPr lvl="3"/>
+            <a:r>
+              <a:rPr lang="en-US"/>
+              <a:t>Fourth level</a:t>
+            </a:r>
+          </a:p>
+          <a:p>
+            <a:pPr lvl="4"/>
+            <a:r>
+              <a:rPr lang="en-US"/>
+              <a:t>Fifth level</a:t>
+            </a:r>
+          </a:p>
         </p:txBody>
       </p:sp>
       <p:sp>
         <p:nvSpPr>
-          <p:cNvPr id="6" name="Footer Placeholder"/>
-          <p:cNvSpPr/>
+          <p:cNvPr id="6" name="Footer Placeholder 5">
+            <a:extLst>
+              <a:ext uri="{FF2B5EF4-FFF2-40B4-BE49-F238E27FC236}">
+                <a16:creationId xmlns:a16="http://schemas.microsoft.com/office/drawing/2014/main" id="{E625228F-4F60-FF8C-D6EE-EA699FABF148}"/>
+              </a:ext>
+            </a:extLst>
+          </p:cNvPr>
+          <p:cNvSpPr>
+            <a:spLocks noGrp="1"/>
+          </p:cNvSpPr>
           <p:nvPr>
             <p:ph type="ftr" sz="quarter" idx="4"/>
           </p:nvPr>
         </p:nvSpPr>
         <p:spPr>
-          <a:prstGeom xmlns:a="http://schemas.openxmlformats.org/drawingml/2006/main" prst="rect">
+          <a:xfrm>
+            <a:off x="0" y="8685213"/>
+            <a:ext cx="2971800" cy="458787"/>
+          </a:xfrm>
+          <a:prstGeom prst="rect">
             <a:avLst/>
           </a:prstGeom>
         </p:spPr>
         <p:txBody>
-          <a:bodyPr xmlns:a="http://schemas.openxmlformats.org/drawingml/2006/main"/>
-          <a:lstStyle xmlns:a="http://schemas.openxmlformats.org/drawingml/2006/main"/>
-          <a:p xmlns:a="http://schemas.openxmlformats.org/drawingml/2006/main"/>
+          <a:bodyPr vert="horz" lIns="91440" tIns="45720" rIns="91440" bIns="45720" rtlCol="0" anchor="b"/>
+          <a:lstStyle>
+            <a:lvl1pPr algn="l">
+              <a:defRPr sz="1200"/>
+            </a:lvl1pPr>
+          </a:lstStyle>
+          <a:p>
+            <a:endParaRPr lang="en-US"/>
+          </a:p>
         </p:txBody>
       </p:sp>
       <p:sp>
         <p:nvSpPr>
-          <p:cNvPr id="7" name="Slide Number Placeholder"/>
-          <p:cNvSpPr/>
+          <p:cNvPr id="7" name="Slide Number Placeholder 6">
+            <a:extLst>
+              <a:ext uri="{FF2B5EF4-FFF2-40B4-BE49-F238E27FC236}">
+                <a16:creationId xmlns:a16="http://schemas.microsoft.com/office/drawing/2014/main" id="{94DD2956-B571-1BE1-A6AF-A26D57BDECAF}"/>
+              </a:ext>
+            </a:extLst>
+          </p:cNvPr>
+          <p:cNvSpPr>
+            <a:spLocks noGrp="1"/>
+          </p:cNvSpPr>
           <p:nvPr>
             <p:ph type="sldNum" sz="quarter" idx="5"/>
           </p:nvPr>
         </p:nvSpPr>
         <p:spPr>
-          <a:prstGeom xmlns:a="http://schemas.openxmlformats.org/drawingml/2006/main" prst="rect">
+          <a:xfrm>
+            <a:off x="3884613" y="8685213"/>
+            <a:ext cx="2971800" cy="458787"/>
+          </a:xfrm>
+          <a:prstGeom prst="rect">
             <a:avLst/>
           </a:prstGeom>
         </p:spPr>
         <p:txBody>
-          <a:bodyPr xmlns:a="http://schemas.openxmlformats.org/drawingml/2006/main"/>
-          <a:lstStyle xmlns:a="http://schemas.openxmlformats.org/drawingml/2006/main"/>
-          <a:p xmlns:a="http://schemas.openxmlformats.org/drawingml/2006/main"/>
+          <a:bodyPr vert="horz" lIns="91440" tIns="45720" rIns="91440" bIns="45720" rtlCol="0" anchor="b"/>
+          <a:lstStyle>
+            <a:lvl1pPr algn="r">
+              <a:defRPr sz="1200"/>
+            </a:lvl1pPr>
+          </a:lstStyle>
+          <a:p>
+            <a:fld id="{7DEDD8FB-3BDB-EE4F-B918-6A928C52B455}" type="slidenum">
+              <a:rPr lang="en-US" smtClean="0"/>
+              <a:t>‹#›</a:t>
+            </a:fld>
+            <a:endParaRPr lang="en-US"/>
+          </a:p>
         </p:txBody>
       </p:sp>
     </p:spTree>
   </p:cSld>
   <p:clrMap bg1="lt1" tx1="dk1" bg2="lt2" tx2="dk2" accent1="accent1" accent2="accent2" accent3="accent3" accent4="accent4" accent5="accent5" accent6="accent6" hlink="hlink" folHlink="folHlink"/>
   <p:notesStyle>
-    <a:lvl1pPr xmlns:a="http://schemas.openxmlformats.org/drawingml/2006/main" marL="0" algn="l" defTabSz="914400" rtl="0" eaLnBrk="1" latinLnBrk="0" hangingPunct="1">
-      <a:defRPr sz="1200" kern="1200"/>
+    <a:lvl1pPr marL="0" algn="l" defTabSz="914400" rtl="0" eaLnBrk="1" latinLnBrk="0" hangingPunct="1">
+      <a:defRPr sz="1200" kern="1200">
+        <a:solidFill>
+          <a:schemeClr val="tx1"/>
+        </a:solidFill>
+        <a:latin typeface="+mn-lt"/>
+        <a:ea typeface="+mn-ea"/>
+        <a:cs typeface="+mn-cs"/>
+      </a:defRPr>
     </a:lvl1pPr>
+    <a:lvl2pPr marL="457200" algn="l" defTabSz="914400" rtl="0" eaLnBrk="1" latinLnBrk="0" hangingPunct="1">
+      <a:defRPr sz="1200" kern="1200">
+        <a:solidFill>
+          <a:schemeClr val="tx1"/>
+        </a:solidFill>
+        <a:latin typeface="+mn-lt"/>
+        <a:ea typeface="+mn-ea"/>
+        <a:cs typeface="+mn-cs"/>
+      </a:defRPr>
+    </a:lvl2pPr>
+    <a:lvl3pPr marL="914400" algn="l" defTabSz="914400" rtl="0" eaLnBrk="1" latinLnBrk="0" hangingPunct="1">
+      <a:defRPr sz="1200" kern="1200">
+        <a:solidFill>
+          <a:schemeClr val="tx1"/>
+        </a:solidFill>
+        <a:latin typeface="+mn-lt"/>
+        <a:ea typeface="+mn-ea"/>
+        <a:cs typeface="+mn-cs"/>
+      </a:defRPr>
+    </a:lvl3pPr>
+    <a:lvl4pPr marL="1371600" algn="l" defTabSz="914400" rtl="0" eaLnBrk="1" latinLnBrk="0" hangingPunct="1">
+      <a:defRPr sz="1200" kern="1200">
+        <a:solidFill>
+          <a:schemeClr val="tx1"/>
+        </a:solidFill>
+        <a:latin typeface="+mn-lt"/>
+        <a:ea typeface="+mn-ea"/>
+        <a:cs typeface="+mn-cs"/>
+      </a:defRPr>
+    </a:lvl4pPr>
+    <a:lvl5pPr marL="1828800" algn="l" defTabSz="914400" rtl="0" eaLnBrk="1" latinLnBrk="0" hangingPunct="1">
+      <a:defRPr sz="1200" kern="1200">
+        <a:solidFill>
+          <a:schemeClr val="tx1"/>
+        </a:solidFill>
+        <a:latin typeface="+mn-lt"/>
+        <a:ea typeface="+mn-ea"/>
+        <a:cs typeface="+mn-cs"/>
+      </a:defRPr>
+    </a:lvl5pPr>
+    <a:lvl6pPr marL="2286000" algn="l" defTabSz="914400" rtl="0" eaLnBrk="1" latinLnBrk="0" hangingPunct="1">
+      <a:defRPr sz="1200" kern="1200">
+        <a:solidFill>
+          <a:schemeClr val="tx1"/>
+        </a:solidFill>
+        <a:latin typeface="+mn-lt"/>
+        <a:ea typeface="+mn-ea"/>
+        <a:cs typeface="+mn-cs"/>
+      </a:defRPr>
+    </a:lvl6pPr>
+    <a:lvl7pPr marL="2743200" algn="l" defTabSz="914400" rtl="0" eaLnBrk="1" latinLnBrk="0" hangingPunct="1">
+      <a:defRPr sz="1200" kern="1200">
+        <a:solidFill>
+          <a:schemeClr val="tx1"/>
+        </a:solidFill>
+        <a:latin typeface="+mn-lt"/>
+        <a:ea typeface="+mn-ea"/>
+        <a:cs typeface="+mn-cs"/>
+      </a:defRPr>
+    </a:lvl7pPr>
+    <a:lvl8pPr marL="3200400" algn="l" defTabSz="914400" rtl="0" eaLnBrk="1" latinLnBrk="0" hangingPunct="1">
+      <a:defRPr sz="1200" kern="1200">
+        <a:solidFill>
+          <a:schemeClr val="tx1"/>
+        </a:solidFill>
+        <a:latin typeface="+mn-lt"/>
+        <a:ea typeface="+mn-ea"/>
+        <a:cs typeface="+mn-cs"/>
+      </a:defRPr>
+    </a:lvl8pPr>
+    <a:lvl9pPr marL="3657600" algn="l" defTabSz="914400" rtl="0" eaLnBrk="1" latinLnBrk="0" hangingPunct="1">
+      <a:defRPr sz="1200" kern="1200">
+        <a:solidFill>
+          <a:schemeClr val="tx1"/>
+        </a:solidFill>
+        <a:latin typeface="+mn-lt"/>
+        <a:ea typeface="+mn-ea"/>
+        <a:cs typeface="+mn-cs"/>
+      </a:defRPr>
+    </a:lvl9pPr>
   </p:notesStyle>
 </p:notesMaster>
 </file>
 
-<file path=ppt/notesMasters/theme/theme3.xml><?xml version="1.0" encoding="utf-8"?>
-<a:theme xmlns:a="http://schemas.openxmlformats.org/drawingml/2006/main" name="ChatGPT">
-  <a:themeElements>
-    <a:clrScheme name="ChatGPT">
-      <a:dk1>
-        <a:srgbClr val="000000"/>
-      </a:dk1>
-      <a:lt1>
-        <a:srgbClr val="FFFFFF"/>
-      </a:lt1>
-      <a:dk2>
-        <a:srgbClr val="0E2841"/>
-      </a:dk2>
-      <a:lt2>
-        <a:srgbClr val="E8E8E8"/>
-      </a:lt2>
-      <a:accent1>
-        <a:srgbClr val="156082"/>
-      </a:accent1>
-      <a:accent2>
-        <a:srgbClr val="E97132"/>
-      </a:accent2>
-      <a:accent3>
-        <a:srgbClr val="196B24"/>
-      </a:accent3>
-      <a:accent4>
-        <a:srgbClr val="0F9ED5"/>
-      </a:accent4>
-      <a:accent5>
-        <a:srgbClr val="A02B93"/>
-      </a:accent5>
-      <a:accent6>
-        <a:srgbClr val="4EA72E"/>
-      </a:accent6>
-      <a:hlink>
-        <a:srgbClr val="467886"/>
-      </a:hlink>
-      <a:folHlink>
-        <a:srgbClr val="96607D"/>
-      </a:folHlink>
-    </a:clrScheme>
-    <a:fontScheme name="">
-      <a:majorFont>
-        <a:latin typeface="Aptos"/>
-        <a:ea typeface=""/>
-        <a:cs typeface=""/>
-      </a:majorFont>
-      <a:minorFont>
-        <a:latin typeface="Aptos"/>
-        <a:ea typeface=""/>
-        <a:cs typeface=""/>
-      </a:minorFont>
-    </a:fontScheme>
-    <a:fmtScheme name="ChatGPT">
-      <a:fillStyleLst>
-        <a:solidFill>
-          <a:schemeClr val="phClr"/>
-        </a:solidFill>
-        <a:gradFill>
-          <a:gsLst>
-            <a:gs pos="0">
-              <a:schemeClr val="phClr">
-                <a:tint val="67000"/>
-                <a:lumMod val="110000"/>
-                <a:satMod val="105000"/>
-              </a:schemeClr>
-            </a:gs>
-            <a:gs pos="50000">
-              <a:schemeClr val="phClr">
-                <a:tint val="73000"/>
-                <a:lumMod val="105000"/>
-                <a:satMod val="103000"/>
-              </a:schemeClr>
-            </a:gs>
-            <a:gs pos="100000">
-              <a:schemeClr val="phClr">
-                <a:tint val="81000"/>
-                <a:lumMod val="105000"/>
-                <a:satMod val="109000"/>
-              </a:schemeClr>
-            </a:gs>
-          </a:gsLst>
-          <a:lin ang="5400000" scaled="0"/>
-        </a:gradFill>
-        <a:gradFill>
-          <a:gsLst>
-            <a:gs pos="0">
-              <a:schemeClr val="phClr">
-                <a:tint val="94000"/>
-                <a:lumMod val="102000"/>
-                <a:satMod val="103000"/>
-              </a:schemeClr>
-            </a:gs>
-            <a:gs pos="50000">
-              <a:schemeClr val="phClr">
-                <a:shade val="100000"/>
-                <a:lumMod val="100000"/>
-                <a:satMod val="110000"/>
-              </a:schemeClr>
-            </a:gs>
-            <a:gs pos="100000">
-              <a:schemeClr val="phClr">
-                <a:shade val="78000"/>
-                <a:lumMod val="99000"/>
-                <a:satMod val="120000"/>
-              </a:schemeClr>
-            </a:gs>
-          </a:gsLst>
-          <a:lin ang="5400000" scaled="0"/>
-        </a:gradFill>
-      </a:fillStyleLst>
-      <a:lnStyleLst>
-        <a:ln w="12700">
-          <a:solidFill>
-            <a:schemeClr val="phClr"/>
-          </a:solidFill>
-          <a:prstDash val="solid"/>
-        </a:ln>
-        <a:ln w="19050">
-          <a:solidFill>
-            <a:schemeClr val="phClr"/>
-          </a:solidFill>
-          <a:prstDash val="solid"/>
-        </a:ln>
-        <a:ln w="25400">
-          <a:solidFill>
-            <a:schemeClr val="phClr"/>
-          </a:solidFill>
-          <a:prstDash val="solid"/>
-        </a:ln>
-      </a:lnStyleLst>
-      <a:effectStyleLst>
-        <a:effectStyle>
-          <a:effectLst/>
-        </a:effectStyle>
-        <a:effectStyle>
-          <a:effectLst/>
-        </a:effectStyle>
-        <a:effectStyle>
-          <a:effectLst>
-            <a:outerShdw blurRad="57150" dist="19050" dir="5400000">
-              <a:srgbClr val="000000">
-                <a:alpha val="16000"/>
-              </a:srgbClr>
-            </a:outerShdw>
-          </a:effectLst>
-        </a:effectStyle>
-        <a:effectStyle>
-          <a:effectLst>
-            <a:outerShdw blurRad="19050" dist="9525" dir="5400000">
-              <a:srgbClr val="000000">
-                <a:alpha val="6000"/>
-              </a:srgbClr>
-            </a:outerShdw>
-          </a:effectLst>
-        </a:effectStyle>
-        <a:effectStyle>
-          <a:effectLst>
-            <a:outerShdw blurRad="28575" dist="9525" dir="5400000">
-              <a:srgbClr val="000000">
-                <a:alpha val="8000"/>
-              </a:srgbClr>
-            </a:outerShdw>
-          </a:effectLst>
-        </a:effectStyle>
-        <a:effectStyle>
-          <a:effectLst>
-            <a:outerShdw blurRad="57150" dist="19050" dir="5400000">
-              <a:srgbClr val="000000">
-                <a:alpha val="10000"/>
-              </a:srgbClr>
-            </a:outerShdw>
-          </a:effectLst>
-        </a:effectStyle>
-        <a:effectStyle>
-          <a:effectLst>
-            <a:outerShdw blurRad="114300" dist="38100" dir="5400000">
-              <a:srgbClr val="000000">
-                <a:alpha val="12000"/>
-              </a:srgbClr>
-            </a:outerShdw>
-          </a:effectLst>
-        </a:effectStyle>
-        <a:effectStyle>
-          <a:effectLst>
-            <a:outerShdw blurRad="171450" dist="57150" dir="5400000">
-              <a:srgbClr val="000000">
-                <a:alpha val="16000"/>
-              </a:srgbClr>
-            </a:outerShdw>
-          </a:effectLst>
-        </a:effectStyle>
-        <a:effectStyle>
-          <a:effectLst>
-            <a:outerShdw blurRad="266700" dist="95250" dir="5400000">
-              <a:srgbClr val="000000">
-                <a:alpha val="24000"/>
-              </a:srgbClr>
-            </a:outerShdw>
-          </a:effectLst>
-        </a:effectStyle>
-      </a:effectStyleLst>
-      <a:bgFillStyleLst>
-        <a:solidFill>
-          <a:schemeClr val="phClr"/>
-        </a:solidFill>
-        <a:solidFill>
-          <a:schemeClr val="phClr">
-            <a:tint val="95000"/>
-            <a:satMod val="170000"/>
-          </a:schemeClr>
-        </a:solidFill>
-        <a:gradFill>
-          <a:gsLst>
-            <a:gs pos="0">
-              <a:schemeClr val="phClr">
-                <a:tint val="93000"/>
-                <a:shade val="98000"/>
-                <a:lumMod val="102000"/>
-                <a:satMod val="150000"/>
-              </a:schemeClr>
-            </a:gs>
-            <a:gs pos="50000">
-              <a:schemeClr val="phClr">
-                <a:tint val="98000"/>
-                <a:shade val="90000"/>
-                <a:lumMod val="103000"/>
-                <a:satMod val="130000"/>
-              </a:schemeClr>
-            </a:gs>
-            <a:gs pos="100000">
-              <a:schemeClr val="phClr">
-                <a:shade val="63000"/>
-                <a:satMod val="120000"/>
-              </a:schemeClr>
-            </a:gs>
-          </a:gsLst>
-          <a:lin ang="5400000" scaled="0"/>
-        </a:gradFill>
-      </a:bgFillStyleLst>
-    </a:fmtScheme>
-  </a:themeElements>
-</a:theme>
-</file>
-
-<file path=ppt/notesSlides/notesSlide1.xml><?xml version="1.0" encoding="utf-8"?>
-<p:notes xmlns:p="http://schemas.openxmlformats.org/presentationml/2006/main">
-  <p:cSld>
-    <p:spTree>
-      <p:nvGrpSpPr>
-        <p:cNvPr id="1" name=""/>
-        <p:cNvGrpSpPr/>
-        <p:nvPr/>
-      </p:nvGrpSpPr>
-      <p:grpSpPr>
-        <a:xfrm xmlns:a="http://schemas.openxmlformats.org/drawingml/2006/main"/>
-      </p:grpSpPr>
-      <p:sp>
-        <p:nvSpPr>
-          <p:cNvPr id="2" name="Slide Image Placeholder 1"/>
-          <p:cNvSpPr>
-            <a:spLocks xmlns:a="http://schemas.openxmlformats.org/drawingml/2006/main" noGrp="1"/>
-          </p:cNvSpPr>
-          <p:nvPr>
-            <p:ph type="sldImg" idx="0"/>
-          </p:nvPr>
-        </p:nvSpPr>
-        <p:spPr/>
-      </p:sp>
-      <p:sp>
-        <p:nvSpPr>
-          <p:cNvPr id="3" name="Notes Placeholder 2"/>
-          <p:cNvSpPr>
-            <a:spLocks xmlns:a="http://schemas.openxmlformats.org/drawingml/2006/main" noGrp="1"/>
-          </p:cNvSpPr>
-          <p:nvPr>
-            <p:ph type="body" idx="1"/>
-          </p:nvPr>
-        </p:nvSpPr>
-        <p:spPr/>
-        <p:txBody>
-          <a:bodyPr xmlns:a="http://schemas.openxmlformats.org/drawingml/2006/main"/>
-          <a:lstStyle xmlns:a="http://schemas.openxmlformats.org/drawingml/2006/main"/>
-          <a:p xmlns:a="http://schemas.openxmlformats.org/drawingml/2006/main">
-            <a:r>
-              <a:t>Personal connected care project. The scope is information availability and configured visit rules, not a clinical recommendation or proof of improved patient outcomes.</a:t>
-            </a:r>
-          </a:p>
-        </p:txBody>
-      </p:sp>
-      <p:sp>
-        <p:nvSpPr>
-          <p:cNvPr id="4" name="Slide Number Placeholder 3"/>
-          <p:cNvSpPr>
-            <a:spLocks xmlns:a="http://schemas.openxmlformats.org/drawingml/2006/main" noGrp="1"/>
-          </p:cNvSpPr>
-          <p:nvPr>
-            <p:ph type="sldNum" idx="5"/>
-          </p:nvPr>
-        </p:nvSpPr>
-        <p:spPr/>
-        <p:txBody>
-          <a:bodyPr xmlns:a="http://schemas.openxmlformats.org/drawingml/2006/main"/>
-          <a:lstStyle xmlns:a="http://schemas.openxmlformats.org/drawingml/2006/main"/>
-          <a:p xmlns:a="http://schemas.openxmlformats.org/drawingml/2006/main"/>
-        </p:txBody>
-      </p:sp>
-    </p:spTree>
-  </p:cSld>
-  <p:clrMapOvr>
-    <a:masterClrMapping xmlns:a="http://schemas.openxmlformats.org/drawingml/2006/main"/>
-  </p:clrMapOvr>
-</p:notes>
-</file>
-
-<file path=ppt/notesSlides/notesSlide2.xml><?xml version="1.0" encoding="utf-8"?>
-<p:notes xmlns:p="http://schemas.openxmlformats.org/presentationml/2006/main">
-  <p:cSld>
-    <p:spTree>
-      <p:nvGrpSpPr>
-        <p:cNvPr id="1" name=""/>
-        <p:cNvGrpSpPr/>
-        <p:nvPr/>
-      </p:nvGrpSpPr>
-      <p:grpSpPr>
-        <a:xfrm xmlns:a="http://schemas.openxmlformats.org/drawingml/2006/main"/>
-      </p:grpSpPr>
-      <p:sp>
-        <p:nvSpPr>
-          <p:cNvPr id="2" name="Slide Image Placeholder 1"/>
-          <p:cNvSpPr>
-            <a:spLocks xmlns:a="http://schemas.openxmlformats.org/drawingml/2006/main" noGrp="1"/>
-          </p:cNvSpPr>
-          <p:nvPr>
-            <p:ph type="sldImg" idx="0"/>
-          </p:nvPr>
-        </p:nvSpPr>
-        <p:spPr/>
-      </p:sp>
-      <p:sp>
-        <p:nvSpPr>
-          <p:cNvPr id="3" name="Notes Placeholder 2"/>
-          <p:cNvSpPr>
-            <a:spLocks xmlns:a="http://schemas.openxmlformats.org/drawingml/2006/main" noGrp="1"/>
-          </p:cNvSpPr>
-          <p:nvPr>
-            <p:ph type="body" idx="1"/>
-          </p:nvPr>
-        </p:nvSpPr>
-        <p:spPr/>
-        <p:txBody>
-          <a:bodyPr xmlns:a="http://schemas.openxmlformats.org/drawingml/2006/main"/>
-          <a:lstStyle xmlns:a="http://schemas.openxmlformats.org/drawingml/2006/main"/>
-          <a:p xmlns:a="http://schemas.openxmlformats.org/drawingml/2006/main">
-            <a:r>
-              <a:t>The HL7 conversion path covers ADT, ORU and SIU to Patient, Observation and Appointment. The expanded dataset contains 933 native FHIR resources including 265 Patient resources and 11 selected resource types. Native FHIR bypasses HL7 conversion and extends downstream analytics. Evidence also covers authenticated reviewer access, S3 encryption, batch lineage, reference resolution and configured visit-rule tests. Resource counts are source-archive calculations, not 933 HL7 conversions.</a:t>
-            </a:r>
-          </a:p>
-        </p:txBody>
-      </p:sp>
-      <p:sp>
-        <p:nvSpPr>
-          <p:cNvPr id="4" name="Slide Number Placeholder 3"/>
-          <p:cNvSpPr>
-            <a:spLocks xmlns:a="http://schemas.openxmlformats.org/drawingml/2006/main" noGrp="1"/>
-          </p:cNvSpPr>
-          <p:nvPr>
-            <p:ph type="sldNum" idx="5"/>
-          </p:nvPr>
-        </p:nvSpPr>
-        <p:spPr/>
-        <p:txBody>
-          <a:bodyPr xmlns:a="http://schemas.openxmlformats.org/drawingml/2006/main"/>
-          <a:lstStyle xmlns:a="http://schemas.openxmlformats.org/drawingml/2006/main"/>
-          <a:p xmlns:a="http://schemas.openxmlformats.org/drawingml/2006/main"/>
-        </p:txBody>
-      </p:sp>
-    </p:spTree>
-  </p:cSld>
-  <p:clrMapOvr>
-    <a:masterClrMapping xmlns:a="http://schemas.openxmlformats.org/drawingml/2006/main"/>
-  </p:clrMapOvr>
-</p:notes>
-</file>
-
-<file path=ppt/notesSlides/notesSlide3.xml><?xml version="1.0" encoding="utf-8"?>
-<p:notes xmlns:p="http://schemas.openxmlformats.org/presentationml/2006/main">
-  <p:cSld>
-    <p:spTree>
-      <p:nvGrpSpPr>
-        <p:cNvPr id="1" name=""/>
-        <p:cNvGrpSpPr/>
-        <p:nvPr/>
-      </p:nvGrpSpPr>
-      <p:grpSpPr>
-        <a:xfrm xmlns:a="http://schemas.openxmlformats.org/drawingml/2006/main"/>
-      </p:grpSpPr>
-      <p:sp>
-        <p:nvSpPr>
-          <p:cNvPr id="2" name="Slide Image Placeholder 1"/>
-          <p:cNvSpPr>
-            <a:spLocks xmlns:a="http://schemas.openxmlformats.org/drawingml/2006/main" noGrp="1"/>
-          </p:cNvSpPr>
-          <p:nvPr>
-            <p:ph type="sldImg" idx="0"/>
-          </p:nvPr>
-        </p:nvSpPr>
-        <p:spPr/>
-      </p:sp>
-      <p:sp>
-        <p:nvSpPr>
-          <p:cNvPr id="3" name="Notes Placeholder 2"/>
-          <p:cNvSpPr>
-            <a:spLocks xmlns:a="http://schemas.openxmlformats.org/drawingml/2006/main" noGrp="1"/>
-          </p:cNvSpPr>
-          <p:nvPr>
-            <p:ph type="body" idx="1"/>
-          </p:nvPr>
-        </p:nvSpPr>
-        <p:spPr/>
-        <p:txBody>
-          <a:bodyPr xmlns:a="http://schemas.openxmlformats.org/drawingml/2006/main"/>
-          <a:lstStyle xmlns:a="http://schemas.openxmlformats.org/drawingml/2006/main"/>
-          <a:p xmlns:a="http://schemas.openxmlformats.org/drawingml/2006/main">
-            <a:r>
-              <a:t>Coverage analytics describe linked records in a selected batch. Configured appointment checks apply to the demonstrated glucose rules; they do not establish clinical readiness. The authenticated reviewer UI displays configured information status and qualifying-result counts. The invitation is for peer feedback and potential collaboration.</a:t>
-            </a:r>
-          </a:p>
-        </p:txBody>
-      </p:sp>
-      <p:sp>
-        <p:nvSpPr>
-          <p:cNvPr id="4" name="Slide Number Placeholder 3"/>
-          <p:cNvSpPr>
-            <a:spLocks xmlns:a="http://schemas.openxmlformats.org/drawingml/2006/main" noGrp="1"/>
-          </p:cNvSpPr>
-          <p:nvPr>
-            <p:ph type="sldNum" idx="5"/>
-          </p:nvPr>
-        </p:nvSpPr>
-        <p:spPr/>
-        <p:txBody>
-          <a:bodyPr xmlns:a="http://schemas.openxmlformats.org/drawingml/2006/main"/>
-          <a:lstStyle xmlns:a="http://schemas.openxmlformats.org/drawingml/2006/main"/>
-          <a:p xmlns:a="http://schemas.openxmlformats.org/drawingml/2006/main"/>
-        </p:txBody>
-      </p:sp>
-    </p:spTree>
-  </p:cSld>
-  <p:clrMapOvr>
-    <a:masterClrMapping xmlns:a="http://schemas.openxmlformats.org/drawingml/2006/main"/>
-  </p:clrMapOvr>
-</p:notes>
-</file>
-
 <file path=ppt/slideLayouts/slideLayout1.xml><?xml version="1.0" encoding="utf-8"?>
-<p:sldLayout xmlns:p="http://schemas.openxmlformats.org/presentationml/2006/main" type="title">
+<p:sldLayout xmlns:a="http://schemas.openxmlformats.org/drawingml/2006/main" xmlns:r="http://schemas.openxmlformats.org/officeDocument/2006/relationships" xmlns:p="http://schemas.openxmlformats.org/presentationml/2006/main" type="title">
   <p:cSld name="Title Slide">
     <p:spTree>
       <p:nvGrpSpPr>
@@ -624,43 +502,48 @@
         <p:nvPr/>
       </p:nvGrpSpPr>
       <p:grpSpPr>
-        <a:xfrm xmlns:a="http://schemas.openxmlformats.org/drawingml/2006/main"/>
+        <a:xfrm>
+          <a:off x="0" y="0"/>
+          <a:ext cx="0" cy="0"/>
+          <a:chOff x="0" y="0"/>
+          <a:chExt cx="0" cy="0"/>
+        </a:xfrm>
       </p:grpSpPr>
       <p:sp>
         <p:nvSpPr>
           <p:cNvPr id="3" name="Title">
-            <a:extLst xmlns:a="http://schemas.openxmlformats.org/drawingml/2006/main">
+            <a:extLst>
               <a:ext uri="{FF2B5EF4-FFF2-40B4-BE49-F238E27FC236}">
-                <a16:creationId xmlns:a16="http://schemas.microsoft.com/office/drawing/2014/main" id="{24CEAAB9-1997-4A08-A3D7-8A751A6A9470}"/>
+                <a16:creationId xmlns:a16="http://schemas.microsoft.com/office/drawing/2014/main" id="{574FB671-E886-4058-9CF1-ACC68DC066C4}"/>
               </a:ext>
             </a:extLst>
           </p:cNvPr>
           <p:cNvSpPr>
-            <a:spLocks xmlns:a="http://schemas.openxmlformats.org/drawingml/2006/main" noGrp="1"/>
+            <a:spLocks noGrp="1"/>
           </p:cNvSpPr>
           <p:nvPr>
-            <p:ph type="title" idx="0"/>
+            <p:ph type="title"/>
           </p:nvPr>
         </p:nvSpPr>
         <p:spPr>
-          <a:xfrm xmlns:a="http://schemas.openxmlformats.org/drawingml/2006/main">
+          <a:xfrm>
             <a:off x="1028700" y="3886200"/>
             <a:ext cx="8229600" cy="1485900"/>
           </a:xfrm>
-          <a:prstGeom xmlns:a="http://schemas.openxmlformats.org/drawingml/2006/main" prst="rect">
+          <a:prstGeom prst="rect">
             <a:avLst/>
           </a:prstGeom>
-          <a:noFill xmlns:a="http://schemas.openxmlformats.org/drawingml/2006/main"/>
-          <a:ln xmlns:a="http://schemas.openxmlformats.org/drawingml/2006/main">
+          <a:noFill/>
+          <a:ln>
             <a:noFill/>
             <a:prstDash val="solid"/>
           </a:ln>
         </p:spPr>
         <p:txBody>
-          <a:bodyPr xmlns:a="http://schemas.openxmlformats.org/drawingml/2006/main" wrap="square" lIns="0" tIns="0" rIns="0" bIns="0" anchor="ctr">
+          <a:bodyPr wrap="square" lIns="0" tIns="0" rIns="0" bIns="0" anchor="ctr">
             <a:normAutofit/>
           </a:bodyPr>
-          <a:lstStyle xmlns:a="http://schemas.openxmlformats.org/drawingml/2006/main">
+          <a:lstStyle>
             <a:defPPr algn="ctr">
               <a:defRPr sz="4050" b="1">
                 <a:solidFill>
@@ -780,44 +663,46 @@
               <a:buNone/>
             </a:lvl9pPr>
           </a:lstStyle>
-          <a:p xmlns:a="http://schemas.openxmlformats.org/drawingml/2006/main"/>
+          <a:p>
+            <a:endParaRPr/>
+          </a:p>
         </p:txBody>
       </p:sp>
       <p:sp>
         <p:nvSpPr>
           <p:cNvPr id="2" name="Subtitle">
-            <a:extLst xmlns:a="http://schemas.openxmlformats.org/drawingml/2006/main">
+            <a:extLst>
               <a:ext uri="{FF2B5EF4-FFF2-40B4-BE49-F238E27FC236}">
-                <a16:creationId xmlns:a16="http://schemas.microsoft.com/office/drawing/2014/main" id="{39A940A7-7C41-4ED6-BC7F-7F63299C0B16}"/>
+                <a16:creationId xmlns:a16="http://schemas.microsoft.com/office/drawing/2014/main" id="{17CB344D-9ED6-4974-A1CC-6CD6A46CA05B}"/>
               </a:ext>
             </a:extLst>
           </p:cNvPr>
           <p:cNvSpPr>
-            <a:spLocks xmlns:a="http://schemas.openxmlformats.org/drawingml/2006/main" noGrp="1"/>
+            <a:spLocks noGrp="1"/>
           </p:cNvSpPr>
           <p:nvPr>
             <p:ph type="subTitle" idx="1"/>
           </p:nvPr>
         </p:nvSpPr>
         <p:spPr>
-          <a:xfrm xmlns:a="http://schemas.openxmlformats.org/drawingml/2006/main">
+          <a:xfrm>
             <a:off x="1543050" y="5657850"/>
             <a:ext cx="7200900" cy="1143000"/>
           </a:xfrm>
-          <a:prstGeom xmlns:a="http://schemas.openxmlformats.org/drawingml/2006/main" prst="rect">
+          <a:prstGeom prst="rect">
             <a:avLst/>
           </a:prstGeom>
-          <a:noFill xmlns:a="http://schemas.openxmlformats.org/drawingml/2006/main"/>
-          <a:ln xmlns:a="http://schemas.openxmlformats.org/drawingml/2006/main">
+          <a:noFill/>
+          <a:ln>
             <a:noFill/>
             <a:prstDash val="solid"/>
           </a:ln>
         </p:spPr>
         <p:txBody>
-          <a:bodyPr xmlns:a="http://schemas.openxmlformats.org/drawingml/2006/main" wrap="square" lIns="0" tIns="0" rIns="0" bIns="0" anchor="ctr">
+          <a:bodyPr wrap="square" lIns="0" tIns="0" rIns="0" bIns="0" anchor="ctr">
             <a:normAutofit/>
           </a:bodyPr>
-          <a:lstStyle xmlns:a="http://schemas.openxmlformats.org/drawingml/2006/main">
+          <a:lstStyle>
             <a:defPPr algn="ctr">
               <a:defRPr sz="1772" b="0">
                 <a:solidFill>
@@ -937,16 +822,21 @@
               <a:buNone/>
             </a:lvl9pPr>
           </a:lstStyle>
-          <a:p xmlns:a="http://schemas.openxmlformats.org/drawingml/2006/main"/>
+          <a:p>
+            <a:endParaRPr/>
+          </a:p>
         </p:txBody>
       </p:sp>
     </p:spTree>
   </p:cSld>
+  <p:clrMapOvr>
+    <a:masterClrMapping/>
+  </p:clrMapOvr>
 </p:sldLayout>
 </file>
 
 <file path=ppt/slideLayouts/slideLayout2.xml><?xml version="1.0" encoding="utf-8"?>
-<p:sldLayout xmlns:p="http://schemas.openxmlformats.org/presentationml/2006/main">
+<p:sldLayout xmlns:a="http://schemas.openxmlformats.org/drawingml/2006/main" xmlns:r="http://schemas.openxmlformats.org/officeDocument/2006/relationships" xmlns:p="http://schemas.openxmlformats.org/presentationml/2006/main">
   <p:cSld name="Section Header">
     <p:spTree>
       <p:nvGrpSpPr>
@@ -955,43 +845,48 @@
         <p:nvPr/>
       </p:nvGrpSpPr>
       <p:grpSpPr>
-        <a:xfrm xmlns:a="http://schemas.openxmlformats.org/drawingml/2006/main"/>
+        <a:xfrm>
+          <a:off x="0" y="0"/>
+          <a:ext cx="0" cy="0"/>
+          <a:chOff x="0" y="0"/>
+          <a:chExt cx="0" cy="0"/>
+        </a:xfrm>
       </p:grpSpPr>
       <p:sp>
         <p:nvSpPr>
           <p:cNvPr id="2" name="Section title">
-            <a:extLst xmlns:a="http://schemas.openxmlformats.org/drawingml/2006/main">
+            <a:extLst>
               <a:ext uri="{FF2B5EF4-FFF2-40B4-BE49-F238E27FC236}">
-                <a16:creationId xmlns:a16="http://schemas.microsoft.com/office/drawing/2014/main" id="{101296BA-84BE-4C1B-BEF7-252B8A64A690}"/>
+                <a16:creationId xmlns:a16="http://schemas.microsoft.com/office/drawing/2014/main" id="{983EFA4F-5634-4085-8A7C-9664D5091B46}"/>
               </a:ext>
             </a:extLst>
           </p:cNvPr>
           <p:cNvSpPr>
-            <a:spLocks xmlns:a="http://schemas.openxmlformats.org/drawingml/2006/main" noGrp="1"/>
+            <a:spLocks noGrp="1"/>
           </p:cNvSpPr>
           <p:nvPr>
-            <p:ph type="title" idx="0"/>
+            <p:ph type="title"/>
           </p:nvPr>
         </p:nvSpPr>
         <p:spPr>
-          <a:xfrm xmlns:a="http://schemas.openxmlformats.org/drawingml/2006/main">
+          <a:xfrm>
             <a:off x="1028700" y="4286250"/>
             <a:ext cx="8229600" cy="1714500"/>
           </a:xfrm>
-          <a:prstGeom xmlns:a="http://schemas.openxmlformats.org/drawingml/2006/main" prst="rect">
+          <a:prstGeom prst="rect">
             <a:avLst/>
           </a:prstGeom>
-          <a:noFill xmlns:a="http://schemas.openxmlformats.org/drawingml/2006/main"/>
-          <a:ln xmlns:a="http://schemas.openxmlformats.org/drawingml/2006/main">
+          <a:noFill/>
+          <a:ln>
             <a:noFill/>
             <a:prstDash val="solid"/>
           </a:ln>
         </p:spPr>
         <p:txBody>
-          <a:bodyPr xmlns:a="http://schemas.openxmlformats.org/drawingml/2006/main" wrap="square" lIns="0" tIns="0" rIns="0" bIns="0" anchor="ctr">
+          <a:bodyPr wrap="square" lIns="0" tIns="0" rIns="0" bIns="0" anchor="ctr">
             <a:normAutofit/>
           </a:bodyPr>
-          <a:lstStyle xmlns:a="http://schemas.openxmlformats.org/drawingml/2006/main">
+          <a:lstStyle>
             <a:defPPr algn="ctr">
               <a:defRPr sz="3544" b="1">
                 <a:solidFill>
@@ -1111,16 +1006,21 @@
               <a:buNone/>
             </a:lvl9pPr>
           </a:lstStyle>
-          <a:p xmlns:a="http://schemas.openxmlformats.org/drawingml/2006/main"/>
+          <a:p>
+            <a:endParaRPr/>
+          </a:p>
         </p:txBody>
       </p:sp>
     </p:spTree>
   </p:cSld>
+  <p:clrMapOvr>
+    <a:masterClrMapping/>
+  </p:clrMapOvr>
 </p:sldLayout>
 </file>
 
 <file path=ppt/slideLayouts/slideLayout3.xml><?xml version="1.0" encoding="utf-8"?>
-<p:sldLayout xmlns:p="http://schemas.openxmlformats.org/presentationml/2006/main">
+<p:sldLayout xmlns:a="http://schemas.openxmlformats.org/drawingml/2006/main" xmlns:r="http://schemas.openxmlformats.org/officeDocument/2006/relationships" xmlns:p="http://schemas.openxmlformats.org/presentationml/2006/main">
   <p:cSld name="Title and Body">
     <p:spTree>
       <p:nvGrpSpPr>
@@ -1129,43 +1029,48 @@
         <p:nvPr/>
       </p:nvGrpSpPr>
       <p:grpSpPr>
-        <a:xfrm xmlns:a="http://schemas.openxmlformats.org/drawingml/2006/main"/>
+        <a:xfrm>
+          <a:off x="0" y="0"/>
+          <a:ext cx="0" cy="0"/>
+          <a:chOff x="0" y="0"/>
+          <a:chExt cx="0" cy="0"/>
+        </a:xfrm>
       </p:grpSpPr>
       <p:sp>
         <p:nvSpPr>
           <p:cNvPr id="3" name="Title">
-            <a:extLst xmlns:a="http://schemas.openxmlformats.org/drawingml/2006/main">
+            <a:extLst>
               <a:ext uri="{FF2B5EF4-FFF2-40B4-BE49-F238E27FC236}">
-                <a16:creationId xmlns:a16="http://schemas.microsoft.com/office/drawing/2014/main" id="{FB943513-A5E7-4A6C-BB52-522CA9886B4B}"/>
+                <a16:creationId xmlns:a16="http://schemas.microsoft.com/office/drawing/2014/main" id="{408C2A43-FD50-4B6E-8DAD-E9BCDBEEA533}"/>
               </a:ext>
             </a:extLst>
           </p:cNvPr>
           <p:cNvSpPr>
-            <a:spLocks xmlns:a="http://schemas.openxmlformats.org/drawingml/2006/main" noGrp="1"/>
+            <a:spLocks noGrp="1"/>
           </p:cNvSpPr>
           <p:nvPr>
-            <p:ph type="title" idx="0"/>
+            <p:ph type="title"/>
           </p:nvPr>
         </p:nvSpPr>
         <p:spPr>
-          <a:xfrm xmlns:a="http://schemas.openxmlformats.org/drawingml/2006/main">
+          <a:xfrm>
             <a:off x="578644" y="800100"/>
             <a:ext cx="9129713" cy="1257300"/>
           </a:xfrm>
-          <a:prstGeom xmlns:a="http://schemas.openxmlformats.org/drawingml/2006/main" prst="rect">
+          <a:prstGeom prst="rect">
             <a:avLst/>
           </a:prstGeom>
-          <a:noFill xmlns:a="http://schemas.openxmlformats.org/drawingml/2006/main"/>
-          <a:ln xmlns:a="http://schemas.openxmlformats.org/drawingml/2006/main">
+          <a:noFill/>
+          <a:ln>
             <a:noFill/>
             <a:prstDash val="solid"/>
           </a:ln>
         </p:spPr>
         <p:txBody>
-          <a:bodyPr xmlns:a="http://schemas.openxmlformats.org/drawingml/2006/main" wrap="square" lIns="0" tIns="0" rIns="0" bIns="0" anchor="t">
+          <a:bodyPr wrap="square" lIns="0" tIns="0" rIns="0" bIns="0" anchor="t">
             <a:normAutofit/>
           </a:bodyPr>
-          <a:lstStyle xmlns:a="http://schemas.openxmlformats.org/drawingml/2006/main">
+          <a:lstStyle>
             <a:defPPr algn="l">
               <a:defRPr sz="2784" b="1">
                 <a:solidFill>
@@ -1285,44 +1190,46 @@
               <a:buNone/>
             </a:lvl9pPr>
           </a:lstStyle>
-          <a:p xmlns:a="http://schemas.openxmlformats.org/drawingml/2006/main"/>
+          <a:p>
+            <a:endParaRPr/>
+          </a:p>
         </p:txBody>
       </p:sp>
       <p:sp>
         <p:nvSpPr>
           <p:cNvPr id="2" name="Body">
-            <a:extLst xmlns:a="http://schemas.openxmlformats.org/drawingml/2006/main">
+            <a:extLst>
               <a:ext uri="{FF2B5EF4-FFF2-40B4-BE49-F238E27FC236}">
-                <a16:creationId xmlns:a16="http://schemas.microsoft.com/office/drawing/2014/main" id="{ECE930CF-6530-4B0F-9D2D-C560D8F55B91}"/>
+                <a16:creationId xmlns:a16="http://schemas.microsoft.com/office/drawing/2014/main" id="{84216F54-EE3B-42F4-9F11-DA2A1B13468F}"/>
               </a:ext>
             </a:extLst>
           </p:cNvPr>
           <p:cNvSpPr>
-            <a:spLocks xmlns:a="http://schemas.openxmlformats.org/drawingml/2006/main" noGrp="1"/>
+            <a:spLocks noGrp="1"/>
           </p:cNvSpPr>
           <p:nvPr>
             <p:ph type="body" idx="1"/>
           </p:nvPr>
         </p:nvSpPr>
         <p:spPr>
-          <a:xfrm xmlns:a="http://schemas.openxmlformats.org/drawingml/2006/main">
+          <a:xfrm>
             <a:off x="578644" y="2857500"/>
             <a:ext cx="9129713" cy="6400800"/>
           </a:xfrm>
-          <a:prstGeom xmlns:a="http://schemas.openxmlformats.org/drawingml/2006/main" prst="rect">
+          <a:prstGeom prst="rect">
             <a:avLst/>
           </a:prstGeom>
-          <a:noFill xmlns:a="http://schemas.openxmlformats.org/drawingml/2006/main"/>
-          <a:ln xmlns:a="http://schemas.openxmlformats.org/drawingml/2006/main">
+          <a:noFill/>
+          <a:ln>
             <a:noFill/>
             <a:prstDash val="solid"/>
           </a:ln>
         </p:spPr>
         <p:txBody>
-          <a:bodyPr xmlns:a="http://schemas.openxmlformats.org/drawingml/2006/main" wrap="square" lIns="0" tIns="0" rIns="0" bIns="0" anchor="t">
+          <a:bodyPr wrap="square" lIns="0" tIns="0" rIns="0" bIns="0" anchor="t">
             <a:normAutofit/>
           </a:bodyPr>
-          <a:lstStyle xmlns:a="http://schemas.openxmlformats.org/drawingml/2006/main">
+          <a:lstStyle>
             <a:defPPr algn="l">
               <a:defRPr sz="1898" b="0">
                 <a:solidFill>
@@ -1442,16 +1349,21 @@
               <a:buChar char="•"/>
             </a:lvl9pPr>
           </a:lstStyle>
-          <a:p xmlns:a="http://schemas.openxmlformats.org/drawingml/2006/main"/>
+          <a:p>
+            <a:endParaRPr/>
+          </a:p>
         </p:txBody>
       </p:sp>
     </p:spTree>
   </p:cSld>
+  <p:clrMapOvr>
+    <a:masterClrMapping/>
+  </p:clrMapOvr>
 </p:sldLayout>
 </file>
 
 <file path=ppt/slideLayouts/slideLayout4.xml><?xml version="1.0" encoding="utf-8"?>
-<p:sldLayout xmlns:p="http://schemas.openxmlformats.org/presentationml/2006/main">
+<p:sldLayout xmlns:a="http://schemas.openxmlformats.org/drawingml/2006/main" xmlns:r="http://schemas.openxmlformats.org/officeDocument/2006/relationships" xmlns:p="http://schemas.openxmlformats.org/presentationml/2006/main">
   <p:cSld name="Title and Two Column">
     <p:spTree>
       <p:nvGrpSpPr>
@@ -1460,43 +1372,48 @@
         <p:nvPr/>
       </p:nvGrpSpPr>
       <p:grpSpPr>
-        <a:xfrm xmlns:a="http://schemas.openxmlformats.org/drawingml/2006/main"/>
+        <a:xfrm>
+          <a:off x="0" y="0"/>
+          <a:ext cx="0" cy="0"/>
+          <a:chOff x="0" y="0"/>
+          <a:chExt cx="0" cy="0"/>
+        </a:xfrm>
       </p:grpSpPr>
       <p:sp>
         <p:nvSpPr>
           <p:cNvPr id="4" name="Title">
-            <a:extLst xmlns:a="http://schemas.openxmlformats.org/drawingml/2006/main">
+            <a:extLst>
               <a:ext uri="{FF2B5EF4-FFF2-40B4-BE49-F238E27FC236}">
-                <a16:creationId xmlns:a16="http://schemas.microsoft.com/office/drawing/2014/main" id="{4189F6A7-3A31-4EF7-8CE1-9A30B56A7706}"/>
+                <a16:creationId xmlns:a16="http://schemas.microsoft.com/office/drawing/2014/main" id="{2D6A2A13-B3CF-450E-A034-48E8E81DD709}"/>
               </a:ext>
             </a:extLst>
           </p:cNvPr>
           <p:cNvSpPr>
-            <a:spLocks xmlns:a="http://schemas.openxmlformats.org/drawingml/2006/main" noGrp="1"/>
+            <a:spLocks noGrp="1"/>
           </p:cNvSpPr>
           <p:nvPr>
-            <p:ph type="title" idx="0"/>
+            <p:ph type="title"/>
           </p:nvPr>
         </p:nvSpPr>
         <p:spPr>
-          <a:xfrm xmlns:a="http://schemas.openxmlformats.org/drawingml/2006/main">
+          <a:xfrm>
             <a:off x="578644" y="800100"/>
             <a:ext cx="9129713" cy="1257300"/>
           </a:xfrm>
-          <a:prstGeom xmlns:a="http://schemas.openxmlformats.org/drawingml/2006/main" prst="rect">
+          <a:prstGeom prst="rect">
             <a:avLst/>
           </a:prstGeom>
-          <a:noFill xmlns:a="http://schemas.openxmlformats.org/drawingml/2006/main"/>
-          <a:ln xmlns:a="http://schemas.openxmlformats.org/drawingml/2006/main">
+          <a:noFill/>
+          <a:ln>
             <a:noFill/>
             <a:prstDash val="solid"/>
           </a:ln>
         </p:spPr>
         <p:txBody>
-          <a:bodyPr xmlns:a="http://schemas.openxmlformats.org/drawingml/2006/main" wrap="square" lIns="0" tIns="0" rIns="0" bIns="0" anchor="t">
+          <a:bodyPr wrap="square" lIns="0" tIns="0" rIns="0" bIns="0" anchor="t">
             <a:normAutofit/>
           </a:bodyPr>
-          <a:lstStyle xmlns:a="http://schemas.openxmlformats.org/drawingml/2006/main">
+          <a:lstStyle>
             <a:defPPr algn="l">
               <a:defRPr sz="2784" b="1">
                 <a:solidFill>
@@ -1616,44 +1533,46 @@
               <a:buNone/>
             </a:lvl9pPr>
           </a:lstStyle>
-          <a:p xmlns:a="http://schemas.openxmlformats.org/drawingml/2006/main"/>
+          <a:p>
+            <a:endParaRPr/>
+          </a:p>
         </p:txBody>
       </p:sp>
       <p:sp>
         <p:nvSpPr>
           <p:cNvPr id="2" name="Left column">
-            <a:extLst xmlns:a="http://schemas.openxmlformats.org/drawingml/2006/main">
+            <a:extLst>
               <a:ext uri="{FF2B5EF4-FFF2-40B4-BE49-F238E27FC236}">
-                <a16:creationId xmlns:a16="http://schemas.microsoft.com/office/drawing/2014/main" id="{A8F968F1-4395-45A9-928A-DC0F7E57A84E}"/>
+                <a16:creationId xmlns:a16="http://schemas.microsoft.com/office/drawing/2014/main" id="{82DD80B6-D6AA-49BD-96AF-F293426EC8E0}"/>
               </a:ext>
             </a:extLst>
           </p:cNvPr>
           <p:cNvSpPr>
-            <a:spLocks xmlns:a="http://schemas.openxmlformats.org/drawingml/2006/main" noGrp="1"/>
+            <a:spLocks noGrp="1"/>
           </p:cNvSpPr>
           <p:nvPr>
             <p:ph type="body" idx="1"/>
           </p:nvPr>
         </p:nvSpPr>
         <p:spPr>
-          <a:xfrm xmlns:a="http://schemas.openxmlformats.org/drawingml/2006/main">
+          <a:xfrm>
             <a:off x="578644" y="2857500"/>
             <a:ext cx="4243388" cy="6400800"/>
           </a:xfrm>
-          <a:prstGeom xmlns:a="http://schemas.openxmlformats.org/drawingml/2006/main" prst="rect">
+          <a:prstGeom prst="rect">
             <a:avLst/>
           </a:prstGeom>
-          <a:noFill xmlns:a="http://schemas.openxmlformats.org/drawingml/2006/main"/>
-          <a:ln xmlns:a="http://schemas.openxmlformats.org/drawingml/2006/main">
+          <a:noFill/>
+          <a:ln>
             <a:noFill/>
             <a:prstDash val="solid"/>
           </a:ln>
         </p:spPr>
         <p:txBody>
-          <a:bodyPr xmlns:a="http://schemas.openxmlformats.org/drawingml/2006/main" wrap="square" lIns="0" tIns="0" rIns="0" bIns="0" anchor="t">
+          <a:bodyPr wrap="square" lIns="0" tIns="0" rIns="0" bIns="0" anchor="t">
             <a:normAutofit/>
           </a:bodyPr>
-          <a:lstStyle xmlns:a="http://schemas.openxmlformats.org/drawingml/2006/main">
+          <a:lstStyle>
             <a:defPPr algn="l">
               <a:defRPr sz="1772" b="0">
                 <a:solidFill>
@@ -1773,44 +1692,46 @@
               <a:buChar char="•"/>
             </a:lvl9pPr>
           </a:lstStyle>
-          <a:p xmlns:a="http://schemas.openxmlformats.org/drawingml/2006/main"/>
+          <a:p>
+            <a:endParaRPr/>
+          </a:p>
         </p:txBody>
       </p:sp>
       <p:sp>
         <p:nvSpPr>
           <p:cNvPr id="3" name="Right column">
-            <a:extLst xmlns:a="http://schemas.openxmlformats.org/drawingml/2006/main">
+            <a:extLst>
               <a:ext uri="{FF2B5EF4-FFF2-40B4-BE49-F238E27FC236}">
-                <a16:creationId xmlns:a16="http://schemas.microsoft.com/office/drawing/2014/main" id="{0AAEB1EE-E89E-4C18-B76A-9641DAA08D06}"/>
+                <a16:creationId xmlns:a16="http://schemas.microsoft.com/office/drawing/2014/main" id="{57A7FA01-33C8-465A-AC08-ADF192E220B7}"/>
               </a:ext>
             </a:extLst>
           </p:cNvPr>
           <p:cNvSpPr>
-            <a:spLocks xmlns:a="http://schemas.openxmlformats.org/drawingml/2006/main" noGrp="1"/>
+            <a:spLocks noGrp="1"/>
           </p:cNvSpPr>
           <p:nvPr>
             <p:ph type="body" idx="2"/>
           </p:nvPr>
         </p:nvSpPr>
         <p:spPr>
-          <a:xfrm xmlns:a="http://schemas.openxmlformats.org/drawingml/2006/main">
+          <a:xfrm>
             <a:off x="5464969" y="2857500"/>
             <a:ext cx="4243388" cy="6400800"/>
           </a:xfrm>
-          <a:prstGeom xmlns:a="http://schemas.openxmlformats.org/drawingml/2006/main" prst="rect">
+          <a:prstGeom prst="rect">
             <a:avLst/>
           </a:prstGeom>
-          <a:noFill xmlns:a="http://schemas.openxmlformats.org/drawingml/2006/main"/>
-          <a:ln xmlns:a="http://schemas.openxmlformats.org/drawingml/2006/main">
+          <a:noFill/>
+          <a:ln>
             <a:noFill/>
             <a:prstDash val="solid"/>
           </a:ln>
         </p:spPr>
         <p:txBody>
-          <a:bodyPr xmlns:a="http://schemas.openxmlformats.org/drawingml/2006/main" wrap="square" lIns="0" tIns="0" rIns="0" bIns="0" anchor="t">
+          <a:bodyPr wrap="square" lIns="0" tIns="0" rIns="0" bIns="0" anchor="t">
             <a:normAutofit/>
           </a:bodyPr>
-          <a:lstStyle xmlns:a="http://schemas.openxmlformats.org/drawingml/2006/main">
+          <a:lstStyle>
             <a:defPPr algn="l">
               <a:defRPr sz="1772" b="0">
                 <a:solidFill>
@@ -1930,16 +1851,21 @@
               <a:buChar char="•"/>
             </a:lvl9pPr>
           </a:lstStyle>
-          <a:p xmlns:a="http://schemas.openxmlformats.org/drawingml/2006/main"/>
+          <a:p>
+            <a:endParaRPr/>
+          </a:p>
         </p:txBody>
       </p:sp>
     </p:spTree>
   </p:cSld>
+  <p:clrMapOvr>
+    <a:masterClrMapping/>
+  </p:clrMapOvr>
 </p:sldLayout>
 </file>
 
 <file path=ppt/slideLayouts/slideLayout5.xml><?xml version="1.0" encoding="utf-8"?>
-<p:sldLayout xmlns:p="http://schemas.openxmlformats.org/presentationml/2006/main">
+<p:sldLayout xmlns:a="http://schemas.openxmlformats.org/drawingml/2006/main" xmlns:r="http://schemas.openxmlformats.org/officeDocument/2006/relationships" xmlns:p="http://schemas.openxmlformats.org/presentationml/2006/main">
   <p:cSld name="Title and One Column">
     <p:spTree>
       <p:nvGrpSpPr>
@@ -1948,43 +1874,48 @@
         <p:nvPr/>
       </p:nvGrpSpPr>
       <p:grpSpPr>
-        <a:xfrm xmlns:a="http://schemas.openxmlformats.org/drawingml/2006/main"/>
+        <a:xfrm>
+          <a:off x="0" y="0"/>
+          <a:ext cx="0" cy="0"/>
+          <a:chOff x="0" y="0"/>
+          <a:chExt cx="0" cy="0"/>
+        </a:xfrm>
       </p:grpSpPr>
       <p:sp>
         <p:nvSpPr>
           <p:cNvPr id="3" name="Title">
-            <a:extLst xmlns:a="http://schemas.openxmlformats.org/drawingml/2006/main">
+            <a:extLst>
               <a:ext uri="{FF2B5EF4-FFF2-40B4-BE49-F238E27FC236}">
-                <a16:creationId xmlns:a16="http://schemas.microsoft.com/office/drawing/2014/main" id="{E79F60E8-3B60-4464-ABCD-4FE35D564F00}"/>
+                <a16:creationId xmlns:a16="http://schemas.microsoft.com/office/drawing/2014/main" id="{D9D3ACBB-E69C-46A5-8E68-28A014E92A83}"/>
               </a:ext>
             </a:extLst>
           </p:cNvPr>
           <p:cNvSpPr>
-            <a:spLocks xmlns:a="http://schemas.openxmlformats.org/drawingml/2006/main" noGrp="1"/>
+            <a:spLocks noGrp="1"/>
           </p:cNvSpPr>
           <p:nvPr>
-            <p:ph type="title" idx="0"/>
+            <p:ph type="title"/>
           </p:nvPr>
         </p:nvSpPr>
         <p:spPr>
-          <a:xfrm xmlns:a="http://schemas.openxmlformats.org/drawingml/2006/main">
+          <a:xfrm>
             <a:off x="578644" y="800100"/>
             <a:ext cx="9129713" cy="1257300"/>
           </a:xfrm>
-          <a:prstGeom xmlns:a="http://schemas.openxmlformats.org/drawingml/2006/main" prst="rect">
+          <a:prstGeom prst="rect">
             <a:avLst/>
           </a:prstGeom>
-          <a:noFill xmlns:a="http://schemas.openxmlformats.org/drawingml/2006/main"/>
-          <a:ln xmlns:a="http://schemas.openxmlformats.org/drawingml/2006/main">
+          <a:noFill/>
+          <a:ln>
             <a:noFill/>
             <a:prstDash val="solid"/>
           </a:ln>
         </p:spPr>
         <p:txBody>
-          <a:bodyPr xmlns:a="http://schemas.openxmlformats.org/drawingml/2006/main" wrap="square" lIns="0" tIns="0" rIns="0" bIns="0" anchor="t">
+          <a:bodyPr wrap="square" lIns="0" tIns="0" rIns="0" bIns="0" anchor="t">
             <a:normAutofit/>
           </a:bodyPr>
-          <a:lstStyle xmlns:a="http://schemas.openxmlformats.org/drawingml/2006/main">
+          <a:lstStyle>
             <a:defPPr algn="l">
               <a:defRPr sz="2784" b="1">
                 <a:solidFill>
@@ -2104,44 +2035,46 @@
               <a:buNone/>
             </a:lvl9pPr>
           </a:lstStyle>
-          <a:p xmlns:a="http://schemas.openxmlformats.org/drawingml/2006/main"/>
+          <a:p>
+            <a:endParaRPr/>
+          </a:p>
         </p:txBody>
       </p:sp>
       <p:sp>
         <p:nvSpPr>
           <p:cNvPr id="2" name="Left column">
-            <a:extLst xmlns:a="http://schemas.openxmlformats.org/drawingml/2006/main">
+            <a:extLst>
               <a:ext uri="{FF2B5EF4-FFF2-40B4-BE49-F238E27FC236}">
-                <a16:creationId xmlns:a16="http://schemas.microsoft.com/office/drawing/2014/main" id="{41E9AE46-7C3B-4E89-9F94-5991C593B52B}"/>
+                <a16:creationId xmlns:a16="http://schemas.microsoft.com/office/drawing/2014/main" id="{90B1DC8D-A69B-4733-8B7B-077292FFCABB}"/>
               </a:ext>
             </a:extLst>
           </p:cNvPr>
           <p:cNvSpPr>
-            <a:spLocks xmlns:a="http://schemas.openxmlformats.org/drawingml/2006/main" noGrp="1"/>
+            <a:spLocks noGrp="1"/>
           </p:cNvSpPr>
           <p:nvPr>
             <p:ph type="body" idx="1"/>
           </p:nvPr>
         </p:nvSpPr>
         <p:spPr>
-          <a:xfrm xmlns:a="http://schemas.openxmlformats.org/drawingml/2006/main">
+          <a:xfrm>
             <a:off x="578644" y="2857500"/>
             <a:ext cx="4243388" cy="6400800"/>
           </a:xfrm>
-          <a:prstGeom xmlns:a="http://schemas.openxmlformats.org/drawingml/2006/main" prst="rect">
+          <a:prstGeom prst="rect">
             <a:avLst/>
           </a:prstGeom>
-          <a:noFill xmlns:a="http://schemas.openxmlformats.org/drawingml/2006/main"/>
-          <a:ln xmlns:a="http://schemas.openxmlformats.org/drawingml/2006/main">
+          <a:noFill/>
+          <a:ln>
             <a:noFill/>
             <a:prstDash val="solid"/>
           </a:ln>
         </p:spPr>
         <p:txBody>
-          <a:bodyPr xmlns:a="http://schemas.openxmlformats.org/drawingml/2006/main" wrap="square" lIns="0" tIns="0" rIns="0" bIns="0" anchor="t">
+          <a:bodyPr wrap="square" lIns="0" tIns="0" rIns="0" bIns="0" anchor="t">
             <a:normAutofit/>
           </a:bodyPr>
-          <a:lstStyle xmlns:a="http://schemas.openxmlformats.org/drawingml/2006/main">
+          <a:lstStyle>
             <a:defPPr algn="l">
               <a:defRPr sz="1898" b="0">
                 <a:solidFill>
@@ -2261,16 +2194,21 @@
               <a:buChar char="•"/>
             </a:lvl9pPr>
           </a:lstStyle>
-          <a:p xmlns:a="http://schemas.openxmlformats.org/drawingml/2006/main"/>
+          <a:p>
+            <a:endParaRPr/>
+          </a:p>
         </p:txBody>
       </p:sp>
     </p:spTree>
   </p:cSld>
+  <p:clrMapOvr>
+    <a:masterClrMapping/>
+  </p:clrMapOvr>
 </p:sldLayout>
 </file>
 
 <file path=ppt/slideLayouts/slideLayout6.xml><?xml version="1.0" encoding="utf-8"?>
-<p:sldLayout xmlns:p="http://schemas.openxmlformats.org/presentationml/2006/main" type="blank">
+<p:sldLayout xmlns:a="http://schemas.openxmlformats.org/drawingml/2006/main" xmlns:r="http://schemas.openxmlformats.org/officeDocument/2006/relationships" xmlns:p="http://schemas.openxmlformats.org/presentationml/2006/main" type="blank">
   <p:cSld name="Blank">
     <p:spTree>
       <p:nvGrpSpPr>
@@ -2279,19 +2217,27 @@
         <p:nvPr/>
       </p:nvGrpSpPr>
       <p:grpSpPr>
-        <a:xfrm xmlns:a="http://schemas.openxmlformats.org/drawingml/2006/main"/>
+        <a:xfrm>
+          <a:off x="0" y="0"/>
+          <a:ext cx="0" cy="0"/>
+          <a:chOff x="0" y="0"/>
+          <a:chExt cx="0" cy="0"/>
+        </a:xfrm>
       </p:grpSpPr>
     </p:spTree>
   </p:cSld>
+  <p:clrMapOvr>
+    <a:masterClrMapping/>
+  </p:clrMapOvr>
 </p:sldLayout>
 </file>
 
 <file path=ppt/slideMasters/slideMaster1.xml><?xml version="1.0" encoding="utf-8"?>
-<p:sldMaster xmlns:p="http://schemas.openxmlformats.org/presentationml/2006/main">
+<p:sldMaster xmlns:a="http://schemas.openxmlformats.org/drawingml/2006/main" xmlns:r="http://schemas.openxmlformats.org/officeDocument/2006/relationships" xmlns:p="http://schemas.openxmlformats.org/presentationml/2006/main">
   <p:cSld name="Master">
     <p:bg>
       <p:bgRef idx="1001">
-        <a:schemeClr xmlns:a="http://schemas.openxmlformats.org/drawingml/2006/main" val="bg1"/>
+        <a:schemeClr val="bg1"/>
       </p:bgRef>
     </p:bg>
     <p:spTree>
@@ -2301,22 +2247,27 @@
         <p:nvPr/>
       </p:nvGrpSpPr>
       <p:grpSpPr>
-        <a:xfrm xmlns:a="http://schemas.openxmlformats.org/drawingml/2006/main"/>
+        <a:xfrm>
+          <a:off x="0" y="0"/>
+          <a:ext cx="0" cy="0"/>
+          <a:chOff x="0" y="0"/>
+          <a:chExt cx="0" cy="0"/>
+        </a:xfrm>
       </p:grpSpPr>
     </p:spTree>
   </p:cSld>
   <p:clrMap bg1="lt1" tx1="dk1" bg2="lt2" tx2="dk2" accent1="accent1" accent2="accent2" accent3="accent3" accent4="accent4" accent5="accent5" accent6="accent6" hlink="hlink" folHlink="folHlink"/>
   <p:sldLayoutIdLst>
-    <p:sldLayoutId xmlns:r="http://schemas.openxmlformats.org/officeDocument/2006/relationships" id="2147483649" r:id="R4d082447bf3b41ea"/>
-    <p:sldLayoutId xmlns:r="http://schemas.openxmlformats.org/officeDocument/2006/relationships" id="2147483650" r:id="R6af3882444c14d73"/>
-    <p:sldLayoutId xmlns:r="http://schemas.openxmlformats.org/officeDocument/2006/relationships" id="2147483651" r:id="R460c447e46964a22"/>
-    <p:sldLayoutId xmlns:r="http://schemas.openxmlformats.org/officeDocument/2006/relationships" id="2147483652" r:id="Rc306fd0015194243"/>
-    <p:sldLayoutId xmlns:r="http://schemas.openxmlformats.org/officeDocument/2006/relationships" id="2147483653" r:id="R9122142cf8e14da0"/>
-    <p:sldLayoutId xmlns:r="http://schemas.openxmlformats.org/officeDocument/2006/relationships" id="2147483654" r:id="Rd85266f1dd6f4289"/>
+    <p:sldLayoutId id="2147483649" r:id="rId1"/>
+    <p:sldLayoutId id="2147483650" r:id="rId2"/>
+    <p:sldLayoutId id="2147483651" r:id="rId3"/>
+    <p:sldLayoutId id="2147483652" r:id="rId4"/>
+    <p:sldLayoutId id="2147483653" r:id="rId5"/>
+    <p:sldLayoutId id="2147483654" r:id="rId6"/>
   </p:sldLayoutIdLst>
   <p:txStyles>
     <p:titleStyle>
-      <a:lvl1pPr xmlns:a="http://schemas.openxmlformats.org/drawingml/2006/main" algn="l">
+      <a:lvl1pPr algn="l">
         <a:lnSpc>
           <a:spcPct val="90000"/>
         </a:lnSpc>
@@ -2335,7 +2286,7 @@
       </a:lvl1pPr>
     </p:titleStyle>
     <p:bodyStyle>
-      <a:lvl1pPr xmlns:a="http://schemas.openxmlformats.org/drawingml/2006/main" marL="228600" indent="-228600" algn="l">
+      <a:lvl1pPr marL="228600" indent="-228600" algn="l">
         <a:lnSpc>
           <a:spcPct val="90000"/>
         </a:lnSpc>
@@ -2352,7 +2303,7 @@
           <a:cs typeface="+mn-lt"/>
         </a:defRPr>
       </a:lvl1pPr>
-      <a:lvl2pPr xmlns:a="http://schemas.openxmlformats.org/drawingml/2006/main" marL="685800" indent="-228600" algn="l">
+      <a:lvl2pPr marL="685800" indent="-228600" algn="l">
         <a:lnSpc>
           <a:spcPct val="90000"/>
         </a:lnSpc>
@@ -2369,7 +2320,7 @@
           <a:cs typeface="+mn-lt"/>
         </a:defRPr>
       </a:lvl2pPr>
-      <a:lvl3pPr xmlns:a="http://schemas.openxmlformats.org/drawingml/2006/main" marL="1143000" indent="-228600" algn="l">
+      <a:lvl3pPr marL="1143000" indent="-228600" algn="l">
         <a:lnSpc>
           <a:spcPct val="90000"/>
         </a:lnSpc>
@@ -2386,7 +2337,7 @@
           <a:cs typeface="+mn-lt"/>
         </a:defRPr>
       </a:lvl3pPr>
-      <a:lvl4pPr xmlns:a="http://schemas.openxmlformats.org/drawingml/2006/main" marL="1600200" indent="-228600" algn="l">
+      <a:lvl4pPr marL="1600200" indent="-228600" algn="l">
         <a:lnSpc>
           <a:spcPct val="90000"/>
         </a:lnSpc>
@@ -2403,7 +2354,7 @@
           <a:cs typeface="+mn-lt"/>
         </a:defRPr>
       </a:lvl4pPr>
-      <a:lvl5pPr xmlns:a="http://schemas.openxmlformats.org/drawingml/2006/main" marL="2057400" indent="-228600" algn="l">
+      <a:lvl5pPr marL="2057400" indent="-228600" algn="l">
         <a:lnSpc>
           <a:spcPct val="90000"/>
         </a:lnSpc>
@@ -2420,7 +2371,7 @@
           <a:cs typeface="+mn-lt"/>
         </a:defRPr>
       </a:lvl5pPr>
-      <a:lvl6pPr xmlns:a="http://schemas.openxmlformats.org/drawingml/2006/main" marL="2514600" indent="-228600" algn="l">
+      <a:lvl6pPr marL="2514600" indent="-228600" algn="l">
         <a:lnSpc>
           <a:spcPct val="90000"/>
         </a:lnSpc>
@@ -2437,7 +2388,7 @@
           <a:cs typeface="+mn-lt"/>
         </a:defRPr>
       </a:lvl6pPr>
-      <a:lvl7pPr xmlns:a="http://schemas.openxmlformats.org/drawingml/2006/main" marL="2971800" indent="-228600" algn="l">
+      <a:lvl7pPr marL="2971800" indent="-228600" algn="l">
         <a:lnSpc>
           <a:spcPct val="90000"/>
         </a:lnSpc>
@@ -2454,7 +2405,7 @@
           <a:cs typeface="+mn-lt"/>
         </a:defRPr>
       </a:lvl7pPr>
-      <a:lvl8pPr xmlns:a="http://schemas.openxmlformats.org/drawingml/2006/main" marL="3429000" indent="-228600" algn="l">
+      <a:lvl8pPr marL="3429000" indent="-228600" algn="l">
         <a:lnSpc>
           <a:spcPct val="90000"/>
         </a:lnSpc>
@@ -2471,7 +2422,7 @@
           <a:cs typeface="+mn-lt"/>
         </a:defRPr>
       </a:lvl8pPr>
-      <a:lvl9pPr xmlns:a="http://schemas.openxmlformats.org/drawingml/2006/main" marL="3886200" indent="-228600" algn="l">
+      <a:lvl9pPr marL="3886200" indent="-228600" algn="l">
         <a:lnSpc>
           <a:spcPct val="90000"/>
         </a:lnSpc>
@@ -2490,7 +2441,7 @@
       </a:lvl9pPr>
     </p:bodyStyle>
     <p:otherStyle>
-      <a:lvl1pPr xmlns:a="http://schemas.openxmlformats.org/drawingml/2006/main" marL="0" algn="l">
+      <a:lvl1pPr marL="0" algn="l">
         <a:buNone/>
         <a:defRPr sz="1800">
           <a:solidFill>
@@ -2501,7 +2452,7 @@
           <a:cs typeface="+mn-lt"/>
         </a:defRPr>
       </a:lvl1pPr>
-      <a:lvl2pPr xmlns:a="http://schemas.openxmlformats.org/drawingml/2006/main" marL="457200" algn="l">
+      <a:lvl2pPr marL="457200" algn="l">
         <a:buNone/>
         <a:defRPr sz="1800">
           <a:solidFill>
@@ -2512,7 +2463,7 @@
           <a:cs typeface="+mn-lt"/>
         </a:defRPr>
       </a:lvl2pPr>
-      <a:lvl3pPr xmlns:a="http://schemas.openxmlformats.org/drawingml/2006/main" marL="914400" algn="l">
+      <a:lvl3pPr marL="914400" algn="l">
         <a:buNone/>
         <a:defRPr sz="1800">
           <a:solidFill>
@@ -2523,7 +2474,7 @@
           <a:cs typeface="+mn-lt"/>
         </a:defRPr>
       </a:lvl3pPr>
-      <a:lvl4pPr xmlns:a="http://schemas.openxmlformats.org/drawingml/2006/main" marL="1371600" algn="l">
+      <a:lvl4pPr marL="1371600" algn="l">
         <a:buNone/>
         <a:defRPr sz="1800">
           <a:solidFill>
@@ -2534,7 +2485,7 @@
           <a:cs typeface="+mn-lt"/>
         </a:defRPr>
       </a:lvl4pPr>
-      <a:lvl5pPr xmlns:a="http://schemas.openxmlformats.org/drawingml/2006/main" marL="1828800" algn="l">
+      <a:lvl5pPr marL="1828800" algn="l">
         <a:buNone/>
         <a:defRPr sz="1800">
           <a:solidFill>
@@ -2545,7 +2496,7 @@
           <a:cs typeface="+mn-lt"/>
         </a:defRPr>
       </a:lvl5pPr>
-      <a:lvl6pPr xmlns:a="http://schemas.openxmlformats.org/drawingml/2006/main" marL="2286000" algn="l">
+      <a:lvl6pPr marL="2286000" algn="l">
         <a:buNone/>
         <a:defRPr sz="1800">
           <a:solidFill>
@@ -2556,7 +2507,7 @@
           <a:cs typeface="+mn-lt"/>
         </a:defRPr>
       </a:lvl6pPr>
-      <a:lvl7pPr xmlns:a="http://schemas.openxmlformats.org/drawingml/2006/main" marL="2743200" algn="l">
+      <a:lvl7pPr marL="2743200" algn="l">
         <a:buNone/>
         <a:defRPr sz="1800">
           <a:solidFill>
@@ -2567,7 +2518,7 @@
           <a:cs typeface="+mn-lt"/>
         </a:defRPr>
       </a:lvl7pPr>
-      <a:lvl8pPr xmlns:a="http://schemas.openxmlformats.org/drawingml/2006/main" marL="3200400" algn="l">
+      <a:lvl8pPr marL="3200400" algn="l">
         <a:buNone/>
         <a:defRPr sz="1800">
           <a:solidFill>
@@ -2578,7 +2529,7 @@
           <a:cs typeface="+mn-lt"/>
         </a:defRPr>
       </a:lvl8pPr>
-      <a:lvl9pPr xmlns:a="http://schemas.openxmlformats.org/drawingml/2006/main" marL="3657600" algn="l">
+      <a:lvl9pPr marL="3657600" algn="l">
         <a:buNone/>
         <a:defRPr sz="1800">
           <a:solidFill>
@@ -2594,259 +2545,15 @@
 </p:sldMaster>
 </file>
 
-<file path=ppt/slideMasters/theme/theme2.xml><?xml version="1.0" encoding="utf-8"?>
-<a:theme xmlns:a="http://schemas.openxmlformats.org/drawingml/2006/main" name="ChatGPT">
-  <a:themeElements>
-    <a:clrScheme name="ChatGPT">
-      <a:dk1>
-        <a:srgbClr val="000000"/>
-      </a:dk1>
-      <a:lt1>
-        <a:srgbClr val="FFFFFF"/>
-      </a:lt1>
-      <a:dk2>
-        <a:srgbClr val="0E2841"/>
-      </a:dk2>
-      <a:lt2>
-        <a:srgbClr val="E8E8E8"/>
-      </a:lt2>
-      <a:accent1>
-        <a:srgbClr val="156082"/>
-      </a:accent1>
-      <a:accent2>
-        <a:srgbClr val="E97132"/>
-      </a:accent2>
-      <a:accent3>
-        <a:srgbClr val="196B24"/>
-      </a:accent3>
-      <a:accent4>
-        <a:srgbClr val="0F9ED5"/>
-      </a:accent4>
-      <a:accent5>
-        <a:srgbClr val="A02B93"/>
-      </a:accent5>
-      <a:accent6>
-        <a:srgbClr val="4EA72E"/>
-      </a:accent6>
-      <a:hlink>
-        <a:srgbClr val="467886"/>
-      </a:hlink>
-      <a:folHlink>
-        <a:srgbClr val="96607D"/>
-      </a:folHlink>
-    </a:clrScheme>
-    <a:fontScheme name="">
-      <a:majorFont>
-        <a:latin typeface="Aptos"/>
-        <a:ea typeface=""/>
-        <a:cs typeface=""/>
-      </a:majorFont>
-      <a:minorFont>
-        <a:latin typeface="Aptos"/>
-        <a:ea typeface=""/>
-        <a:cs typeface=""/>
-      </a:minorFont>
-    </a:fontScheme>
-    <a:fmtScheme name="ChatGPT">
-      <a:fillStyleLst>
-        <a:solidFill>
-          <a:schemeClr val="phClr"/>
-        </a:solidFill>
-        <a:gradFill>
-          <a:gsLst>
-            <a:gs pos="0">
-              <a:schemeClr val="phClr">
-                <a:tint val="67000"/>
-                <a:lumMod val="110000"/>
-                <a:satMod val="105000"/>
-              </a:schemeClr>
-            </a:gs>
-            <a:gs pos="50000">
-              <a:schemeClr val="phClr">
-                <a:tint val="73000"/>
-                <a:lumMod val="105000"/>
-                <a:satMod val="103000"/>
-              </a:schemeClr>
-            </a:gs>
-            <a:gs pos="100000">
-              <a:schemeClr val="phClr">
-                <a:tint val="81000"/>
-                <a:lumMod val="105000"/>
-                <a:satMod val="109000"/>
-              </a:schemeClr>
-            </a:gs>
-          </a:gsLst>
-          <a:lin ang="5400000" scaled="0"/>
-        </a:gradFill>
-        <a:gradFill>
-          <a:gsLst>
-            <a:gs pos="0">
-              <a:schemeClr val="phClr">
-                <a:tint val="94000"/>
-                <a:lumMod val="102000"/>
-                <a:satMod val="103000"/>
-              </a:schemeClr>
-            </a:gs>
-            <a:gs pos="50000">
-              <a:schemeClr val="phClr">
-                <a:shade val="100000"/>
-                <a:lumMod val="100000"/>
-                <a:satMod val="110000"/>
-              </a:schemeClr>
-            </a:gs>
-            <a:gs pos="100000">
-              <a:schemeClr val="phClr">
-                <a:shade val="78000"/>
-                <a:lumMod val="99000"/>
-                <a:satMod val="120000"/>
-              </a:schemeClr>
-            </a:gs>
-          </a:gsLst>
-          <a:lin ang="5400000" scaled="0"/>
-        </a:gradFill>
-      </a:fillStyleLst>
-      <a:lnStyleLst>
-        <a:ln w="12700">
-          <a:solidFill>
-            <a:schemeClr val="phClr"/>
-          </a:solidFill>
-          <a:prstDash val="solid"/>
-        </a:ln>
-        <a:ln w="19050">
-          <a:solidFill>
-            <a:schemeClr val="phClr"/>
-          </a:solidFill>
-          <a:prstDash val="solid"/>
-        </a:ln>
-        <a:ln w="25400">
-          <a:solidFill>
-            <a:schemeClr val="phClr"/>
-          </a:solidFill>
-          <a:prstDash val="solid"/>
-        </a:ln>
-      </a:lnStyleLst>
-      <a:effectStyleLst>
-        <a:effectStyle>
-          <a:effectLst/>
-        </a:effectStyle>
-        <a:effectStyle>
-          <a:effectLst/>
-        </a:effectStyle>
-        <a:effectStyle>
-          <a:effectLst>
-            <a:outerShdw blurRad="57150" dist="19050" dir="5400000">
-              <a:srgbClr val="000000">
-                <a:alpha val="16000"/>
-              </a:srgbClr>
-            </a:outerShdw>
-          </a:effectLst>
-        </a:effectStyle>
-        <a:effectStyle>
-          <a:effectLst>
-            <a:outerShdw blurRad="19050" dist="9525" dir="5400000">
-              <a:srgbClr val="000000">
-                <a:alpha val="6000"/>
-              </a:srgbClr>
-            </a:outerShdw>
-          </a:effectLst>
-        </a:effectStyle>
-        <a:effectStyle>
-          <a:effectLst>
-            <a:outerShdw blurRad="28575" dist="9525" dir="5400000">
-              <a:srgbClr val="000000">
-                <a:alpha val="8000"/>
-              </a:srgbClr>
-            </a:outerShdw>
-          </a:effectLst>
-        </a:effectStyle>
-        <a:effectStyle>
-          <a:effectLst>
-            <a:outerShdw blurRad="57150" dist="19050" dir="5400000">
-              <a:srgbClr val="000000">
-                <a:alpha val="10000"/>
-              </a:srgbClr>
-            </a:outerShdw>
-          </a:effectLst>
-        </a:effectStyle>
-        <a:effectStyle>
-          <a:effectLst>
-            <a:outerShdw blurRad="114300" dist="38100" dir="5400000">
-              <a:srgbClr val="000000">
-                <a:alpha val="12000"/>
-              </a:srgbClr>
-            </a:outerShdw>
-          </a:effectLst>
-        </a:effectStyle>
-        <a:effectStyle>
-          <a:effectLst>
-            <a:outerShdw blurRad="171450" dist="57150" dir="5400000">
-              <a:srgbClr val="000000">
-                <a:alpha val="16000"/>
-              </a:srgbClr>
-            </a:outerShdw>
-          </a:effectLst>
-        </a:effectStyle>
-        <a:effectStyle>
-          <a:effectLst>
-            <a:outerShdw blurRad="266700" dist="95250" dir="5400000">
-              <a:srgbClr val="000000">
-                <a:alpha val="24000"/>
-              </a:srgbClr>
-            </a:outerShdw>
-          </a:effectLst>
-        </a:effectStyle>
-      </a:effectStyleLst>
-      <a:bgFillStyleLst>
-        <a:solidFill>
-          <a:schemeClr val="phClr"/>
-        </a:solidFill>
-        <a:solidFill>
-          <a:schemeClr val="phClr">
-            <a:tint val="95000"/>
-            <a:satMod val="170000"/>
-          </a:schemeClr>
-        </a:solidFill>
-        <a:gradFill>
-          <a:gsLst>
-            <a:gs pos="0">
-              <a:schemeClr val="phClr">
-                <a:tint val="93000"/>
-                <a:shade val="98000"/>
-                <a:lumMod val="102000"/>
-                <a:satMod val="150000"/>
-              </a:schemeClr>
-            </a:gs>
-            <a:gs pos="50000">
-              <a:schemeClr val="phClr">
-                <a:tint val="98000"/>
-                <a:shade val="90000"/>
-                <a:lumMod val="103000"/>
-                <a:satMod val="130000"/>
-              </a:schemeClr>
-            </a:gs>
-            <a:gs pos="100000">
-              <a:schemeClr val="phClr">
-                <a:shade val="63000"/>
-                <a:satMod val="120000"/>
-              </a:schemeClr>
-            </a:gs>
-          </a:gsLst>
-          <a:lin ang="5400000" scaled="0"/>
-        </a:gradFill>
-      </a:bgFillStyleLst>
-    </a:fmtScheme>
-  </a:themeElements>
-</a:theme>
-</file>
-
 <file path=ppt/slides/slide1.xml><?xml version="1.0" encoding="utf-8"?>
-<p:sld xmlns:p="http://schemas.openxmlformats.org/presentationml/2006/main">
+<p:sld xmlns:a="http://schemas.openxmlformats.org/drawingml/2006/main" xmlns:r="http://schemas.openxmlformats.org/officeDocument/2006/relationships" xmlns:p="http://schemas.openxmlformats.org/presentationml/2006/main">
   <p:cSld>
     <p:bg>
       <p:bgPr>
-        <a:solidFill xmlns:a="http://schemas.openxmlformats.org/drawingml/2006/main">
-          <a:srgbClr val="12375F"/>
+        <a:solidFill>
+          <a:srgbClr val="FFFFFF"/>
         </a:solidFill>
+        <a:effectLst/>
       </p:bgPr>
     </p:bg>
     <p:spTree>
@@ -2856,44 +2563,49 @@
         <p:nvPr/>
       </p:nvGrpSpPr>
       <p:grpSpPr>
-        <a:xfrm xmlns:a="http://schemas.openxmlformats.org/drawingml/2006/main"/>
+        <a:xfrm>
+          <a:off x="0" y="0"/>
+          <a:ext cx="0" cy="0"/>
+          <a:chOff x="0" y="0"/>
+          <a:chExt cx="0" cy="0"/>
+        </a:xfrm>
       </p:grpSpPr>
       <p:sp>
         <p:nvSpPr>
-          <p:cNvPr id="4" name="">
-            <a:extLst xmlns:a="http://schemas.openxmlformats.org/drawingml/2006/main">
+          <p:cNvPr id="5" name="Rectangle 4">
+            <a:extLst>
               <a:ext uri="{FF2B5EF4-FFF2-40B4-BE49-F238E27FC236}">
-                <a16:creationId xmlns:a16="http://schemas.microsoft.com/office/drawing/2014/main" id="{B5F1CFBC-D644-45CC-A1DF-AAD95B83CF7A}"/>
+                <a16:creationId xmlns:a16="http://schemas.microsoft.com/office/drawing/2014/main" id="{0A159079-5779-4B80-83D7-9E473EDEEA76}"/>
               </a:ext>
             </a:extLst>
           </p:cNvPr>
           <p:cNvSpPr>
-            <a:spLocks xmlns:a="http://schemas.openxmlformats.org/drawingml/2006/main" noGrp="1"/>
+            <a:spLocks noGrp="1"/>
           </p:cNvSpPr>
           <p:nvPr/>
         </p:nvSpPr>
         <p:spPr>
-          <a:xfrm xmlns:a="http://schemas.openxmlformats.org/drawingml/2006/main">
-            <a:off x="723900" y="1123950"/>
-            <a:ext cx="8858250" cy="2857500"/>
+          <a:xfrm>
+            <a:off x="723900" y="762000"/>
+            <a:ext cx="8858250" cy="1857375"/>
           </a:xfrm>
-          <a:prstGeom xmlns:a="http://schemas.openxmlformats.org/drawingml/2006/main" prst="rect">
+          <a:prstGeom prst="rect">
             <a:avLst/>
           </a:prstGeom>
-          <a:noFill xmlns:a="http://schemas.openxmlformats.org/drawingml/2006/main"/>
-          <a:ln xmlns:a="http://schemas.openxmlformats.org/drawingml/2006/main" w="0">
+          <a:noFill/>
+          <a:ln w="0">
             <a:noFill/>
           </a:ln>
         </p:spPr>
         <p:txBody>
-          <a:bodyPr xmlns:a="http://schemas.openxmlformats.org/drawingml/2006/main" lIns="0" tIns="0" rIns="0" bIns="0">
+          <a:bodyPr lIns="0" tIns="0" rIns="0" bIns="0">
             <a:noAutofit/>
           </a:bodyPr>
-          <a:lstStyle xmlns:a="http://schemas.openxmlformats.org/drawingml/2006/main">
+          <a:lstStyle>
             <a:defPPr>
-              <a:defRPr sz="5025" b="1">
-                <a:solidFill>
-                  <a:srgbClr val="FFFFFF"/>
+              <a:defRPr sz="4500" b="1">
+                <a:solidFill>
+                  <a:srgbClr val="12375F"/>
                 </a:solidFill>
                 <a:latin typeface="DejaVu Sans"/>
                 <a:ea typeface="DejaVu Sans"/>
@@ -2901,11 +2613,11 @@
               </a:defRPr>
             </a:defPPr>
           </a:lstStyle>
-          <a:p xmlns:a="http://schemas.openxmlformats.org/drawingml/2006/main">
+          <a:p>
             <a:pPr>
-              <a:defRPr sz="5025" b="1">
-                <a:solidFill>
-                  <a:srgbClr val="FFFFFF"/>
+              <a:defRPr sz="4500" b="1">
+                <a:solidFill>
+                  <a:srgbClr val="12375F"/>
                 </a:solidFill>
                 <a:latin typeface="DejaVu Sans"/>
                 <a:ea typeface="DejaVu Sans"/>
@@ -2913,22 +2625,22 @@
               </a:defRPr>
             </a:pPr>
             <a:r>
-              <a:rPr sz="5025" b="1">
-                <a:solidFill>
-                  <a:srgbClr val="FFFFFF"/>
+              <a:rPr sz="4500" b="1">
+                <a:solidFill>
+                  <a:srgbClr val="12375F"/>
                 </a:solidFill>
                 <a:latin typeface="DejaVu Sans"/>
                 <a:ea typeface="DejaVu Sans"/>
                 <a:cs typeface="DejaVu Sans"/>
               </a:rPr>
-              <a:t>Is the right information</a:t>
+              <a:t>Connected Care:</a:t>
             </a:r>
           </a:p>
-          <a:p xmlns:a="http://schemas.openxmlformats.org/drawingml/2006/main">
+          <a:p>
             <a:pPr>
-              <a:defRPr sz="5025" b="1">
-                <a:solidFill>
-                  <a:srgbClr val="FFFFFF"/>
+              <a:defRPr sz="4500" b="1">
+                <a:solidFill>
+                  <a:srgbClr val="12375F"/>
                 </a:solidFill>
                 <a:latin typeface="DejaVu Sans"/>
                 <a:ea typeface="DejaVu Sans"/>
@@ -2936,78 +2648,55 @@
               </a:defRPr>
             </a:pPr>
             <a:r>
-              <a:rPr sz="5025" b="1">
-                <a:solidFill>
-                  <a:srgbClr val="FFFFFF"/>
+              <a:rPr sz="4500" b="1">
+                <a:solidFill>
+                  <a:srgbClr val="12375F"/>
                 </a:solidFill>
                 <a:latin typeface="DejaVu Sans"/>
                 <a:ea typeface="DejaVu Sans"/>
                 <a:cs typeface="DejaVu Sans"/>
               </a:rPr>
-              <a:t>available before</a:t>
-            </a:r>
-          </a:p>
-          <a:p xmlns:a="http://schemas.openxmlformats.org/drawingml/2006/main">
-            <a:pPr>
-              <a:defRPr sz="5025" b="1">
-                <a:solidFill>
-                  <a:srgbClr val="FFFFFF"/>
-                </a:solidFill>
-                <a:latin typeface="DejaVu Sans"/>
-                <a:ea typeface="DejaVu Sans"/>
-                <a:cs typeface="DejaVu Sans"/>
-              </a:defRPr>
-            </a:pPr>
-            <a:r>
-              <a:rPr sz="5025" b="1">
-                <a:solidFill>
-                  <a:srgbClr val="FFFFFF"/>
-                </a:solidFill>
-                <a:latin typeface="DejaVu Sans"/>
-                <a:ea typeface="DejaVu Sans"/>
-                <a:cs typeface="DejaVu Sans"/>
-              </a:rPr>
-              <a:t>a visit?</a:t>
+              <a:t>Healthcare Data Platform</a:t>
             </a:r>
           </a:p>
         </p:txBody>
       </p:sp>
       <p:sp>
         <p:nvSpPr>
-          <p:cNvPr id="2" name="">
-            <a:extLst xmlns:a="http://schemas.openxmlformats.org/drawingml/2006/main">
+          <p:cNvPr id="2" name="Rectangle 1">
+            <a:extLst>
               <a:ext uri="{FF2B5EF4-FFF2-40B4-BE49-F238E27FC236}">
-                <a16:creationId xmlns:a16="http://schemas.microsoft.com/office/drawing/2014/main" id="{BAACF7DA-94ED-43A1-99BD-FDF7E3DA9008}"/>
+                <a16:creationId xmlns:a16="http://schemas.microsoft.com/office/drawing/2014/main" id="{55C58DDF-3AD8-4A40-BD8A-A85041555F4B}"/>
               </a:ext>
             </a:extLst>
           </p:cNvPr>
           <p:cNvSpPr>
-            <a:spLocks xmlns:a="http://schemas.openxmlformats.org/drawingml/2006/main" noGrp="1"/>
+            <a:spLocks noGrp="1"/>
           </p:cNvSpPr>
           <p:nvPr/>
         </p:nvSpPr>
         <p:spPr>
-          <a:xfrm xmlns:a="http://schemas.openxmlformats.org/drawingml/2006/main">
-            <a:off x="762000" y="5000625"/>
-            <a:ext cx="8705850" cy="2381250"/>
+          <a:xfrm>
+            <a:off x="762000" y="2809875"/>
+            <a:ext cx="8763000" cy="1143000"/>
           </a:xfrm>
-          <a:prstGeom xmlns:a="http://schemas.openxmlformats.org/drawingml/2006/main" prst="rect">
+          <a:prstGeom prst="rect">
             <a:avLst/>
           </a:prstGeom>
-          <a:noFill xmlns:a="http://schemas.openxmlformats.org/drawingml/2006/main"/>
-          <a:ln xmlns:a="http://schemas.openxmlformats.org/drawingml/2006/main" w="0">
+          <a:noFill/>
+          <a:ln w="0">
             <a:noFill/>
           </a:ln>
         </p:spPr>
         <p:txBody>
-          <a:bodyPr xmlns:a="http://schemas.openxmlformats.org/drawingml/2006/main" lIns="0" tIns="0" rIns="0" bIns="0">
+          <a:bodyPr lIns="0" tIns="0" rIns="0" bIns="0">
             <a:noAutofit/>
           </a:bodyPr>
-          <a:lstStyle xmlns:a="http://schemas.openxmlformats.org/drawingml/2006/main">
+          <a:lstStyle>
             <a:defPPr>
-              <a:defRPr sz="2925" b="0">
-                <a:solidFill>
-                  <a:srgbClr val="D8E7F5"/>
+              <a:defRPr sz="2925" b="1">
+                <a:solidFill>
+                  <a:srgbClr val="16867F"/>
                 </a:solidFill>
                 <a:latin typeface="DejaVu Sans"/>
                 <a:ea typeface="DejaVu Sans"/>
@@ -3015,11 +2704,11 @@
               </a:defRPr>
             </a:defPPr>
           </a:lstStyle>
-          <a:p xmlns:a="http://schemas.openxmlformats.org/drawingml/2006/main">
+          <a:p>
             <a:pPr>
-              <a:defRPr sz="2925" b="0">
-                <a:solidFill>
-                  <a:srgbClr val="D8E7F5"/>
+              <a:defRPr sz="2925" b="1">
+                <a:solidFill>
+                  <a:srgbClr val="16867F"/>
                 </a:solidFill>
                 <a:latin typeface="DejaVu Sans"/>
                 <a:ea typeface="DejaVu Sans"/>
@@ -3027,22 +2716,22 @@
               </a:defRPr>
             </a:pPr>
             <a:r>
-              <a:rPr sz="2925" b="0">
-                <a:solidFill>
-                  <a:srgbClr val="D8E7F5"/>
+              <a:rPr sz="2925" b="1">
+                <a:solidFill>
+                  <a:srgbClr val="16867F"/>
                 </a:solidFill>
                 <a:latin typeface="DejaVu Sans"/>
                 <a:ea typeface="DejaVu Sans"/>
                 <a:cs typeface="DejaVu Sans"/>
               </a:rPr>
-              <a:t>Lab results and appointments can sit in</a:t>
+              <a:t>Is the right patient information available</a:t>
             </a:r>
           </a:p>
-          <a:p xmlns:a="http://schemas.openxmlformats.org/drawingml/2006/main">
+          <a:p>
             <a:pPr>
-              <a:defRPr sz="2925" b="0">
-                <a:solidFill>
-                  <a:srgbClr val="D8E7F5"/>
+              <a:defRPr sz="2925" b="1">
+                <a:solidFill>
+                  <a:srgbClr val="16867F"/>
                 </a:solidFill>
                 <a:latin typeface="DejaVu Sans"/>
                 <a:ea typeface="DejaVu Sans"/>
@@ -3050,78 +2739,55 @@
               </a:defRPr>
             </a:pPr>
             <a:r>
-              <a:rPr sz="2925" b="0">
-                <a:solidFill>
-                  <a:srgbClr val="D8E7F5"/>
+              <a:rPr sz="2925" b="1">
+                <a:solidFill>
+                  <a:srgbClr val="16867F"/>
                 </a:solidFill>
                 <a:latin typeface="DejaVu Sans"/>
                 <a:ea typeface="DejaVu Sans"/>
                 <a:cs typeface="DejaVu Sans"/>
               </a:rPr>
-              <a:t>separate records. I built a workflow to</a:t>
-            </a:r>
-          </a:p>
-          <a:p xmlns:a="http://schemas.openxmlformats.org/drawingml/2006/main">
-            <a:pPr>
-              <a:defRPr sz="2925" b="0">
-                <a:solidFill>
-                  <a:srgbClr val="D8E7F5"/>
-                </a:solidFill>
-                <a:latin typeface="DejaVu Sans"/>
-                <a:ea typeface="DejaVu Sans"/>
-                <a:cs typeface="DejaVu Sans"/>
-              </a:defRPr>
-            </a:pPr>
-            <a:r>
-              <a:rPr sz="2925" b="0">
-                <a:solidFill>
-                  <a:srgbClr val="D8E7F5"/>
-                </a:solidFill>
-                <a:latin typeface="DejaVu Sans"/>
-                <a:ea typeface="DejaVu Sans"/>
-                <a:cs typeface="DejaVu Sans"/>
-              </a:rPr>
-              <a:t>connect them and check what is available.</a:t>
+              <a:t>before a healthcare appointment?</a:t>
             </a:r>
           </a:p>
         </p:txBody>
       </p:sp>
       <p:sp>
         <p:nvSpPr>
-          <p:cNvPr id="3" name="">
-            <a:extLst xmlns:a="http://schemas.openxmlformats.org/drawingml/2006/main">
+          <p:cNvPr id="3" name="Rectangle 2">
+            <a:extLst>
               <a:ext uri="{FF2B5EF4-FFF2-40B4-BE49-F238E27FC236}">
-                <a16:creationId xmlns:a16="http://schemas.microsoft.com/office/drawing/2014/main" id="{7FB91B3A-B2D2-4F55-94C6-90EDBF35C909}"/>
+                <a16:creationId xmlns:a16="http://schemas.microsoft.com/office/drawing/2014/main" id="{B2DAF1A0-503B-472D-81D7-B22A2CBD4C2D}"/>
               </a:ext>
             </a:extLst>
           </p:cNvPr>
           <p:cNvSpPr>
-            <a:spLocks xmlns:a="http://schemas.openxmlformats.org/drawingml/2006/main" noGrp="1"/>
+            <a:spLocks noGrp="1"/>
           </p:cNvSpPr>
           <p:nvPr/>
         </p:nvSpPr>
         <p:spPr>
-          <a:xfrm xmlns:a="http://schemas.openxmlformats.org/drawingml/2006/main">
-            <a:off x="762000" y="8220075"/>
-            <a:ext cx="8705850" cy="1143000"/>
+          <a:xfrm>
+            <a:off x="762000" y="4333875"/>
+            <a:ext cx="8763000" cy="2857500"/>
           </a:xfrm>
-          <a:prstGeom xmlns:a="http://schemas.openxmlformats.org/drawingml/2006/main" prst="rect">
+          <a:prstGeom prst="rect">
             <a:avLst/>
           </a:prstGeom>
-          <a:noFill xmlns:a="http://schemas.openxmlformats.org/drawingml/2006/main"/>
-          <a:ln xmlns:a="http://schemas.openxmlformats.org/drawingml/2006/main" w="0">
+          <a:noFill/>
+          <a:ln w="0">
             <a:noFill/>
           </a:ln>
         </p:spPr>
         <p:txBody>
-          <a:bodyPr xmlns:a="http://schemas.openxmlformats.org/drawingml/2006/main" lIns="0" tIns="0" rIns="0" bIns="0">
+          <a:bodyPr lIns="0" tIns="0" rIns="0" bIns="0">
             <a:noAutofit/>
           </a:bodyPr>
-          <a:lstStyle xmlns:a="http://schemas.openxmlformats.org/drawingml/2006/main">
+          <a:lstStyle>
             <a:defPPr>
-              <a:defRPr sz="2250" b="0">
-                <a:solidFill>
-                  <a:srgbClr val="78D8CF"/>
+              <a:defRPr sz="2700" b="0">
+                <a:solidFill>
+                  <a:srgbClr val="30455F"/>
                 </a:solidFill>
                 <a:latin typeface="DejaVu Sans"/>
                 <a:ea typeface="DejaVu Sans"/>
@@ -3129,11 +2795,11 @@
               </a:defRPr>
             </a:defPPr>
           </a:lstStyle>
-          <a:p xmlns:a="http://schemas.openxmlformats.org/drawingml/2006/main">
+          <a:p>
             <a:pPr>
-              <a:defRPr sz="2250" b="0">
-                <a:solidFill>
-                  <a:srgbClr val="78D8CF"/>
+              <a:defRPr sz="2700" b="0">
+                <a:solidFill>
+                  <a:srgbClr val="30455F"/>
                 </a:solidFill>
                 <a:latin typeface="DejaVu Sans"/>
                 <a:ea typeface="DejaVu Sans"/>
@@ -3141,22 +2807,22 @@
               </a:defRPr>
             </a:pPr>
             <a:r>
-              <a:rPr sz="2250" b="0">
-                <a:solidFill>
-                  <a:srgbClr val="78D8CF"/>
+              <a:rPr sz="2700" b="0" dirty="0">
+                <a:solidFill>
+                  <a:srgbClr val="30455F"/>
                 </a:solidFill>
                 <a:latin typeface="DejaVu Sans"/>
                 <a:ea typeface="DejaVu Sans"/>
                 <a:cs typeface="DejaVu Sans"/>
               </a:rPr>
-              <a:t>933 native FHIR resources across 11 types</a:t>
+              <a:t>Patient records, lab results and appointment</a:t>
             </a:r>
           </a:p>
-          <a:p xmlns:a="http://schemas.openxmlformats.org/drawingml/2006/main">
+          <a:p>
             <a:pPr>
-              <a:defRPr sz="2250" b="0">
-                <a:solidFill>
-                  <a:srgbClr val="78D8CF"/>
+              <a:defRPr sz="2700" b="0">
+                <a:solidFill>
+                  <a:srgbClr val="30455F"/>
                 </a:solidFill>
                 <a:latin typeface="DejaVu Sans"/>
                 <a:ea typeface="DejaVu Sans"/>
@@ -3164,37 +2830,278 @@
               </a:defRPr>
             </a:pPr>
             <a:r>
-              <a:rPr sz="2250" b="0">
-                <a:solidFill>
-                  <a:srgbClr val="78D8CF"/>
+              <a:rPr sz="2700" b="0" dirty="0">
+                <a:solidFill>
+                  <a:srgbClr val="30455F"/>
                 </a:solidFill>
                 <a:latin typeface="DejaVu Sans"/>
                 <a:ea typeface="DejaVu Sans"/>
                 <a:cs typeface="DejaVu Sans"/>
               </a:rPr>
-              <a:t>Expanded dataset for downstream analytics</a:t>
+              <a:t>details can arrive in different formats.</a:t>
             </a:r>
+            <a:endParaRPr lang="en-US" sz="2700" b="0" dirty="0">
+              <a:solidFill>
+                <a:srgbClr val="30455F"/>
+              </a:solidFill>
+              <a:latin typeface="DejaVu Sans"/>
+              <a:ea typeface="DejaVu Sans"/>
+              <a:cs typeface="DejaVu Sans"/>
+            </a:endParaRPr>
+          </a:p>
+          <a:p>
+            <a:pPr>
+              <a:defRPr sz="2700" b="0">
+                <a:solidFill>
+                  <a:srgbClr val="30455F"/>
+                </a:solidFill>
+                <a:latin typeface="DejaVu Sans"/>
+                <a:ea typeface="DejaVu Sans"/>
+                <a:cs typeface="DejaVu Sans"/>
+              </a:defRPr>
+            </a:pPr>
+            <a:endParaRPr lang="en-US" sz="2700" dirty="0">
+              <a:solidFill>
+                <a:srgbClr val="30455F"/>
+              </a:solidFill>
+              <a:latin typeface="DejaVu Sans"/>
+              <a:ea typeface="DejaVu Sans"/>
+              <a:cs typeface="DejaVu Sans"/>
+            </a:endParaRPr>
+          </a:p>
+          <a:p>
+            <a:pPr>
+              <a:defRPr sz="2625" b="1">
+                <a:solidFill>
+                  <a:srgbClr val="1765BA"/>
+                </a:solidFill>
+                <a:latin typeface="DejaVu Sans"/>
+                <a:ea typeface="DejaVu Sans"/>
+                <a:cs typeface="DejaVu Sans"/>
+              </a:defRPr>
+            </a:pPr>
+            <a:r>
+              <a:rPr lang="en-US" sz="2800" b="1" dirty="0">
+                <a:solidFill>
+                  <a:srgbClr val="1765BA"/>
+                </a:solidFill>
+                <a:latin typeface="DejaVu Sans"/>
+                <a:ea typeface="DejaVu Sans"/>
+                <a:cs typeface="DejaVu Sans"/>
+              </a:rPr>
+              <a:t>HL7 v2 / FHIR R4 / </a:t>
+            </a:r>
+            <a:r>
+              <a:rPr lang="en-US" sz="2800" b="1" dirty="0" err="1">
+                <a:solidFill>
+                  <a:srgbClr val="1765BA"/>
+                </a:solidFill>
+                <a:latin typeface="DejaVu Sans"/>
+                <a:ea typeface="DejaVu Sans"/>
+                <a:cs typeface="DejaVu Sans"/>
+              </a:rPr>
+              <a:t>Firely</a:t>
+            </a:r>
+            <a:endParaRPr lang="en-US" sz="2800" b="1" dirty="0">
+              <a:solidFill>
+                <a:srgbClr val="1765BA"/>
+              </a:solidFill>
+              <a:latin typeface="DejaVu Sans"/>
+              <a:ea typeface="DejaVu Sans"/>
+              <a:cs typeface="DejaVu Sans"/>
+            </a:endParaRPr>
+          </a:p>
+          <a:p>
+            <a:pPr>
+              <a:defRPr sz="2625" b="1">
+                <a:solidFill>
+                  <a:srgbClr val="1765BA"/>
+                </a:solidFill>
+                <a:latin typeface="DejaVu Sans"/>
+                <a:ea typeface="DejaVu Sans"/>
+                <a:cs typeface="DejaVu Sans"/>
+              </a:defRPr>
+            </a:pPr>
+            <a:r>
+              <a:rPr lang="en-US" sz="2800" b="1" dirty="0">
+                <a:solidFill>
+                  <a:srgbClr val="1765BA"/>
+                </a:solidFill>
+                <a:latin typeface="DejaVu Sans"/>
+                <a:ea typeface="DejaVu Sans"/>
+                <a:cs typeface="DejaVu Sans"/>
+              </a:rPr>
+              <a:t>Python / AWS S3 / Snowflake</a:t>
+            </a:r>
+          </a:p>
+          <a:p>
+            <a:endParaRPr sz="2700" b="0" dirty="0">
+              <a:solidFill>
+                <a:srgbClr val="30455F"/>
+              </a:solidFill>
+              <a:latin typeface="DejaVu Sans"/>
+              <a:ea typeface="DejaVu Sans"/>
+              <a:cs typeface="DejaVu Sans"/>
+            </a:endParaRPr>
+          </a:p>
+          <a:p>
+            <a:pPr>
+              <a:defRPr sz="2700" b="0">
+                <a:solidFill>
+                  <a:srgbClr val="30455F"/>
+                </a:solidFill>
+                <a:latin typeface="DejaVu Sans"/>
+                <a:ea typeface="DejaVu Sans"/>
+                <a:cs typeface="DejaVu Sans"/>
+              </a:defRPr>
+            </a:pPr>
+            <a:r>
+              <a:rPr sz="2700" b="0" dirty="0">
+                <a:solidFill>
+                  <a:srgbClr val="30455F"/>
+                </a:solidFill>
+                <a:latin typeface="DejaVu Sans"/>
+                <a:ea typeface="DejaVu Sans"/>
+                <a:cs typeface="DejaVu Sans"/>
+              </a:rPr>
+              <a:t>I built a workflow to connect these records</a:t>
+            </a:r>
+          </a:p>
+          <a:p>
+            <a:pPr>
+              <a:defRPr sz="2700" b="0">
+                <a:solidFill>
+                  <a:srgbClr val="30455F"/>
+                </a:solidFill>
+                <a:latin typeface="DejaVu Sans"/>
+                <a:ea typeface="DejaVu Sans"/>
+                <a:cs typeface="DejaVu Sans"/>
+              </a:defRPr>
+            </a:pPr>
+            <a:r>
+              <a:rPr sz="2700" b="0" dirty="0">
+                <a:solidFill>
+                  <a:srgbClr val="30455F"/>
+                </a:solidFill>
+                <a:latin typeface="DejaVu Sans"/>
+                <a:ea typeface="DejaVu Sans"/>
+                <a:cs typeface="DejaVu Sans"/>
+              </a:rPr>
+              <a:t>and assess information availability</a:t>
+            </a:r>
+          </a:p>
+          <a:p>
+            <a:pPr>
+              <a:defRPr sz="2700" b="0">
+                <a:solidFill>
+                  <a:srgbClr val="30455F"/>
+                </a:solidFill>
+                <a:latin typeface="DejaVu Sans"/>
+                <a:ea typeface="DejaVu Sans"/>
+                <a:cs typeface="DejaVu Sans"/>
+              </a:defRPr>
+            </a:pPr>
+            <a:r>
+              <a:rPr sz="2700" b="0" dirty="0">
+                <a:solidFill>
+                  <a:srgbClr val="30455F"/>
+                </a:solidFill>
+                <a:latin typeface="DejaVu Sans"/>
+                <a:ea typeface="DejaVu Sans"/>
+                <a:cs typeface="DejaVu Sans"/>
+              </a:rPr>
+              <a:t>for patient review.</a:t>
+            </a:r>
+          </a:p>
+        </p:txBody>
+      </p:sp>
+      <p:sp>
+        <p:nvSpPr>
+          <p:cNvPr id="4" name="Rectangle 3">
+            <a:extLst>
+              <a:ext uri="{FF2B5EF4-FFF2-40B4-BE49-F238E27FC236}">
+                <a16:creationId xmlns:a16="http://schemas.microsoft.com/office/drawing/2014/main" id="{8A33E280-17CF-443E-B2F7-AD48A71AF774}"/>
+              </a:ext>
+            </a:extLst>
+          </p:cNvPr>
+          <p:cNvSpPr>
+            <a:spLocks noGrp="1"/>
+          </p:cNvSpPr>
+          <p:nvPr/>
+        </p:nvSpPr>
+        <p:spPr>
+          <a:xfrm>
+            <a:off x="762000" y="8096250"/>
+            <a:ext cx="8763000" cy="1238250"/>
+          </a:xfrm>
+          <a:prstGeom prst="rect">
+            <a:avLst/>
+          </a:prstGeom>
+          <a:noFill/>
+          <a:ln w="0">
+            <a:noFill/>
+          </a:ln>
+        </p:spPr>
+        <p:txBody>
+          <a:bodyPr lIns="0" tIns="0" rIns="0" bIns="0">
+            <a:noAutofit/>
+          </a:bodyPr>
+          <a:lstStyle>
+            <a:defPPr>
+              <a:defRPr sz="2625" b="1">
+                <a:solidFill>
+                  <a:srgbClr val="1765BA"/>
+                </a:solidFill>
+                <a:latin typeface="DejaVu Sans"/>
+                <a:ea typeface="DejaVu Sans"/>
+                <a:cs typeface="DejaVu Sans"/>
+              </a:defRPr>
+            </a:defPPr>
+          </a:lstStyle>
+          <a:p>
+            <a:pPr>
+              <a:defRPr sz="2625" b="1">
+                <a:solidFill>
+                  <a:srgbClr val="1765BA"/>
+                </a:solidFill>
+                <a:latin typeface="DejaVu Sans"/>
+                <a:ea typeface="DejaVu Sans"/>
+                <a:cs typeface="DejaVu Sans"/>
+              </a:defRPr>
+            </a:pPr>
+            <a:endParaRPr sz="2625" b="1" dirty="0">
+              <a:solidFill>
+                <a:srgbClr val="1765BA"/>
+              </a:solidFill>
+              <a:latin typeface="DejaVu Sans"/>
+              <a:ea typeface="DejaVu Sans"/>
+              <a:cs typeface="DejaVu Sans"/>
+            </a:endParaRPr>
           </a:p>
         </p:txBody>
       </p:sp>
     </p:spTree>
     <p:extLst>
       <p:ext uri="{BB962C8B-B14F-4D97-AF65-F5344CB8AC3E}">
-        <p14:creationId xmlns:p14="http://schemas.microsoft.com/office/powerpoint/2010/main" val="600462984"/>
+        <p14:creationId xmlns:p14="http://schemas.microsoft.com/office/powerpoint/2010/main" val="1310335856"/>
       </p:ext>
     </p:extLst>
   </p:cSld>
+  <p:clrMapOvr>
+    <a:masterClrMapping/>
+  </p:clrMapOvr>
 </p:sld>
 </file>
 
 <file path=ppt/slides/slide2.xml><?xml version="1.0" encoding="utf-8"?>
-<p:sld xmlns:p="http://schemas.openxmlformats.org/presentationml/2006/main">
+<p:sld xmlns:a="http://schemas.openxmlformats.org/drawingml/2006/main" xmlns:r="http://schemas.openxmlformats.org/officeDocument/2006/relationships" xmlns:p="http://schemas.openxmlformats.org/presentationml/2006/main">
   <p:cSld>
     <p:bg>
       <p:bgPr>
-        <a:solidFill xmlns:a="http://schemas.openxmlformats.org/drawingml/2006/main">
-          <a:srgbClr val="F5F8FD"/>
+        <a:solidFill>
+          <a:srgbClr val="FFFFFF"/>
         </a:solidFill>
+        <a:effectLst/>
       </p:bgPr>
     </p:bg>
     <p:spTree>
@@ -3204,42 +3111,47 @@
         <p:nvPr/>
       </p:nvGrpSpPr>
       <p:grpSpPr>
-        <a:xfrm xmlns:a="http://schemas.openxmlformats.org/drawingml/2006/main"/>
+        <a:xfrm>
+          <a:off x="0" y="0"/>
+          <a:ext cx="0" cy="0"/>
+          <a:chOff x="0" y="0"/>
+          <a:chExt cx="0" cy="0"/>
+        </a:xfrm>
       </p:grpSpPr>
       <p:sp>
         <p:nvSpPr>
-          <p:cNvPr id="8" name="">
-            <a:extLst xmlns:a="http://schemas.openxmlformats.org/drawingml/2006/main">
+          <p:cNvPr id="8" name="Rectangle 7">
+            <a:extLst>
               <a:ext uri="{FF2B5EF4-FFF2-40B4-BE49-F238E27FC236}">
-                <a16:creationId xmlns:a16="http://schemas.microsoft.com/office/drawing/2014/main" id="{CF235680-7603-460F-AF81-851896614626}"/>
+                <a16:creationId xmlns:a16="http://schemas.microsoft.com/office/drawing/2014/main" id="{D8785984-EDCE-4489-84B1-C807120D195B}"/>
               </a:ext>
             </a:extLst>
           </p:cNvPr>
           <p:cNvSpPr>
-            <a:spLocks xmlns:a="http://schemas.openxmlformats.org/drawingml/2006/main" noGrp="1"/>
+            <a:spLocks noGrp="1"/>
           </p:cNvSpPr>
           <p:nvPr/>
         </p:nvSpPr>
         <p:spPr>
-          <a:xfrm xmlns:a="http://schemas.openxmlformats.org/drawingml/2006/main">
-            <a:off x="723900" y="819150"/>
-            <a:ext cx="8858250" cy="1905000"/>
+          <a:xfrm>
+            <a:off x="723900" y="723900"/>
+            <a:ext cx="8858250" cy="1714500"/>
           </a:xfrm>
-          <a:prstGeom xmlns:a="http://schemas.openxmlformats.org/drawingml/2006/main" prst="rect">
+          <a:prstGeom prst="rect">
             <a:avLst/>
           </a:prstGeom>
-          <a:noFill xmlns:a="http://schemas.openxmlformats.org/drawingml/2006/main"/>
-          <a:ln xmlns:a="http://schemas.openxmlformats.org/drawingml/2006/main" w="0">
+          <a:noFill/>
+          <a:ln w="0">
             <a:noFill/>
           </a:ln>
         </p:spPr>
         <p:txBody>
-          <a:bodyPr xmlns:a="http://schemas.openxmlformats.org/drawingml/2006/main" lIns="0" tIns="0" rIns="0" bIns="0">
+          <a:bodyPr lIns="0" tIns="0" rIns="0" bIns="0">
             <a:noAutofit/>
           </a:bodyPr>
-          <a:lstStyle xmlns:a="http://schemas.openxmlformats.org/drawingml/2006/main">
+          <a:lstStyle>
             <a:defPPr>
-              <a:defRPr sz="4500" b="1">
+              <a:defRPr sz="4275" b="1">
                 <a:solidFill>
                   <a:srgbClr val="12375F"/>
                 </a:solidFill>
@@ -3249,9 +3161,9 @@
               </a:defRPr>
             </a:defPPr>
           </a:lstStyle>
-          <a:p xmlns:a="http://schemas.openxmlformats.org/drawingml/2006/main">
+          <a:p>
             <a:pPr>
-              <a:defRPr sz="4500" b="1">
+              <a:defRPr sz="4275" b="1">
                 <a:solidFill>
                   <a:srgbClr val="12375F"/>
                 </a:solidFill>
@@ -3261,7 +3173,7 @@
               </a:defRPr>
             </a:pPr>
             <a:r>
-              <a:rPr sz="4500" b="1">
+              <a:rPr sz="4275" b="1">
                 <a:solidFill>
                   <a:srgbClr val="12375F"/>
                 </a:solidFill>
@@ -3269,12 +3181,12 @@
                 <a:ea typeface="DejaVu Sans"/>
                 <a:cs typeface="DejaVu Sans"/>
               </a:rPr>
-              <a:t>Connecting records</a:t>
+              <a:t>The platform connects</a:t>
             </a:r>
           </a:p>
-          <a:p xmlns:a="http://schemas.openxmlformats.org/drawingml/2006/main">
+          <a:p>
             <a:pPr>
-              <a:defRPr sz="4500" b="1">
+              <a:defRPr sz="4275" b="1">
                 <a:solidFill>
                   <a:srgbClr val="12375F"/>
                 </a:solidFill>
@@ -3284,7 +3196,7 @@
               </a:defRPr>
             </a:pPr>
             <a:r>
-              <a:rPr sz="4500" b="1">
+              <a:rPr sz="4275" b="1">
                 <a:solidFill>
                   <a:srgbClr val="12375F"/>
                 </a:solidFill>
@@ -3292,43 +3204,43 @@
                 <a:ea typeface="DejaVu Sans"/>
                 <a:cs typeface="DejaVu Sans"/>
               </a:rPr>
-              <a:t>makes them reviewable</a:t>
+              <a:t>clinical data to analytics</a:t>
             </a:r>
           </a:p>
         </p:txBody>
       </p:sp>
       <p:sp>
         <p:nvSpPr>
-          <p:cNvPr id="2" name="">
-            <a:extLst xmlns:a="http://schemas.openxmlformats.org/drawingml/2006/main">
+          <p:cNvPr id="2" name="Rectangle 1">
+            <a:extLst>
               <a:ext uri="{FF2B5EF4-FFF2-40B4-BE49-F238E27FC236}">
-                <a16:creationId xmlns:a16="http://schemas.microsoft.com/office/drawing/2014/main" id="{89901920-B260-41A2-9940-33367613BED3}"/>
+                <a16:creationId xmlns:a16="http://schemas.microsoft.com/office/drawing/2014/main" id="{6566F75B-1409-436A-8D56-EE2418D43CB9}"/>
               </a:ext>
             </a:extLst>
           </p:cNvPr>
           <p:cNvSpPr>
-            <a:spLocks xmlns:a="http://schemas.openxmlformats.org/drawingml/2006/main" noGrp="1"/>
+            <a:spLocks noGrp="1"/>
           </p:cNvSpPr>
           <p:nvPr/>
         </p:nvSpPr>
         <p:spPr>
-          <a:xfrm xmlns:a="http://schemas.openxmlformats.org/drawingml/2006/main">
-            <a:off x="762000" y="2857500"/>
+          <a:xfrm>
+            <a:off x="762000" y="2762250"/>
             <a:ext cx="8763000" cy="523875"/>
           </a:xfrm>
-          <a:prstGeom xmlns:a="http://schemas.openxmlformats.org/drawingml/2006/main" prst="rect">
+          <a:prstGeom prst="rect">
             <a:avLst/>
           </a:prstGeom>
-          <a:noFill xmlns:a="http://schemas.openxmlformats.org/drawingml/2006/main"/>
-          <a:ln xmlns:a="http://schemas.openxmlformats.org/drawingml/2006/main" w="0">
+          <a:noFill/>
+          <a:ln w="0">
             <a:noFill/>
           </a:ln>
         </p:spPr>
         <p:txBody>
-          <a:bodyPr xmlns:a="http://schemas.openxmlformats.org/drawingml/2006/main" lIns="0" tIns="0" rIns="0" bIns="0">
+          <a:bodyPr lIns="0" tIns="0" rIns="0" bIns="0">
             <a:noAutofit/>
           </a:bodyPr>
-          <a:lstStyle xmlns:a="http://schemas.openxmlformats.org/drawingml/2006/main">
+          <a:lstStyle>
             <a:defPPr>
               <a:defRPr sz="2850" b="1">
                 <a:solidFill>
@@ -3340,7 +3252,7 @@
               </a:defRPr>
             </a:defPPr>
           </a:lstStyle>
-          <a:p xmlns:a="http://schemas.openxmlformats.org/drawingml/2006/main">
+          <a:p>
             <a:pPr>
               <a:defRPr sz="2850" b="1">
                 <a:solidFill>
@@ -3367,40 +3279,40 @@
       </p:sp>
       <p:sp>
         <p:nvSpPr>
-          <p:cNvPr id="3" name="">
-            <a:extLst xmlns:a="http://schemas.openxmlformats.org/drawingml/2006/main">
+          <p:cNvPr id="3" name="Rectangle 2">
+            <a:extLst>
               <a:ext uri="{FF2B5EF4-FFF2-40B4-BE49-F238E27FC236}">
-                <a16:creationId xmlns:a16="http://schemas.microsoft.com/office/drawing/2014/main" id="{FBA51E69-5A8E-4867-85D3-CDF9D4A2FB20}"/>
+                <a16:creationId xmlns:a16="http://schemas.microsoft.com/office/drawing/2014/main" id="{FB0E1A12-C71B-4ABF-AAEB-F11D125F094B}"/>
               </a:ext>
             </a:extLst>
           </p:cNvPr>
           <p:cNvSpPr>
-            <a:spLocks xmlns:a="http://schemas.openxmlformats.org/drawingml/2006/main" noGrp="1"/>
+            <a:spLocks noGrp="1"/>
           </p:cNvSpPr>
           <p:nvPr/>
         </p:nvSpPr>
         <p:spPr>
-          <a:xfrm xmlns:a="http://schemas.openxmlformats.org/drawingml/2006/main">
-            <a:off x="762000" y="3467100"/>
-            <a:ext cx="8763000" cy="952500"/>
+          <a:xfrm>
+            <a:off x="762000" y="3400425"/>
+            <a:ext cx="8763000" cy="1381125"/>
           </a:xfrm>
-          <a:prstGeom xmlns:a="http://schemas.openxmlformats.org/drawingml/2006/main" prst="rect">
+          <a:prstGeom prst="rect">
             <a:avLst/>
           </a:prstGeom>
-          <a:noFill xmlns:a="http://schemas.openxmlformats.org/drawingml/2006/main"/>
-          <a:ln xmlns:a="http://schemas.openxmlformats.org/drawingml/2006/main" w="0">
+          <a:noFill/>
+          <a:ln w="0">
             <a:noFill/>
           </a:ln>
         </p:spPr>
         <p:txBody>
-          <a:bodyPr xmlns:a="http://schemas.openxmlformats.org/drawingml/2006/main" lIns="0" tIns="0" rIns="0" bIns="0">
+          <a:bodyPr lIns="0" tIns="0" rIns="0" bIns="0">
             <a:noAutofit/>
           </a:bodyPr>
-          <a:lstStyle xmlns:a="http://schemas.openxmlformats.org/drawingml/2006/main">
+          <a:lstStyle>
             <a:defPPr>
-              <a:defRPr sz="2325" b="0">
-                <a:solidFill>
-                  <a:srgbClr val="12375F"/>
+              <a:defRPr sz="2400" b="0">
+                <a:solidFill>
+                  <a:srgbClr val="30455F"/>
                 </a:solidFill>
                 <a:latin typeface="DejaVu Sans"/>
                 <a:ea typeface="DejaVu Sans"/>
@@ -3408,11 +3320,11 @@
               </a:defRPr>
             </a:defPPr>
           </a:lstStyle>
-          <a:p xmlns:a="http://schemas.openxmlformats.org/drawingml/2006/main">
+          <a:p>
             <a:pPr>
-              <a:defRPr sz="2325" b="0">
-                <a:solidFill>
-                  <a:srgbClr val="12375F"/>
+              <a:defRPr sz="2400" b="0">
+                <a:solidFill>
+                  <a:srgbClr val="30455F"/>
                 </a:solidFill>
                 <a:latin typeface="DejaVu Sans"/>
                 <a:ea typeface="DejaVu Sans"/>
@@ -3420,9 +3332,9 @@
               </a:defRPr>
             </a:pPr>
             <a:r>
-              <a:rPr sz="2325" b="0">
-                <a:solidFill>
-                  <a:srgbClr val="12375F"/>
+              <a:rPr sz="2400" b="0">
+                <a:solidFill>
+                  <a:srgbClr val="30455F"/>
                 </a:solidFill>
                 <a:latin typeface="DejaVu Sans"/>
                 <a:ea typeface="DejaVu Sans"/>
@@ -3431,11 +3343,11 @@
               <a:t>HL7-to-FHIR transformation with linked patient,</a:t>
             </a:r>
           </a:p>
-          <a:p xmlns:a="http://schemas.openxmlformats.org/drawingml/2006/main">
+          <a:p>
             <a:pPr>
-              <a:defRPr sz="2325" b="0">
-                <a:solidFill>
-                  <a:srgbClr val="12375F"/>
+              <a:defRPr sz="2400" b="0">
+                <a:solidFill>
+                  <a:srgbClr val="30455F"/>
                 </a:solidFill>
                 <a:latin typeface="DejaVu Sans"/>
                 <a:ea typeface="DejaVu Sans"/>
@@ -3443,51 +3355,74 @@
               </a:defRPr>
             </a:pPr>
             <a:r>
-              <a:rPr sz="2325" b="0">
-                <a:solidFill>
-                  <a:srgbClr val="12375F"/>
+              <a:rPr sz="2400" b="0">
+                <a:solidFill>
+                  <a:srgbClr val="30455F"/>
                 </a:solidFill>
                 <a:latin typeface="DejaVu Sans"/>
                 <a:ea typeface="DejaVu Sans"/>
                 <a:cs typeface="DejaVu Sans"/>
               </a:rPr>
-              <a:t>laboratory and appointment records.</a:t>
+              <a:t>laboratory and appointment records,</a:t>
+            </a:r>
+          </a:p>
+          <a:p>
+            <a:pPr>
+              <a:defRPr sz="2400" b="0">
+                <a:solidFill>
+                  <a:srgbClr val="30455F"/>
+                </a:solidFill>
+                <a:latin typeface="DejaVu Sans"/>
+                <a:ea typeface="DejaVu Sans"/>
+                <a:cs typeface="DejaVu Sans"/>
+              </a:defRPr>
+            </a:pPr>
+            <a:r>
+              <a:rPr sz="2400" b="0">
+                <a:solidFill>
+                  <a:srgbClr val="30455F"/>
+                </a:solidFill>
+                <a:latin typeface="DejaVu Sans"/>
+                <a:ea typeface="DejaVu Sans"/>
+                <a:cs typeface="DejaVu Sans"/>
+              </a:rPr>
+              <a:t>managed through Firely.</a:t>
             </a:r>
           </a:p>
         </p:txBody>
       </p:sp>
       <p:sp>
         <p:nvSpPr>
-          <p:cNvPr id="4" name="">
-            <a:extLst xmlns:a="http://schemas.openxmlformats.org/drawingml/2006/main">
+          <p:cNvPr id="4" name="Rectangle 3">
+            <a:extLst>
               <a:ext uri="{FF2B5EF4-FFF2-40B4-BE49-F238E27FC236}">
-                <a16:creationId xmlns:a16="http://schemas.microsoft.com/office/drawing/2014/main" id="{6B0741BC-620C-4C84-B03E-AEAFD90B7C91}"/>
+                <a16:creationId xmlns:a16="http://schemas.microsoft.com/office/drawing/2014/main" id="{71FBB85E-FA08-46F8-A222-910B7B430B67}"/>
               </a:ext>
             </a:extLst>
           </p:cNvPr>
           <p:cNvSpPr>
-            <a:spLocks xmlns:a="http://schemas.openxmlformats.org/drawingml/2006/main" noGrp="1"/>
+            <a:spLocks noGrp="1"/>
           </p:cNvSpPr>
           <p:nvPr/>
         </p:nvSpPr>
         <p:spPr>
-          <a:xfrm xmlns:a="http://schemas.openxmlformats.org/drawingml/2006/main">
-            <a:off x="762000" y="4772025"/>
+          <a:xfrm>
+            <a:off x="762000" y="5057775"/>
             <a:ext cx="8763000" cy="523875"/>
           </a:xfrm>
-          <a:prstGeom xmlns:a="http://schemas.openxmlformats.org/drawingml/2006/main" prst="rect">
+          <a:prstGeom prst="rect">
             <a:avLst/>
           </a:prstGeom>
-          <a:noFill xmlns:a="http://schemas.openxmlformats.org/drawingml/2006/main"/>
-          <a:ln xmlns:a="http://schemas.openxmlformats.org/drawingml/2006/main" w="0">
+          <a:noFill/>
+          <a:ln w="0">
             <a:noFill/>
           </a:ln>
         </p:spPr>
         <p:txBody>
-          <a:bodyPr xmlns:a="http://schemas.openxmlformats.org/drawingml/2006/main" lIns="0" tIns="0" rIns="0" bIns="0">
+          <a:bodyPr lIns="0" tIns="0" rIns="0" bIns="0">
             <a:noAutofit/>
           </a:bodyPr>
-          <a:lstStyle xmlns:a="http://schemas.openxmlformats.org/drawingml/2006/main">
+          <a:lstStyle>
             <a:defPPr>
               <a:defRPr sz="2850" b="1">
                 <a:solidFill>
@@ -3499,7 +3434,7 @@
               </a:defRPr>
             </a:defPPr>
           </a:lstStyle>
-          <a:p xmlns:a="http://schemas.openxmlformats.org/drawingml/2006/main">
+          <a:p>
             <a:pPr>
               <a:defRPr sz="2850" b="1">
                 <a:solidFill>
@@ -3526,40 +3461,40 @@
       </p:sp>
       <p:sp>
         <p:nvSpPr>
-          <p:cNvPr id="5" name="">
-            <a:extLst xmlns:a="http://schemas.openxmlformats.org/drawingml/2006/main">
+          <p:cNvPr id="5" name="Rectangle 4">
+            <a:extLst>
               <a:ext uri="{FF2B5EF4-FFF2-40B4-BE49-F238E27FC236}">
-                <a16:creationId xmlns:a16="http://schemas.microsoft.com/office/drawing/2014/main" id="{E341634D-6FC9-416B-84BA-6294644F2CD7}"/>
+                <a16:creationId xmlns:a16="http://schemas.microsoft.com/office/drawing/2014/main" id="{63619018-6844-4445-9EA2-135DB6041542}"/>
               </a:ext>
             </a:extLst>
           </p:cNvPr>
           <p:cNvSpPr>
-            <a:spLocks xmlns:a="http://schemas.openxmlformats.org/drawingml/2006/main" noGrp="1"/>
+            <a:spLocks noGrp="1"/>
           </p:cNvSpPr>
           <p:nvPr/>
         </p:nvSpPr>
         <p:spPr>
-          <a:xfrm xmlns:a="http://schemas.openxmlformats.org/drawingml/2006/main">
-            <a:off x="762000" y="5381625"/>
-            <a:ext cx="8763000" cy="952500"/>
+          <a:xfrm>
+            <a:off x="762000" y="5695950"/>
+            <a:ext cx="8763000" cy="1381125"/>
           </a:xfrm>
-          <a:prstGeom xmlns:a="http://schemas.openxmlformats.org/drawingml/2006/main" prst="rect">
+          <a:prstGeom prst="rect">
             <a:avLst/>
           </a:prstGeom>
-          <a:noFill xmlns:a="http://schemas.openxmlformats.org/drawingml/2006/main"/>
-          <a:ln xmlns:a="http://schemas.openxmlformats.org/drawingml/2006/main" w="0">
+          <a:noFill/>
+          <a:ln w="0">
             <a:noFill/>
           </a:ln>
         </p:spPr>
         <p:txBody>
-          <a:bodyPr xmlns:a="http://schemas.openxmlformats.org/drawingml/2006/main" lIns="0" tIns="0" rIns="0" bIns="0">
+          <a:bodyPr lIns="0" tIns="0" rIns="0" bIns="0">
             <a:noAutofit/>
           </a:bodyPr>
-          <a:lstStyle xmlns:a="http://schemas.openxmlformats.org/drawingml/2006/main">
+          <a:lstStyle>
             <a:defPPr>
-              <a:defRPr sz="2325" b="0">
-                <a:solidFill>
-                  <a:srgbClr val="12375F"/>
+              <a:defRPr sz="2400" b="0">
+                <a:solidFill>
+                  <a:srgbClr val="30455F"/>
                 </a:solidFill>
                 <a:latin typeface="DejaVu Sans"/>
                 <a:ea typeface="DejaVu Sans"/>
@@ -3567,11 +3502,11 @@
               </a:defRPr>
             </a:defPPr>
           </a:lstStyle>
-          <a:p xmlns:a="http://schemas.openxmlformats.org/drawingml/2006/main">
+          <a:p>
             <a:pPr>
-              <a:defRPr sz="2325" b="0">
-                <a:solidFill>
-                  <a:srgbClr val="12375F"/>
+              <a:defRPr sz="2400" b="0">
+                <a:solidFill>
+                  <a:srgbClr val="30455F"/>
                 </a:solidFill>
                 <a:latin typeface="DejaVu Sans"/>
                 <a:ea typeface="DejaVu Sans"/>
@@ -3579,22 +3514,22 @@
               </a:defRPr>
             </a:pPr>
             <a:r>
-              <a:rPr sz="2325" b="0">
-                <a:solidFill>
-                  <a:srgbClr val="12375F"/>
+              <a:rPr sz="2400" b="0">
+                <a:solidFill>
+                  <a:srgbClr val="30455F"/>
                 </a:solidFill>
                 <a:latin typeface="DejaVu Sans"/>
                 <a:ea typeface="DejaVu Sans"/>
                 <a:cs typeface="DejaVu Sans"/>
               </a:rPr>
-              <a:t>An AWS S3–Snowflake pipeline with traceable batch</a:t>
+              <a:t>An AWS S3–Snowflake pipeline with private,</a:t>
             </a:r>
           </a:p>
-          <a:p xmlns:a="http://schemas.openxmlformats.org/drawingml/2006/main">
+          <a:p>
             <a:pPr>
-              <a:defRPr sz="2325" b="0">
-                <a:solidFill>
-                  <a:srgbClr val="12375F"/>
+              <a:defRPr sz="2400" b="0">
+                <a:solidFill>
+                  <a:srgbClr val="30455F"/>
                 </a:solidFill>
                 <a:latin typeface="DejaVu Sans"/>
                 <a:ea typeface="DejaVu Sans"/>
@@ -3602,51 +3537,74 @@
               </a:defRPr>
             </a:pPr>
             <a:r>
-              <a:rPr sz="2325" b="0">
-                <a:solidFill>
-                  <a:srgbClr val="12375F"/>
+              <a:rPr sz="2400" b="0">
+                <a:solidFill>
+                  <a:srgbClr val="30455F"/>
                 </a:solidFill>
                 <a:latin typeface="DejaVu Sans"/>
                 <a:ea typeface="DejaVu Sans"/>
                 <a:cs typeface="DejaVu Sans"/>
               </a:rPr>
-              <a:t>ingestion and structured clinical data.</a:t>
+              <a:t>encrypted cloud storage, traceable batches</a:t>
+            </a:r>
+          </a:p>
+          <a:p>
+            <a:pPr>
+              <a:defRPr sz="2400" b="0">
+                <a:solidFill>
+                  <a:srgbClr val="30455F"/>
+                </a:solidFill>
+                <a:latin typeface="DejaVu Sans"/>
+                <a:ea typeface="DejaVu Sans"/>
+                <a:cs typeface="DejaVu Sans"/>
+              </a:defRPr>
+            </a:pPr>
+            <a:r>
+              <a:rPr sz="2400" b="0">
+                <a:solidFill>
+                  <a:srgbClr val="30455F"/>
+                </a:solidFill>
+                <a:latin typeface="DejaVu Sans"/>
+                <a:ea typeface="DejaVu Sans"/>
+                <a:cs typeface="DejaVu Sans"/>
+              </a:rPr>
+              <a:t>and structured clinical data.</a:t>
             </a:r>
           </a:p>
         </p:txBody>
       </p:sp>
       <p:sp>
         <p:nvSpPr>
-          <p:cNvPr id="6" name="">
-            <a:extLst xmlns:a="http://schemas.openxmlformats.org/drawingml/2006/main">
+          <p:cNvPr id="6" name="Rectangle 5">
+            <a:extLst>
               <a:ext uri="{FF2B5EF4-FFF2-40B4-BE49-F238E27FC236}">
-                <a16:creationId xmlns:a16="http://schemas.microsoft.com/office/drawing/2014/main" id="{D16A2362-F68A-442F-B8C1-17788A79AD8B}"/>
+                <a16:creationId xmlns:a16="http://schemas.microsoft.com/office/drawing/2014/main" id="{7E6154E8-25B5-4CBE-814F-26638F708A46}"/>
               </a:ext>
             </a:extLst>
           </p:cNvPr>
           <p:cNvSpPr>
-            <a:spLocks xmlns:a="http://schemas.openxmlformats.org/drawingml/2006/main" noGrp="1"/>
+            <a:spLocks noGrp="1"/>
           </p:cNvSpPr>
           <p:nvPr/>
         </p:nvSpPr>
         <p:spPr>
-          <a:xfrm xmlns:a="http://schemas.openxmlformats.org/drawingml/2006/main">
-            <a:off x="762000" y="6686550"/>
+          <a:xfrm>
+            <a:off x="762000" y="7362825"/>
             <a:ext cx="8763000" cy="523875"/>
           </a:xfrm>
-          <a:prstGeom xmlns:a="http://schemas.openxmlformats.org/drawingml/2006/main" prst="rect">
+          <a:prstGeom prst="rect">
             <a:avLst/>
           </a:prstGeom>
-          <a:noFill xmlns:a="http://schemas.openxmlformats.org/drawingml/2006/main"/>
-          <a:ln xmlns:a="http://schemas.openxmlformats.org/drawingml/2006/main" w="0">
+          <a:noFill/>
+          <a:ln w="0">
             <a:noFill/>
           </a:ln>
         </p:spPr>
         <p:txBody>
-          <a:bodyPr xmlns:a="http://schemas.openxmlformats.org/drawingml/2006/main" lIns="0" tIns="0" rIns="0" bIns="0">
+          <a:bodyPr lIns="0" tIns="0" rIns="0" bIns="0">
             <a:noAutofit/>
           </a:bodyPr>
-          <a:lstStyle xmlns:a="http://schemas.openxmlformats.org/drawingml/2006/main">
+          <a:lstStyle>
             <a:defPPr>
               <a:defRPr sz="2850" b="1">
                 <a:solidFill>
@@ -3658,7 +3616,7 @@
               </a:defRPr>
             </a:defPPr>
           </a:lstStyle>
-          <a:p xmlns:a="http://schemas.openxmlformats.org/drawingml/2006/main">
+          <a:p>
             <a:pPr>
               <a:defRPr sz="2850" b="1">
                 <a:solidFill>
@@ -3685,40 +3643,40 @@
       </p:sp>
       <p:sp>
         <p:nvSpPr>
-          <p:cNvPr id="7" name="">
-            <a:extLst xmlns:a="http://schemas.openxmlformats.org/drawingml/2006/main">
+          <p:cNvPr id="7" name="Rectangle 6">
+            <a:extLst>
               <a:ext uri="{FF2B5EF4-FFF2-40B4-BE49-F238E27FC236}">
-                <a16:creationId xmlns:a16="http://schemas.microsoft.com/office/drawing/2014/main" id="{743C8B53-8B3D-448C-9006-6D58A92EF3BA}"/>
+                <a16:creationId xmlns:a16="http://schemas.microsoft.com/office/drawing/2014/main" id="{1558CD77-5FD6-4455-909D-D88FC2FA6929}"/>
               </a:ext>
             </a:extLst>
           </p:cNvPr>
           <p:cNvSpPr>
-            <a:spLocks xmlns:a="http://schemas.openxmlformats.org/drawingml/2006/main" noGrp="1"/>
+            <a:spLocks noGrp="1"/>
           </p:cNvSpPr>
           <p:nvPr/>
         </p:nvSpPr>
         <p:spPr>
-          <a:xfrm xmlns:a="http://schemas.openxmlformats.org/drawingml/2006/main">
-            <a:off x="762000" y="7296150"/>
-            <a:ext cx="8763000" cy="952500"/>
+          <a:xfrm>
+            <a:off x="762000" y="8001000"/>
+            <a:ext cx="8763000" cy="1381125"/>
           </a:xfrm>
-          <a:prstGeom xmlns:a="http://schemas.openxmlformats.org/drawingml/2006/main" prst="rect">
+          <a:prstGeom prst="rect">
             <a:avLst/>
           </a:prstGeom>
-          <a:noFill xmlns:a="http://schemas.openxmlformats.org/drawingml/2006/main"/>
-          <a:ln xmlns:a="http://schemas.openxmlformats.org/drawingml/2006/main" w="0">
+          <a:noFill/>
+          <a:ln w="0">
             <a:noFill/>
           </a:ln>
         </p:spPr>
         <p:txBody>
-          <a:bodyPr xmlns:a="http://schemas.openxmlformats.org/drawingml/2006/main" lIns="0" tIns="0" rIns="0" bIns="0">
+          <a:bodyPr lIns="0" tIns="0" rIns="0" bIns="0">
             <a:noAutofit/>
           </a:bodyPr>
-          <a:lstStyle xmlns:a="http://schemas.openxmlformats.org/drawingml/2006/main">
+          <a:lstStyle>
             <a:defPPr>
-              <a:defRPr sz="2325" b="0">
-                <a:solidFill>
-                  <a:srgbClr val="12375F"/>
+              <a:defRPr sz="2400" b="0">
+                <a:solidFill>
+                  <a:srgbClr val="30455F"/>
                 </a:solidFill>
                 <a:latin typeface="DejaVu Sans"/>
                 <a:ea typeface="DejaVu Sans"/>
@@ -3726,11 +3684,11 @@
               </a:defRPr>
             </a:defPPr>
           </a:lstStyle>
-          <a:p xmlns:a="http://schemas.openxmlformats.org/drawingml/2006/main">
+          <a:p>
             <a:pPr>
-              <a:defRPr sz="2325" b="0">
-                <a:solidFill>
-                  <a:srgbClr val="12375F"/>
+              <a:defRPr sz="2400" b="0">
+                <a:solidFill>
+                  <a:srgbClr val="30455F"/>
                 </a:solidFill>
                 <a:latin typeface="DejaVu Sans"/>
                 <a:ea typeface="DejaVu Sans"/>
@@ -3738,22 +3696,22 @@
               </a:defRPr>
             </a:pPr>
             <a:r>
-              <a:rPr sz="2325" b="0">
-                <a:solidFill>
-                  <a:srgbClr val="12375F"/>
+              <a:rPr sz="2400" b="0">
+                <a:solidFill>
+                  <a:srgbClr val="30455F"/>
                 </a:solidFill>
                 <a:latin typeface="DejaVu Sans"/>
                 <a:ea typeface="DejaVu Sans"/>
                 <a:cs typeface="DejaVu Sans"/>
               </a:rPr>
-              <a:t>Visibility into patient information coverage and</a:t>
+              <a:t>Patient information coverage across clinical</a:t>
             </a:r>
           </a:p>
-          <a:p xmlns:a="http://schemas.openxmlformats.org/drawingml/2006/main">
+          <a:p>
             <a:pPr>
-              <a:defRPr sz="2325" b="0">
-                <a:solidFill>
-                  <a:srgbClr val="12375F"/>
+              <a:defRPr sz="2400" b="0">
+                <a:solidFill>
+                  <a:srgbClr val="30455F"/>
                 </a:solidFill>
                 <a:latin typeface="DejaVu Sans"/>
                 <a:ea typeface="DejaVu Sans"/>
@@ -3761,15 +3719,38 @@
               </a:defRPr>
             </a:pPr>
             <a:r>
-              <a:rPr sz="2325" b="0">
-                <a:solidFill>
-                  <a:srgbClr val="12375F"/>
+              <a:rPr sz="2400" b="0">
+                <a:solidFill>
+                  <a:srgbClr val="30455F"/>
                 </a:solidFill>
                 <a:latin typeface="DejaVu Sans"/>
                 <a:ea typeface="DejaVu Sans"/>
                 <a:cs typeface="DejaVu Sans"/>
               </a:rPr>
-              <a:t>qualifying results ahead of scheduled visits.</a:t>
+              <a:t>resources, plus appointment-specific checks</a:t>
+            </a:r>
+          </a:p>
+          <a:p>
+            <a:pPr>
+              <a:defRPr sz="2400" b="0">
+                <a:solidFill>
+                  <a:srgbClr val="30455F"/>
+                </a:solidFill>
+                <a:latin typeface="DejaVu Sans"/>
+                <a:ea typeface="DejaVu Sans"/>
+                <a:cs typeface="DejaVu Sans"/>
+              </a:defRPr>
+            </a:pPr>
+            <a:r>
+              <a:rPr sz="2400" b="0">
+                <a:solidFill>
+                  <a:srgbClr val="30455F"/>
+                </a:solidFill>
+                <a:latin typeface="DejaVu Sans"/>
+                <a:ea typeface="DejaVu Sans"/>
+                <a:cs typeface="DejaVu Sans"/>
+              </a:rPr>
+              <a:t>for qualifying laboratory results.</a:t>
             </a:r>
           </a:p>
         </p:txBody>
@@ -3777,21 +3758,25 @@
     </p:spTree>
     <p:extLst>
       <p:ext uri="{BB962C8B-B14F-4D97-AF65-F5344CB8AC3E}">
-        <p14:creationId xmlns:p14="http://schemas.microsoft.com/office/powerpoint/2010/main" val="2014445117"/>
+        <p14:creationId xmlns:p14="http://schemas.microsoft.com/office/powerpoint/2010/main" val="2138538560"/>
       </p:ext>
     </p:extLst>
   </p:cSld>
+  <p:clrMapOvr>
+    <a:masterClrMapping/>
+  </p:clrMapOvr>
 </p:sld>
 </file>
 
 <file path=ppt/slides/slide3.xml><?xml version="1.0" encoding="utf-8"?>
-<p:sld xmlns:p="http://schemas.openxmlformats.org/presentationml/2006/main">
+<p:sld xmlns:a="http://schemas.openxmlformats.org/drawingml/2006/main" xmlns:r="http://schemas.openxmlformats.org/officeDocument/2006/relationships" xmlns:p="http://schemas.openxmlformats.org/presentationml/2006/main">
   <p:cSld>
     <p:bg>
       <p:bgPr>
-        <a:solidFill xmlns:a="http://schemas.openxmlformats.org/drawingml/2006/main">
-          <a:srgbClr val="12375F"/>
+        <a:solidFill>
+          <a:srgbClr val="FFFFFF"/>
         </a:solidFill>
+        <a:effectLst/>
       </p:bgPr>
     </p:bg>
     <p:spTree>
@@ -3801,44 +3786,49 @@
         <p:nvPr/>
       </p:nvGrpSpPr>
       <p:grpSpPr>
-        <a:xfrm xmlns:a="http://schemas.openxmlformats.org/drawingml/2006/main"/>
+        <a:xfrm>
+          <a:off x="0" y="0"/>
+          <a:ext cx="0" cy="0"/>
+          <a:chOff x="0" y="0"/>
+          <a:chExt cx="0" cy="0"/>
+        </a:xfrm>
       </p:grpSpPr>
       <p:sp>
         <p:nvSpPr>
-          <p:cNvPr id="4" name="">
-            <a:extLst xmlns:a="http://schemas.openxmlformats.org/drawingml/2006/main">
+          <p:cNvPr id="8" name="Rectangle 7">
+            <a:extLst>
               <a:ext uri="{FF2B5EF4-FFF2-40B4-BE49-F238E27FC236}">
-                <a16:creationId xmlns:a16="http://schemas.microsoft.com/office/drawing/2014/main" id="{36DD7471-75DA-49C5-B380-13A71EB58791}"/>
+                <a16:creationId xmlns:a16="http://schemas.microsoft.com/office/drawing/2014/main" id="{0503EDDD-2DBA-49B3-B078-235D303D7F6D}"/>
               </a:ext>
             </a:extLst>
           </p:cNvPr>
           <p:cNvSpPr>
-            <a:spLocks xmlns:a="http://schemas.openxmlformats.org/drawingml/2006/main" noGrp="1"/>
+            <a:spLocks noGrp="1"/>
           </p:cNvSpPr>
           <p:nvPr/>
         </p:nvSpPr>
         <p:spPr>
-          <a:xfrm xmlns:a="http://schemas.openxmlformats.org/drawingml/2006/main">
-            <a:off x="723900" y="952500"/>
-            <a:ext cx="8858250" cy="1885950"/>
+          <a:xfrm>
+            <a:off x="723900" y="723900"/>
+            <a:ext cx="8858250" cy="1714500"/>
           </a:xfrm>
-          <a:prstGeom xmlns:a="http://schemas.openxmlformats.org/drawingml/2006/main" prst="rect">
+          <a:prstGeom prst="rect">
             <a:avLst/>
           </a:prstGeom>
-          <a:noFill xmlns:a="http://schemas.openxmlformats.org/drawingml/2006/main"/>
-          <a:ln xmlns:a="http://schemas.openxmlformats.org/drawingml/2006/main" w="0">
+          <a:noFill/>
+          <a:ln w="0">
             <a:noFill/>
           </a:ln>
         </p:spPr>
         <p:txBody>
-          <a:bodyPr xmlns:a="http://schemas.openxmlformats.org/drawingml/2006/main" lIns="0" tIns="0" rIns="0" bIns="0">
+          <a:bodyPr lIns="0" tIns="0" rIns="0" bIns="0">
             <a:noAutofit/>
           </a:bodyPr>
-          <a:lstStyle xmlns:a="http://schemas.openxmlformats.org/drawingml/2006/main">
+          <a:lstStyle>
             <a:defPPr>
-              <a:defRPr sz="4950" b="1">
-                <a:solidFill>
-                  <a:srgbClr val="FFFFFF"/>
+              <a:defRPr sz="4500" b="1">
+                <a:solidFill>
+                  <a:srgbClr val="12375F"/>
                 </a:solidFill>
                 <a:latin typeface="DejaVu Sans"/>
                 <a:ea typeface="DejaVu Sans"/>
@@ -3846,11 +3836,11 @@
               </a:defRPr>
             </a:defPPr>
           </a:lstStyle>
-          <a:p xmlns:a="http://schemas.openxmlformats.org/drawingml/2006/main">
+          <a:p>
             <a:pPr>
-              <a:defRPr sz="4950" b="1">
-                <a:solidFill>
-                  <a:srgbClr val="FFFFFF"/>
+              <a:defRPr sz="4500" b="1">
+                <a:solidFill>
+                  <a:srgbClr val="12375F"/>
                 </a:solidFill>
                 <a:latin typeface="DejaVu Sans"/>
                 <a:ea typeface="DejaVu Sans"/>
@@ -3858,22 +3848,22 @@
               </a:defRPr>
             </a:pPr>
             <a:r>
-              <a:rPr sz="4950" b="1">
-                <a:solidFill>
-                  <a:srgbClr val="FFFFFF"/>
+              <a:rPr sz="4500" b="1">
+                <a:solidFill>
+                  <a:srgbClr val="12375F"/>
                 </a:solidFill>
                 <a:latin typeface="DejaVu Sans"/>
                 <a:ea typeface="DejaVu Sans"/>
                 <a:cs typeface="DejaVu Sans"/>
               </a:rPr>
-              <a:t>Reviewers can see</a:t>
+              <a:t>Patient information</a:t>
             </a:r>
           </a:p>
-          <a:p xmlns:a="http://schemas.openxmlformats.org/drawingml/2006/main">
+          <a:p>
             <a:pPr>
-              <a:defRPr sz="4950" b="1">
-                <a:solidFill>
-                  <a:srgbClr val="FFFFFF"/>
+              <a:defRPr sz="4500" b="1">
+                <a:solidFill>
+                  <a:srgbClr val="12375F"/>
                 </a:solidFill>
                 <a:latin typeface="DejaVu Sans"/>
                 <a:ea typeface="DejaVu Sans"/>
@@ -3881,55 +3871,55 @@
               </a:defRPr>
             </a:pPr>
             <a:r>
-              <a:rPr sz="4950" b="1">
-                <a:solidFill>
-                  <a:srgbClr val="FFFFFF"/>
+              <a:rPr sz="4500" b="1">
+                <a:solidFill>
+                  <a:srgbClr val="12375F"/>
                 </a:solidFill>
                 <a:latin typeface="DejaVu Sans"/>
                 <a:ea typeface="DejaVu Sans"/>
                 <a:cs typeface="DejaVu Sans"/>
               </a:rPr>
-              <a:t>what is available</a:t>
+              <a:t>with context</a:t>
             </a:r>
           </a:p>
         </p:txBody>
       </p:sp>
       <p:sp>
         <p:nvSpPr>
-          <p:cNvPr id="2" name="">
-            <a:extLst xmlns:a="http://schemas.openxmlformats.org/drawingml/2006/main">
+          <p:cNvPr id="2" name="Rectangle 1">
+            <a:extLst>
               <a:ext uri="{FF2B5EF4-FFF2-40B4-BE49-F238E27FC236}">
-                <a16:creationId xmlns:a16="http://schemas.microsoft.com/office/drawing/2014/main" id="{8D6A1AFC-69C0-49F1-9267-15F735598692}"/>
+                <a16:creationId xmlns:a16="http://schemas.microsoft.com/office/drawing/2014/main" id="{D2A69851-D3A1-4A10-BB82-443650E49C5C}"/>
               </a:ext>
             </a:extLst>
           </p:cNvPr>
           <p:cNvSpPr>
-            <a:spLocks xmlns:a="http://schemas.openxmlformats.org/drawingml/2006/main" noGrp="1"/>
+            <a:spLocks noGrp="1"/>
           </p:cNvSpPr>
           <p:nvPr/>
         </p:nvSpPr>
         <p:spPr>
-          <a:xfrm xmlns:a="http://schemas.openxmlformats.org/drawingml/2006/main">
-            <a:off x="762000" y="3914775"/>
-            <a:ext cx="8782050" cy="2286000"/>
+          <a:xfrm>
+            <a:off x="762000" y="2695575"/>
+            <a:ext cx="8763000" cy="523875"/>
           </a:xfrm>
-          <a:prstGeom xmlns:a="http://schemas.openxmlformats.org/drawingml/2006/main" prst="rect">
+          <a:prstGeom prst="rect">
             <a:avLst/>
           </a:prstGeom>
-          <a:noFill xmlns:a="http://schemas.openxmlformats.org/drawingml/2006/main"/>
-          <a:ln xmlns:a="http://schemas.openxmlformats.org/drawingml/2006/main" w="0">
+          <a:noFill/>
+          <a:ln w="0">
             <a:noFill/>
           </a:ln>
         </p:spPr>
         <p:txBody>
-          <a:bodyPr xmlns:a="http://schemas.openxmlformats.org/drawingml/2006/main" lIns="0" tIns="0" rIns="0" bIns="0">
+          <a:bodyPr lIns="0" tIns="0" rIns="0" bIns="0">
             <a:noAutofit/>
           </a:bodyPr>
-          <a:lstStyle xmlns:a="http://schemas.openxmlformats.org/drawingml/2006/main">
+          <a:lstStyle>
             <a:defPPr>
-              <a:defRPr sz="2775" b="0">
-                <a:solidFill>
-                  <a:srgbClr val="D8E7F5"/>
+              <a:defRPr sz="2850" b="1">
+                <a:solidFill>
+                  <a:srgbClr val="16867F"/>
                 </a:solidFill>
                 <a:latin typeface="DejaVu Sans"/>
                 <a:ea typeface="DejaVu Sans"/>
@@ -3937,11 +3927,11 @@
               </a:defRPr>
             </a:defPPr>
           </a:lstStyle>
-          <a:p xmlns:a="http://schemas.openxmlformats.org/drawingml/2006/main">
+          <a:p>
             <a:pPr>
-              <a:defRPr sz="2775" b="0">
-                <a:solidFill>
-                  <a:srgbClr val="D8E7F5"/>
+              <a:defRPr sz="2850" b="1">
+                <a:solidFill>
+                  <a:srgbClr val="16867F"/>
                 </a:solidFill>
                 <a:latin typeface="DejaVu Sans"/>
                 <a:ea typeface="DejaVu Sans"/>
@@ -3949,101 +3939,55 @@
               </a:defRPr>
             </a:pPr>
             <a:r>
-              <a:rPr sz="2775" b="0">
-                <a:solidFill>
-                  <a:srgbClr val="D8E7F5"/>
+              <a:rPr sz="2850" b="1">
+                <a:solidFill>
+                  <a:srgbClr val="16867F"/>
                 </a:solidFill>
                 <a:latin typeface="DejaVu Sans"/>
                 <a:ea typeface="DejaVu Sans"/>
                 <a:cs typeface="DejaVu Sans"/>
               </a:rPr>
-              <a:t>Coverage analytics show linked patient records.</a:t>
-            </a:r>
-          </a:p>
-          <a:p xmlns:a="http://schemas.openxmlformats.org/drawingml/2006/main">
-            <a:pPr>
-              <a:defRPr sz="2775" b="0">
-                <a:solidFill>
-                  <a:srgbClr val="D8E7F5"/>
-                </a:solidFill>
-                <a:latin typeface="DejaVu Sans"/>
-                <a:ea typeface="DejaVu Sans"/>
-                <a:cs typeface="DejaVu Sans"/>
-              </a:defRPr>
-            </a:pPr>
-            <a:r>
-              <a:rPr sz="2775" b="0">
-                <a:solidFill>
-                  <a:srgbClr val="D8E7F5"/>
-                </a:solidFill>
-                <a:latin typeface="DejaVu Sans"/>
-                <a:ea typeface="DejaVu Sans"/>
-                <a:cs typeface="DejaVu Sans"/>
-              </a:rPr>
-              <a:t>Visit checks explain which results qualify</a:t>
-            </a:r>
-          </a:p>
-          <a:p xmlns:a="http://schemas.openxmlformats.org/drawingml/2006/main">
-            <a:pPr>
-              <a:defRPr sz="2775" b="0">
-                <a:solidFill>
-                  <a:srgbClr val="D8E7F5"/>
-                </a:solidFill>
-                <a:latin typeface="DejaVu Sans"/>
-                <a:ea typeface="DejaVu Sans"/>
-                <a:cs typeface="DejaVu Sans"/>
-              </a:defRPr>
-            </a:pPr>
-            <a:r>
-              <a:rPr sz="2775" b="0">
-                <a:solidFill>
-                  <a:srgbClr val="D8E7F5"/>
-                </a:solidFill>
-                <a:latin typeface="DejaVu Sans"/>
-                <a:ea typeface="DejaVu Sans"/>
-                <a:cs typeface="DejaVu Sans"/>
-              </a:rPr>
-              <a:t>before an appointment.</a:t>
+              <a:t>Broader data coverage</a:t>
             </a:r>
           </a:p>
         </p:txBody>
       </p:sp>
       <p:sp>
         <p:nvSpPr>
-          <p:cNvPr id="3" name="">
-            <a:extLst xmlns:a="http://schemas.openxmlformats.org/drawingml/2006/main">
+          <p:cNvPr id="3" name="Rectangle 2">
+            <a:extLst>
               <a:ext uri="{FF2B5EF4-FFF2-40B4-BE49-F238E27FC236}">
-                <a16:creationId xmlns:a16="http://schemas.microsoft.com/office/drawing/2014/main" id="{0E9C1A8A-39EF-42B9-8529-8D67E05C3A11}"/>
+                <a16:creationId xmlns:a16="http://schemas.microsoft.com/office/drawing/2014/main" id="{69A19E2A-776E-4A24-993B-582061DD20B7}"/>
               </a:ext>
             </a:extLst>
           </p:cNvPr>
           <p:cNvSpPr>
-            <a:spLocks xmlns:a="http://schemas.openxmlformats.org/drawingml/2006/main" noGrp="1"/>
+            <a:spLocks noGrp="1"/>
           </p:cNvSpPr>
           <p:nvPr/>
         </p:nvSpPr>
         <p:spPr>
-          <a:xfrm xmlns:a="http://schemas.openxmlformats.org/drawingml/2006/main">
-            <a:off x="762000" y="7515225"/>
-            <a:ext cx="8782050" cy="1819275"/>
+          <a:xfrm>
+            <a:off x="762000" y="3314700"/>
+            <a:ext cx="8763000" cy="1381125"/>
           </a:xfrm>
-          <a:prstGeom xmlns:a="http://schemas.openxmlformats.org/drawingml/2006/main" prst="rect">
+          <a:prstGeom prst="rect">
             <a:avLst/>
           </a:prstGeom>
-          <a:noFill xmlns:a="http://schemas.openxmlformats.org/drawingml/2006/main"/>
-          <a:ln xmlns:a="http://schemas.openxmlformats.org/drawingml/2006/main" w="0">
+          <a:noFill/>
+          <a:ln w="0">
             <a:noFill/>
           </a:ln>
         </p:spPr>
         <p:txBody>
-          <a:bodyPr xmlns:a="http://schemas.openxmlformats.org/drawingml/2006/main" lIns="0" tIns="0" rIns="0" bIns="0">
+          <a:bodyPr lIns="0" tIns="0" rIns="0" bIns="0">
             <a:noAutofit/>
           </a:bodyPr>
-          <a:lstStyle xmlns:a="http://schemas.openxmlformats.org/drawingml/2006/main">
+          <a:lstStyle>
             <a:defPPr>
-              <a:defRPr sz="2625" b="0">
-                <a:solidFill>
-                  <a:srgbClr val="78D8CF"/>
+              <a:defRPr sz="2400" b="0">
+                <a:solidFill>
+                  <a:srgbClr val="30455F"/>
                 </a:solidFill>
                 <a:latin typeface="DejaVu Sans"/>
                 <a:ea typeface="DejaVu Sans"/>
@@ -4051,11 +3995,11 @@
               </a:defRPr>
             </a:defPPr>
           </a:lstStyle>
-          <a:p xmlns:a="http://schemas.openxmlformats.org/drawingml/2006/main">
+          <a:p>
             <a:pPr>
-              <a:defRPr sz="2625" b="0">
-                <a:solidFill>
-                  <a:srgbClr val="78D8CF"/>
+              <a:defRPr sz="2400" b="0">
+                <a:solidFill>
+                  <a:srgbClr val="30455F"/>
                 </a:solidFill>
                 <a:latin typeface="DejaVu Sans"/>
                 <a:ea typeface="DejaVu Sans"/>
@@ -4063,22 +4007,22 @@
               </a:defRPr>
             </a:pPr>
             <a:r>
-              <a:rPr sz="2625" b="0">
-                <a:solidFill>
-                  <a:srgbClr val="78D8CF"/>
+              <a:rPr sz="2400" b="0">
+                <a:solidFill>
+                  <a:srgbClr val="30455F"/>
                 </a:solidFill>
                 <a:latin typeface="DejaVu Sans"/>
                 <a:ea typeface="DejaVu Sans"/>
                 <a:cs typeface="DejaVu Sans"/>
               </a:rPr>
-              <a:t>Building similar platforms?</a:t>
+              <a:t>933 native FHIR resources across 11 types</a:t>
             </a:r>
           </a:p>
-          <a:p xmlns:a="http://schemas.openxmlformats.org/drawingml/2006/main">
+          <a:p>
             <a:pPr>
-              <a:defRPr sz="2625" b="0">
-                <a:solidFill>
-                  <a:srgbClr val="78D8CF"/>
+              <a:defRPr sz="2400" b="0">
+                <a:solidFill>
+                  <a:srgbClr val="30455F"/>
                 </a:solidFill>
                 <a:latin typeface="DejaVu Sans"/>
                 <a:ea typeface="DejaVu Sans"/>
@@ -4086,22 +4030,22 @@
               </a:defRPr>
             </a:pPr>
             <a:r>
-              <a:rPr sz="2625" b="0">
-                <a:solidFill>
-                  <a:srgbClr val="78D8CF"/>
+              <a:rPr sz="2400" b="0">
+                <a:solidFill>
+                  <a:srgbClr val="30455F"/>
                 </a:solidFill>
                 <a:latin typeface="DejaVu Sans"/>
                 <a:ea typeface="DejaVu Sans"/>
                 <a:cs typeface="DejaVu Sans"/>
               </a:rPr>
-              <a:t>I’d welcome your perspective, or a conversation</a:t>
+              <a:t>extended downstream analytics to allergies,</a:t>
             </a:r>
           </a:p>
-          <a:p xmlns:a="http://schemas.openxmlformats.org/drawingml/2006/main">
+          <a:p>
             <a:pPr>
-              <a:defRPr sz="2625" b="0">
-                <a:solidFill>
-                  <a:srgbClr val="78D8CF"/>
+              <a:defRPr sz="2400" b="0">
+                <a:solidFill>
+                  <a:srgbClr val="30455F"/>
                 </a:solidFill>
                 <a:latin typeface="DejaVu Sans"/>
                 <a:ea typeface="DejaVu Sans"/>
@@ -4109,15 +4053,379 @@
               </a:defRPr>
             </a:pPr>
             <a:r>
-              <a:rPr sz="2625" b="0">
-                <a:solidFill>
-                  <a:srgbClr val="78D8CF"/>
+              <a:rPr sz="2400" b="0">
+                <a:solidFill>
+                  <a:srgbClr val="30455F"/>
                 </a:solidFill>
                 <a:latin typeface="DejaVu Sans"/>
                 <a:ea typeface="DejaVu Sans"/>
                 <a:cs typeface="DejaVu Sans"/>
               </a:rPr>
-              <a:t>about where I could contribute.</a:t>
+              <a:t>medications, encounters and other records.</a:t>
+            </a:r>
+          </a:p>
+        </p:txBody>
+      </p:sp>
+      <p:sp>
+        <p:nvSpPr>
+          <p:cNvPr id="4" name="Rectangle 3">
+            <a:extLst>
+              <a:ext uri="{FF2B5EF4-FFF2-40B4-BE49-F238E27FC236}">
+                <a16:creationId xmlns:a16="http://schemas.microsoft.com/office/drawing/2014/main" id="{4C92DA23-997B-4024-9D68-41F0AF0AA7AC}"/>
+              </a:ext>
+            </a:extLst>
+          </p:cNvPr>
+          <p:cNvSpPr>
+            <a:spLocks noGrp="1"/>
+          </p:cNvSpPr>
+          <p:nvPr/>
+        </p:nvSpPr>
+        <p:spPr>
+          <a:xfrm>
+            <a:off x="762000" y="4914900"/>
+            <a:ext cx="8763000" cy="523875"/>
+          </a:xfrm>
+          <a:prstGeom prst="rect">
+            <a:avLst/>
+          </a:prstGeom>
+          <a:noFill/>
+          <a:ln w="0">
+            <a:noFill/>
+          </a:ln>
+        </p:spPr>
+        <p:txBody>
+          <a:bodyPr lIns="0" tIns="0" rIns="0" bIns="0">
+            <a:noAutofit/>
+          </a:bodyPr>
+          <a:lstStyle>
+            <a:defPPr>
+              <a:defRPr sz="2850" b="1">
+                <a:solidFill>
+                  <a:srgbClr val="16867F"/>
+                </a:solidFill>
+                <a:latin typeface="DejaVu Sans"/>
+                <a:ea typeface="DejaVu Sans"/>
+                <a:cs typeface="DejaVu Sans"/>
+              </a:defRPr>
+            </a:defPPr>
+          </a:lstStyle>
+          <a:p>
+            <a:pPr>
+              <a:defRPr sz="2850" b="1">
+                <a:solidFill>
+                  <a:srgbClr val="16867F"/>
+                </a:solidFill>
+                <a:latin typeface="DejaVu Sans"/>
+                <a:ea typeface="DejaVu Sans"/>
+                <a:cs typeface="DejaVu Sans"/>
+              </a:defRPr>
+            </a:pPr>
+            <a:r>
+              <a:rPr sz="2850" b="1">
+                <a:solidFill>
+                  <a:srgbClr val="16867F"/>
+                </a:solidFill>
+                <a:latin typeface="DejaVu Sans"/>
+                <a:ea typeface="DejaVu Sans"/>
+                <a:cs typeface="DejaVu Sans"/>
+              </a:rPr>
+              <a:t>A working reviewer demonstration</a:t>
+            </a:r>
+          </a:p>
+        </p:txBody>
+      </p:sp>
+      <p:sp>
+        <p:nvSpPr>
+          <p:cNvPr id="5" name="Rectangle 4">
+            <a:extLst>
+              <a:ext uri="{FF2B5EF4-FFF2-40B4-BE49-F238E27FC236}">
+                <a16:creationId xmlns:a16="http://schemas.microsoft.com/office/drawing/2014/main" id="{66FFCE9E-60CC-4D43-895D-BD1D30795BC6}"/>
+              </a:ext>
+            </a:extLst>
+          </p:cNvPr>
+          <p:cNvSpPr>
+            <a:spLocks noGrp="1"/>
+          </p:cNvSpPr>
+          <p:nvPr/>
+        </p:nvSpPr>
+        <p:spPr>
+          <a:xfrm>
+            <a:off x="762000" y="5534025"/>
+            <a:ext cx="8763000" cy="1381125"/>
+          </a:xfrm>
+          <a:prstGeom prst="rect">
+            <a:avLst/>
+          </a:prstGeom>
+          <a:noFill/>
+          <a:ln w="0">
+            <a:noFill/>
+          </a:ln>
+        </p:spPr>
+        <p:txBody>
+          <a:bodyPr lIns="0" tIns="0" rIns="0" bIns="0">
+            <a:noAutofit/>
+          </a:bodyPr>
+          <a:lstStyle>
+            <a:defPPr>
+              <a:defRPr sz="2400" b="0">
+                <a:solidFill>
+                  <a:srgbClr val="30455F"/>
+                </a:solidFill>
+                <a:latin typeface="DejaVu Sans"/>
+                <a:ea typeface="DejaVu Sans"/>
+                <a:cs typeface="DejaVu Sans"/>
+              </a:defRPr>
+            </a:defPPr>
+          </a:lstStyle>
+          <a:p>
+            <a:pPr>
+              <a:defRPr sz="2400" b="0">
+                <a:solidFill>
+                  <a:srgbClr val="30455F"/>
+                </a:solidFill>
+                <a:latin typeface="DejaVu Sans"/>
+                <a:ea typeface="DejaVu Sans"/>
+                <a:cs typeface="DejaVu Sans"/>
+              </a:defRPr>
+            </a:pPr>
+            <a:r>
+              <a:rPr sz="2400" b="0">
+                <a:solidFill>
+                  <a:srgbClr val="30455F"/>
+                </a:solidFill>
+                <a:latin typeface="DejaVu Sans"/>
+                <a:ea typeface="DejaVu Sans"/>
+                <a:cs typeface="DejaVu Sans"/>
+              </a:rPr>
+              <a:t>Authenticated access shows appointment status</a:t>
+            </a:r>
+          </a:p>
+          <a:p>
+            <a:pPr>
+              <a:defRPr sz="2400" b="0">
+                <a:solidFill>
+                  <a:srgbClr val="30455F"/>
+                </a:solidFill>
+                <a:latin typeface="DejaVu Sans"/>
+                <a:ea typeface="DejaVu Sans"/>
+                <a:cs typeface="DejaVu Sans"/>
+              </a:defRPr>
+            </a:pPr>
+            <a:r>
+              <a:rPr sz="2400" b="0">
+                <a:solidFill>
+                  <a:srgbClr val="30455F"/>
+                </a:solidFill>
+                <a:latin typeface="DejaVu Sans"/>
+                <a:ea typeface="DejaVu Sans"/>
+                <a:cs typeface="DejaVu Sans"/>
+              </a:rPr>
+              <a:t>and qualifying glucose results. All 9 configured</a:t>
+            </a:r>
+          </a:p>
+          <a:p>
+            <a:pPr>
+              <a:defRPr sz="2400" b="0">
+                <a:solidFill>
+                  <a:srgbClr val="30455F"/>
+                </a:solidFill>
+                <a:latin typeface="DejaVu Sans"/>
+                <a:ea typeface="DejaVu Sans"/>
+                <a:cs typeface="DejaVu Sans"/>
+              </a:defRPr>
+            </a:pPr>
+            <a:r>
+              <a:rPr sz="2400" b="0">
+                <a:solidFill>
+                  <a:srgbClr val="30455F"/>
+                </a:solidFill>
+                <a:latin typeface="DejaVu Sans"/>
+                <a:ea typeface="DejaVu Sans"/>
+                <a:cs typeface="DejaVu Sans"/>
+              </a:rPr>
+              <a:t>visit-rule tests matched expected outcomes.</a:t>
+            </a:r>
+          </a:p>
+        </p:txBody>
+      </p:sp>
+      <p:sp>
+        <p:nvSpPr>
+          <p:cNvPr id="6" name="Rectangle 5">
+            <a:extLst>
+              <a:ext uri="{FF2B5EF4-FFF2-40B4-BE49-F238E27FC236}">
+                <a16:creationId xmlns:a16="http://schemas.microsoft.com/office/drawing/2014/main" id="{736F1BA5-B034-4BE1-B490-37D153693084}"/>
+              </a:ext>
+            </a:extLst>
+          </p:cNvPr>
+          <p:cNvSpPr>
+            <a:spLocks noGrp="1"/>
+          </p:cNvSpPr>
+          <p:nvPr/>
+        </p:nvSpPr>
+        <p:spPr>
+          <a:xfrm>
+            <a:off x="762000" y="7305675"/>
+            <a:ext cx="8763000" cy="523875"/>
+          </a:xfrm>
+          <a:prstGeom prst="rect">
+            <a:avLst/>
+          </a:prstGeom>
+          <a:noFill/>
+          <a:ln w="0">
+            <a:noFill/>
+          </a:ln>
+        </p:spPr>
+        <p:txBody>
+          <a:bodyPr lIns="0" tIns="0" rIns="0" bIns="0">
+            <a:noAutofit/>
+          </a:bodyPr>
+          <a:lstStyle>
+            <a:defPPr>
+              <a:defRPr sz="2700" b="1">
+                <a:solidFill>
+                  <a:srgbClr val="1765BA"/>
+                </a:solidFill>
+                <a:latin typeface="DejaVu Sans"/>
+                <a:ea typeface="DejaVu Sans"/>
+                <a:cs typeface="DejaVu Sans"/>
+              </a:defRPr>
+            </a:defPPr>
+          </a:lstStyle>
+          <a:p>
+            <a:pPr>
+              <a:defRPr sz="2700" b="1">
+                <a:solidFill>
+                  <a:srgbClr val="1765BA"/>
+                </a:solidFill>
+                <a:latin typeface="DejaVu Sans"/>
+                <a:ea typeface="DejaVu Sans"/>
+                <a:cs typeface="DejaVu Sans"/>
+              </a:defRPr>
+            </a:pPr>
+            <a:r>
+              <a:rPr sz="2700" b="1">
+                <a:solidFill>
+                  <a:srgbClr val="1765BA"/>
+                </a:solidFill>
+                <a:latin typeface="DejaVu Sans"/>
+                <a:ea typeface="DejaVu Sans"/>
+                <a:cs typeface="DejaVu Sans"/>
+              </a:rPr>
+              <a:t>Building similar healthcare platforms?</a:t>
+            </a:r>
+          </a:p>
+        </p:txBody>
+      </p:sp>
+      <p:sp>
+        <p:nvSpPr>
+          <p:cNvPr id="7" name="Rectangle 6">
+            <a:extLst>
+              <a:ext uri="{FF2B5EF4-FFF2-40B4-BE49-F238E27FC236}">
+                <a16:creationId xmlns:a16="http://schemas.microsoft.com/office/drawing/2014/main" id="{FA076B4D-45A8-4132-9F66-5A30BB9D023E}"/>
+              </a:ext>
+            </a:extLst>
+          </p:cNvPr>
+          <p:cNvSpPr>
+            <a:spLocks noGrp="1"/>
+          </p:cNvSpPr>
+          <p:nvPr/>
+        </p:nvSpPr>
+        <p:spPr>
+          <a:xfrm>
+            <a:off x="762000" y="7934325"/>
+            <a:ext cx="8763000" cy="1428750"/>
+          </a:xfrm>
+          <a:prstGeom prst="rect">
+            <a:avLst/>
+          </a:prstGeom>
+          <a:noFill/>
+          <a:ln w="0">
+            <a:noFill/>
+          </a:ln>
+        </p:spPr>
+        <p:txBody>
+          <a:bodyPr lIns="0" tIns="0" rIns="0" bIns="0">
+            <a:noAutofit/>
+          </a:bodyPr>
+          <a:lstStyle>
+            <a:defPPr>
+              <a:defRPr sz="2325" b="0">
+                <a:solidFill>
+                  <a:srgbClr val="30455F"/>
+                </a:solidFill>
+                <a:latin typeface="DejaVu Sans"/>
+                <a:ea typeface="DejaVu Sans"/>
+                <a:cs typeface="DejaVu Sans"/>
+              </a:defRPr>
+            </a:defPPr>
+          </a:lstStyle>
+          <a:p>
+            <a:pPr>
+              <a:defRPr sz="2325" b="0">
+                <a:solidFill>
+                  <a:srgbClr val="30455F"/>
+                </a:solidFill>
+                <a:latin typeface="DejaVu Sans"/>
+                <a:ea typeface="DejaVu Sans"/>
+                <a:cs typeface="DejaVu Sans"/>
+              </a:defRPr>
+            </a:pPr>
+            <a:r>
+              <a:rPr sz="2325" b="0">
+                <a:solidFill>
+                  <a:srgbClr val="30455F"/>
+                </a:solidFill>
+                <a:latin typeface="DejaVu Sans"/>
+                <a:ea typeface="DejaVu Sans"/>
+                <a:cs typeface="DejaVu Sans"/>
+              </a:rPr>
+              <a:t>I’d value your perspective on these challenges.</a:t>
+            </a:r>
+          </a:p>
+          <a:p>
+            <a:pPr>
+              <a:defRPr sz="2325" b="0">
+                <a:solidFill>
+                  <a:srgbClr val="30455F"/>
+                </a:solidFill>
+                <a:latin typeface="DejaVu Sans"/>
+                <a:ea typeface="DejaVu Sans"/>
+                <a:cs typeface="DejaVu Sans"/>
+              </a:defRPr>
+            </a:pPr>
+            <a:r>
+              <a:rPr sz="2325" b="0">
+                <a:solidFill>
+                  <a:srgbClr val="30455F"/>
+                </a:solidFill>
+                <a:latin typeface="DejaVu Sans"/>
+                <a:ea typeface="DejaVu Sans"/>
+                <a:cs typeface="DejaVu Sans"/>
+              </a:rPr>
+              <a:t>If this overlaps with your team’s work, I’d welcome</a:t>
+            </a:r>
+          </a:p>
+          <a:p>
+            <a:pPr>
+              <a:defRPr sz="2325" b="0">
+                <a:solidFill>
+                  <a:srgbClr val="30455F"/>
+                </a:solidFill>
+                <a:latin typeface="DejaVu Sans"/>
+                <a:ea typeface="DejaVu Sans"/>
+                <a:cs typeface="DejaVu Sans"/>
+              </a:defRPr>
+            </a:pPr>
+            <a:r>
+              <a:rPr sz="2325" b="0">
+                <a:solidFill>
+                  <a:srgbClr val="30455F"/>
+                </a:solidFill>
+                <a:latin typeface="DejaVu Sans"/>
+                <a:ea typeface="DejaVu Sans"/>
+                <a:cs typeface="DejaVu Sans"/>
+              </a:rPr>
+              <a:t>a conversation about where I could contribute.</a:t>
             </a:r>
           </a:p>
         </p:txBody>
@@ -4125,10 +4433,13 @@
     </p:spTree>
     <p:extLst>
       <p:ext uri="{BB962C8B-B14F-4D97-AF65-F5344CB8AC3E}">
-        <p14:creationId xmlns:p14="http://schemas.microsoft.com/office/powerpoint/2010/main" val="176709538"/>
+        <p14:creationId xmlns:p14="http://schemas.microsoft.com/office/powerpoint/2010/main" val="415127123"/>
       </p:ext>
     </p:extLst>
   </p:cSld>
+  <p:clrMapOvr>
+    <a:masterClrMapping/>
+  </p:clrMapOvr>
 </p:sld>
 </file>
 
@@ -4374,5 +4685,322 @@
       </a:bgFillStyleLst>
     </a:fmtScheme>
   </a:themeElements>
+  <a:objectDefaults/>
+  <a:extraClrSchemeLst/>
+</a:theme>
+</file>
+
+<file path=ppt/theme/theme2.xml><?xml version="1.0" encoding="utf-8"?>
+<a:theme xmlns:a="http://schemas.openxmlformats.org/drawingml/2006/main" name="Office Theme">
+  <a:themeElements>
+    <a:clrScheme name="Office">
+      <a:dk1>
+        <a:sysClr val="windowText" lastClr="000000"/>
+      </a:dk1>
+      <a:lt1>
+        <a:sysClr val="window" lastClr="FFFFFF"/>
+      </a:lt1>
+      <a:dk2>
+        <a:srgbClr val="0E2841"/>
+      </a:dk2>
+      <a:lt2>
+        <a:srgbClr val="E8E8E8"/>
+      </a:lt2>
+      <a:accent1>
+        <a:srgbClr val="156082"/>
+      </a:accent1>
+      <a:accent2>
+        <a:srgbClr val="E97132"/>
+      </a:accent2>
+      <a:accent3>
+        <a:srgbClr val="196B24"/>
+      </a:accent3>
+      <a:accent4>
+        <a:srgbClr val="0F9ED5"/>
+      </a:accent4>
+      <a:accent5>
+        <a:srgbClr val="A02B93"/>
+      </a:accent5>
+      <a:accent6>
+        <a:srgbClr val="4EA72E"/>
+      </a:accent6>
+      <a:hlink>
+        <a:srgbClr val="467886"/>
+      </a:hlink>
+      <a:folHlink>
+        <a:srgbClr val="96607D"/>
+      </a:folHlink>
+    </a:clrScheme>
+    <a:fontScheme name="Office">
+      <a:majorFont>
+        <a:latin typeface="Aptos Display" panose="02110004020202020204"/>
+        <a:ea typeface=""/>
+        <a:cs typeface=""/>
+        <a:font script="Jpan" typeface="游ゴシック Light"/>
+        <a:font script="Hang" typeface="맑은 고딕"/>
+        <a:font script="Hans" typeface="等线 Light"/>
+        <a:font script="Hant" typeface="新細明體"/>
+        <a:font script="Arab" typeface="Times New Roman"/>
+        <a:font script="Hebr" typeface="Times New Roman"/>
+        <a:font script="Thai" typeface="Angsana New"/>
+        <a:font script="Ethi" typeface="Nyala"/>
+        <a:font script="Beng" typeface="Vrinda"/>
+        <a:font script="Gujr" typeface="Shruti"/>
+        <a:font script="Khmr" typeface="MoolBoran"/>
+        <a:font script="Knda" typeface="Tunga"/>
+        <a:font script="Guru" typeface="Raavi"/>
+        <a:font script="Cans" typeface="Euphemia"/>
+        <a:font script="Cher" typeface="Plantagenet Cherokee"/>
+        <a:font script="Yiii" typeface="Microsoft Yi Baiti"/>
+        <a:font script="Tibt" typeface="Microsoft Himalaya"/>
+        <a:font script="Thaa" typeface="MV Boli"/>
+        <a:font script="Deva" typeface="Mangal"/>
+        <a:font script="Telu" typeface="Gautami"/>
+        <a:font script="Taml" typeface="Latha"/>
+        <a:font script="Syrc" typeface="Estrangelo Edessa"/>
+        <a:font script="Orya" typeface="Kalinga"/>
+        <a:font script="Mlym" typeface="Kartika"/>
+        <a:font script="Laoo" typeface="DokChampa"/>
+        <a:font script="Sinh" typeface="Iskoola Pota"/>
+        <a:font script="Mong" typeface="Mongolian Baiti"/>
+        <a:font script="Viet" typeface="Times New Roman"/>
+        <a:font script="Uigh" typeface="Microsoft Uighur"/>
+        <a:font script="Geor" typeface="Sylfaen"/>
+        <a:font script="Armn" typeface="Arial"/>
+        <a:font script="Bugi" typeface="Leelawadee UI"/>
+        <a:font script="Bopo" typeface="Microsoft JhengHei"/>
+        <a:font script="Java" typeface="Javanese Text"/>
+        <a:font script="Lisu" typeface="Segoe UI"/>
+        <a:font script="Mymr" typeface="Myanmar Text"/>
+        <a:font script="Nkoo" typeface="Ebrima"/>
+        <a:font script="Olck" typeface="Nirmala UI"/>
+        <a:font script="Osma" typeface="Ebrima"/>
+        <a:font script="Phag" typeface="Phagspa"/>
+        <a:font script="Syrn" typeface="Estrangelo Edessa"/>
+        <a:font script="Syrj" typeface="Estrangelo Edessa"/>
+        <a:font script="Syre" typeface="Estrangelo Edessa"/>
+        <a:font script="Sora" typeface="Nirmala UI"/>
+        <a:font script="Tale" typeface="Microsoft Tai Le"/>
+        <a:font script="Talu" typeface="Microsoft New Tai Lue"/>
+        <a:font script="Tfng" typeface="Ebrima"/>
+      </a:majorFont>
+      <a:minorFont>
+        <a:latin typeface="Aptos" panose="02110004020202020204"/>
+        <a:ea typeface=""/>
+        <a:cs typeface=""/>
+        <a:font script="Jpan" typeface="游ゴシック"/>
+        <a:font script="Hang" typeface="맑은 고딕"/>
+        <a:font script="Hans" typeface="等线"/>
+        <a:font script="Hant" typeface="新細明體"/>
+        <a:font script="Arab" typeface="Arial"/>
+        <a:font script="Hebr" typeface="Arial"/>
+        <a:font script="Thai" typeface="Cordia New"/>
+        <a:font script="Ethi" typeface="Nyala"/>
+        <a:font script="Beng" typeface="Vrinda"/>
+        <a:font script="Gujr" typeface="Shruti"/>
+        <a:font script="Khmr" typeface="DaunPenh"/>
+        <a:font script="Knda" typeface="Tunga"/>
+        <a:font script="Guru" typeface="Raavi"/>
+        <a:font script="Cans" typeface="Euphemia"/>
+        <a:font script="Cher" typeface="Plantagenet Cherokee"/>
+        <a:font script="Yiii" typeface="Microsoft Yi Baiti"/>
+        <a:font script="Tibt" typeface="Microsoft Himalaya"/>
+        <a:font script="Thaa" typeface="MV Boli"/>
+        <a:font script="Deva" typeface="Mangal"/>
+        <a:font script="Telu" typeface="Gautami"/>
+        <a:font script="Taml" typeface="Latha"/>
+        <a:font script="Syrc" typeface="Estrangelo Edessa"/>
+        <a:font script="Orya" typeface="Kalinga"/>
+        <a:font script="Mlym" typeface="Kartika"/>
+        <a:font script="Laoo" typeface="DokChampa"/>
+        <a:font script="Sinh" typeface="Iskoola Pota"/>
+        <a:font script="Mong" typeface="Mongolian Baiti"/>
+        <a:font script="Viet" typeface="Arial"/>
+        <a:font script="Uigh" typeface="Microsoft Uighur"/>
+        <a:font script="Geor" typeface="Sylfaen"/>
+        <a:font script="Armn" typeface="Arial"/>
+        <a:font script="Bugi" typeface="Leelawadee UI"/>
+        <a:font script="Bopo" typeface="Microsoft JhengHei"/>
+        <a:font script="Java" typeface="Javanese Text"/>
+        <a:font script="Lisu" typeface="Segoe UI"/>
+        <a:font script="Mymr" typeface="Myanmar Text"/>
+        <a:font script="Nkoo" typeface="Ebrima"/>
+        <a:font script="Olck" typeface="Nirmala UI"/>
+        <a:font script="Osma" typeface="Ebrima"/>
+        <a:font script="Phag" typeface="Phagspa"/>
+        <a:font script="Syrn" typeface="Estrangelo Edessa"/>
+        <a:font script="Syrj" typeface="Estrangelo Edessa"/>
+        <a:font script="Syre" typeface="Estrangelo Edessa"/>
+        <a:font script="Sora" typeface="Nirmala UI"/>
+        <a:font script="Tale" typeface="Microsoft Tai Le"/>
+        <a:font script="Talu" typeface="Microsoft New Tai Lue"/>
+        <a:font script="Tfng" typeface="Ebrima"/>
+      </a:minorFont>
+    </a:fontScheme>
+    <a:fmtScheme name="Office">
+      <a:fillStyleLst>
+        <a:solidFill>
+          <a:schemeClr val="phClr"/>
+        </a:solidFill>
+        <a:gradFill rotWithShape="1">
+          <a:gsLst>
+            <a:gs pos="0">
+              <a:schemeClr val="phClr">
+                <a:lumMod val="110000"/>
+                <a:satMod val="105000"/>
+                <a:tint val="67000"/>
+              </a:schemeClr>
+            </a:gs>
+            <a:gs pos="50000">
+              <a:schemeClr val="phClr">
+                <a:lumMod val="105000"/>
+                <a:satMod val="103000"/>
+                <a:tint val="73000"/>
+              </a:schemeClr>
+            </a:gs>
+            <a:gs pos="100000">
+              <a:schemeClr val="phClr">
+                <a:lumMod val="105000"/>
+                <a:satMod val="109000"/>
+                <a:tint val="81000"/>
+              </a:schemeClr>
+            </a:gs>
+          </a:gsLst>
+          <a:lin ang="5400000" scaled="0"/>
+        </a:gradFill>
+        <a:gradFill rotWithShape="1">
+          <a:gsLst>
+            <a:gs pos="0">
+              <a:schemeClr val="phClr">
+                <a:satMod val="103000"/>
+                <a:lumMod val="102000"/>
+                <a:tint val="94000"/>
+              </a:schemeClr>
+            </a:gs>
+            <a:gs pos="50000">
+              <a:schemeClr val="phClr">
+                <a:satMod val="110000"/>
+                <a:lumMod val="100000"/>
+                <a:shade val="100000"/>
+              </a:schemeClr>
+            </a:gs>
+            <a:gs pos="100000">
+              <a:schemeClr val="phClr">
+                <a:lumMod val="99000"/>
+                <a:satMod val="120000"/>
+                <a:shade val="78000"/>
+              </a:schemeClr>
+            </a:gs>
+          </a:gsLst>
+          <a:lin ang="5400000" scaled="0"/>
+        </a:gradFill>
+      </a:fillStyleLst>
+      <a:lnStyleLst>
+        <a:ln w="12700" cap="flat" cmpd="sng" algn="ctr">
+          <a:solidFill>
+            <a:schemeClr val="phClr"/>
+          </a:solidFill>
+          <a:prstDash val="solid"/>
+          <a:miter lim="800000"/>
+        </a:ln>
+        <a:ln w="19050" cap="flat" cmpd="sng" algn="ctr">
+          <a:solidFill>
+            <a:schemeClr val="phClr"/>
+          </a:solidFill>
+          <a:prstDash val="solid"/>
+          <a:miter lim="800000"/>
+        </a:ln>
+        <a:ln w="25400" cap="flat" cmpd="sng" algn="ctr">
+          <a:solidFill>
+            <a:schemeClr val="phClr"/>
+          </a:solidFill>
+          <a:prstDash val="solid"/>
+          <a:miter lim="800000"/>
+        </a:ln>
+      </a:lnStyleLst>
+      <a:effectStyleLst>
+        <a:effectStyle>
+          <a:effectLst/>
+        </a:effectStyle>
+        <a:effectStyle>
+          <a:effectLst/>
+        </a:effectStyle>
+        <a:effectStyle>
+          <a:effectLst>
+            <a:outerShdw blurRad="57150" dist="19050" dir="5400000" algn="ctr" rotWithShape="0">
+              <a:srgbClr val="000000">
+                <a:alpha val="63000"/>
+              </a:srgbClr>
+            </a:outerShdw>
+          </a:effectLst>
+        </a:effectStyle>
+      </a:effectStyleLst>
+      <a:bgFillStyleLst>
+        <a:solidFill>
+          <a:schemeClr val="phClr"/>
+        </a:solidFill>
+        <a:solidFill>
+          <a:schemeClr val="phClr">
+            <a:tint val="95000"/>
+            <a:satMod val="170000"/>
+          </a:schemeClr>
+        </a:solidFill>
+        <a:gradFill rotWithShape="1">
+          <a:gsLst>
+            <a:gs pos="0">
+              <a:schemeClr val="phClr">
+                <a:tint val="93000"/>
+                <a:satMod val="150000"/>
+                <a:shade val="98000"/>
+                <a:lumMod val="102000"/>
+              </a:schemeClr>
+            </a:gs>
+            <a:gs pos="50000">
+              <a:schemeClr val="phClr">
+                <a:tint val="98000"/>
+                <a:satMod val="130000"/>
+                <a:shade val="90000"/>
+                <a:lumMod val="103000"/>
+              </a:schemeClr>
+            </a:gs>
+            <a:gs pos="100000">
+              <a:schemeClr val="phClr">
+                <a:shade val="63000"/>
+                <a:satMod val="120000"/>
+              </a:schemeClr>
+            </a:gs>
+          </a:gsLst>
+          <a:lin ang="5400000" scaled="0"/>
+        </a:gradFill>
+      </a:bgFillStyleLst>
+    </a:fmtScheme>
+  </a:themeElements>
+  <a:objectDefaults>
+    <a:lnDef>
+      <a:spPr/>
+      <a:bodyPr/>
+      <a:lstStyle/>
+      <a:style>
+        <a:lnRef idx="2">
+          <a:schemeClr val="accent1"/>
+        </a:lnRef>
+        <a:fillRef idx="0">
+          <a:schemeClr val="accent1"/>
+        </a:fillRef>
+        <a:effectRef idx="1">
+          <a:schemeClr val="accent1"/>
+        </a:effectRef>
+        <a:fontRef idx="minor">
+          <a:schemeClr val="tx1"/>
+        </a:fontRef>
+      </a:style>
+    </a:lnDef>
+  </a:objectDefaults>
+  <a:extraClrSchemeLst/>
+  <a:extLst>
+    <a:ext uri="{05A4C25C-085E-4340-85A3-A5531E510DB2}">
+      <thm15:themeFamily xmlns:thm15="http://schemas.microsoft.com/office/thememl/2012/main" name="Office Theme" id="{2E142A2C-CD16-42D6-873A-C26D2A0506FA}" vid="{1BDDFF52-6CD6-40A5-AB3C-68EB2F1E4D0A}"/>
+    </a:ext>
+  </a:extLst>
 </a:theme>
 </file>
</xml_diff>